<commit_message>
updates to disease plotting
</commit_message>
<xml_diff>
--- a/results/figures/envexp_timeseries_edited.pptx
+++ b/results/figures/envexp_timeseries_edited.pptx
@@ -8,11 +8,14 @@
     <p:sldId id="256" r:id="rId2"/>
     <p:sldId id="257" r:id="rId3"/>
     <p:sldId id="258" r:id="rId4"/>
+    <p:sldId id="259" r:id="rId5"/>
+    <p:sldId id="260" r:id="rId6"/>
+    <p:sldId id="261" r:id="rId7"/>
   </p:sldIdLst>
   <p:sldSz cx="20574000" cy="27432000"/>
   <p:notesSz cx="6858000" cy="9144000"/>
   <p:custDataLst>
-    <p:tags r:id="rId5"/>
+    <p:tags r:id="rId8"/>
   </p:custDataLst>
   <p:defaultTextStyle>
     <a:defPPr>
@@ -2415,37 +2418,6 @@
           </a:prstGeom>
         </p:spPr>
       </p:pic>
-      <p:pic>
-        <p:nvPicPr>
-          <p:cNvPr id="4" name="Picture 3">
-            <a:extLst>
-              <a:ext uri="{FF2B5EF4-FFF2-40B4-BE49-F238E27FC236}">
-                <a16:creationId xmlns:a16="http://schemas.microsoft.com/office/drawing/2014/main" id="{4C6597BA-21D6-F849-5EC3-980E9C880C4E}"/>
-              </a:ext>
-            </a:extLst>
-          </p:cNvPr>
-          <p:cNvPicPr>
-            <a:picLocks noChangeAspect="1"/>
-          </p:cNvPicPr>
-          <p:nvPr/>
-        </p:nvPicPr>
-        <p:blipFill>
-          <a:blip r:embed="rId2"/>
-          <a:srcRect l="80573" t="40042" b="41465"/>
-          <a:stretch>
-            <a:fillRect/>
-          </a:stretch>
-        </p:blipFill>
-        <p:spPr>
-          <a:xfrm>
-            <a:off x="12663264" y="7163272"/>
-            <a:ext cx="1509936" cy="936105"/>
-          </a:xfrm>
-          <a:prstGeom prst="rect">
-            <a:avLst/>
-          </a:prstGeom>
-        </p:spPr>
-      </p:pic>
       <p:sp>
         <p:nvSpPr>
           <p:cNvPr id="6" name="Rectangle 5">
@@ -2833,12 +2805,562 @@
           </a:p>
         </p:txBody>
       </p:sp>
-      <p:sp>
-        <p:nvSpPr>
-          <p:cNvPr id="12" name="Rectangle 11">
+      <p:grpSp>
+        <p:nvGrpSpPr>
+          <p:cNvPr id="3" name="Group 2">
             <a:extLst>
               <a:ext uri="{FF2B5EF4-FFF2-40B4-BE49-F238E27FC236}">
-                <a16:creationId xmlns:a16="http://schemas.microsoft.com/office/drawing/2014/main" id="{D861C437-6E6E-497D-D237-41B1E4EC8F50}"/>
+                <a16:creationId xmlns:a16="http://schemas.microsoft.com/office/drawing/2014/main" id="{6713AD43-C090-4BE8-F924-0BC6F4FD2122}"/>
+              </a:ext>
+            </a:extLst>
+          </p:cNvPr>
+          <p:cNvGrpSpPr/>
+          <p:nvPr/>
+        </p:nvGrpSpPr>
+        <p:grpSpPr>
+          <a:xfrm>
+            <a:off x="12591256" y="7158608"/>
+            <a:ext cx="1911388" cy="940769"/>
+            <a:chOff x="12591256" y="7158608"/>
+            <a:chExt cx="1911388" cy="940769"/>
+          </a:xfrm>
+        </p:grpSpPr>
+        <p:pic>
+          <p:nvPicPr>
+            <p:cNvPr id="4" name="Picture 3">
+              <a:extLst>
+                <a:ext uri="{FF2B5EF4-FFF2-40B4-BE49-F238E27FC236}">
+                  <a16:creationId xmlns:a16="http://schemas.microsoft.com/office/drawing/2014/main" id="{4C6597BA-21D6-F849-5EC3-980E9C880C4E}"/>
+                </a:ext>
+              </a:extLst>
+            </p:cNvPr>
+            <p:cNvPicPr>
+              <a:picLocks noChangeAspect="1"/>
+            </p:cNvPicPr>
+            <p:nvPr/>
+          </p:nvPicPr>
+          <p:blipFill>
+            <a:blip r:embed="rId2"/>
+            <a:srcRect l="80573" t="40042" b="41465"/>
+            <a:stretch>
+              <a:fillRect/>
+            </a:stretch>
+          </p:blipFill>
+          <p:spPr>
+            <a:xfrm>
+              <a:off x="12663264" y="7163272"/>
+              <a:ext cx="1509936" cy="936105"/>
+            </a:xfrm>
+            <a:prstGeom prst="rect">
+              <a:avLst/>
+            </a:prstGeom>
+          </p:spPr>
+        </p:pic>
+        <p:sp>
+          <p:nvSpPr>
+            <p:cNvPr id="12" name="Rectangle 11">
+              <a:extLst>
+                <a:ext uri="{FF2B5EF4-FFF2-40B4-BE49-F238E27FC236}">
+                  <a16:creationId xmlns:a16="http://schemas.microsoft.com/office/drawing/2014/main" id="{D861C437-6E6E-497D-D237-41B1E4EC8F50}"/>
+                </a:ext>
+              </a:extLst>
+            </p:cNvPr>
+            <p:cNvSpPr/>
+            <p:nvPr/>
+          </p:nvSpPr>
+          <p:spPr>
+            <a:xfrm>
+              <a:off x="12591256" y="7158608"/>
+              <a:ext cx="1911388" cy="220688"/>
+            </a:xfrm>
+            <a:prstGeom prst="rect">
+              <a:avLst/>
+            </a:prstGeom>
+            <a:solidFill>
+              <a:schemeClr val="bg1"/>
+            </a:solidFill>
+            <a:ln>
+              <a:solidFill>
+                <a:schemeClr val="bg1"/>
+              </a:solidFill>
+            </a:ln>
+          </p:spPr>
+          <p:style>
+            <a:lnRef idx="2">
+              <a:schemeClr val="accent1">
+                <a:shade val="15000"/>
+              </a:schemeClr>
+            </a:lnRef>
+            <a:fillRef idx="1">
+              <a:schemeClr val="accent1"/>
+            </a:fillRef>
+            <a:effectRef idx="0">
+              <a:schemeClr val="accent1"/>
+            </a:effectRef>
+            <a:fontRef idx="minor">
+              <a:schemeClr val="lt1"/>
+            </a:fontRef>
+          </p:style>
+          <p:txBody>
+            <a:bodyPr rtlCol="0" anchor="ctr"/>
+            <a:lstStyle/>
+            <a:p>
+              <a:r>
+                <a:rPr lang="en-US" sz="1800" dirty="0">
+                  <a:solidFill>
+                    <a:schemeClr val="tx1"/>
+                  </a:solidFill>
+                </a:rPr>
+                <a:t>Common Garden</a:t>
+              </a:r>
+            </a:p>
+          </p:txBody>
+        </p:sp>
+        <p:sp>
+          <p:nvSpPr>
+            <p:cNvPr id="13" name="Rectangle 12">
+              <a:extLst>
+                <a:ext uri="{FF2B5EF4-FFF2-40B4-BE49-F238E27FC236}">
+                  <a16:creationId xmlns:a16="http://schemas.microsoft.com/office/drawing/2014/main" id="{E8472DED-9560-BF65-1E25-A67B0403DBE6}"/>
+                </a:ext>
+              </a:extLst>
+            </p:cNvPr>
+            <p:cNvSpPr/>
+            <p:nvPr/>
+          </p:nvSpPr>
+          <p:spPr>
+            <a:xfrm>
+              <a:off x="12915292" y="7442813"/>
+              <a:ext cx="1188132" cy="220688"/>
+            </a:xfrm>
+            <a:prstGeom prst="rect">
+              <a:avLst/>
+            </a:prstGeom>
+            <a:solidFill>
+              <a:schemeClr val="bg1"/>
+            </a:solidFill>
+            <a:ln>
+              <a:solidFill>
+                <a:schemeClr val="bg1"/>
+              </a:solidFill>
+            </a:ln>
+          </p:spPr>
+          <p:style>
+            <a:lnRef idx="2">
+              <a:schemeClr val="accent1">
+                <a:shade val="15000"/>
+              </a:schemeClr>
+            </a:lnRef>
+            <a:fillRef idx="1">
+              <a:schemeClr val="accent1"/>
+            </a:fillRef>
+            <a:effectRef idx="0">
+              <a:schemeClr val="accent1"/>
+            </a:effectRef>
+            <a:fontRef idx="minor">
+              <a:schemeClr val="lt1"/>
+            </a:fontRef>
+          </p:style>
+          <p:txBody>
+            <a:bodyPr rtlCol="0" anchor="ctr"/>
+            <a:lstStyle/>
+            <a:p>
+              <a:r>
+                <a:rPr lang="en-US" sz="1600" dirty="0">
+                  <a:solidFill>
+                    <a:schemeClr val="tx1"/>
+                  </a:solidFill>
+                </a:rPr>
+                <a:t>Lewisetta</a:t>
+              </a:r>
+            </a:p>
+          </p:txBody>
+        </p:sp>
+        <p:sp>
+          <p:nvSpPr>
+            <p:cNvPr id="14" name="Rectangle 13">
+              <a:extLst>
+                <a:ext uri="{FF2B5EF4-FFF2-40B4-BE49-F238E27FC236}">
+                  <a16:creationId xmlns:a16="http://schemas.microsoft.com/office/drawing/2014/main" id="{0C697CFC-8144-422B-9249-87AAF57E0972}"/>
+                </a:ext>
+              </a:extLst>
+            </p:cNvPr>
+            <p:cNvSpPr/>
+            <p:nvPr/>
+          </p:nvSpPr>
+          <p:spPr>
+            <a:xfrm>
+              <a:off x="12915292" y="7696336"/>
+              <a:ext cx="1188132" cy="220688"/>
+            </a:xfrm>
+            <a:prstGeom prst="rect">
+              <a:avLst/>
+            </a:prstGeom>
+            <a:solidFill>
+              <a:schemeClr val="bg1"/>
+            </a:solidFill>
+            <a:ln>
+              <a:solidFill>
+                <a:schemeClr val="bg1"/>
+              </a:solidFill>
+            </a:ln>
+          </p:spPr>
+          <p:style>
+            <a:lnRef idx="2">
+              <a:schemeClr val="accent1">
+                <a:shade val="15000"/>
+              </a:schemeClr>
+            </a:lnRef>
+            <a:fillRef idx="1">
+              <a:schemeClr val="accent1"/>
+            </a:fillRef>
+            <a:effectRef idx="0">
+              <a:schemeClr val="accent1"/>
+            </a:effectRef>
+            <a:fontRef idx="minor">
+              <a:schemeClr val="lt1"/>
+            </a:fontRef>
+          </p:style>
+          <p:txBody>
+            <a:bodyPr rtlCol="0" anchor="ctr"/>
+            <a:lstStyle/>
+            <a:p>
+              <a:r>
+                <a:rPr lang="en-US" sz="1600" dirty="0">
+                  <a:solidFill>
+                    <a:schemeClr val="tx1"/>
+                  </a:solidFill>
+                </a:rPr>
+                <a:t>York River</a:t>
+              </a:r>
+            </a:p>
+          </p:txBody>
+        </p:sp>
+        <p:sp>
+          <p:nvSpPr>
+            <p:cNvPr id="15" name="Rectangle 14">
+              <a:extLst>
+                <a:ext uri="{FF2B5EF4-FFF2-40B4-BE49-F238E27FC236}">
+                  <a16:creationId xmlns:a16="http://schemas.microsoft.com/office/drawing/2014/main" id="{D0CBB124-67C4-06F0-28E8-F4003F27691A}"/>
+                </a:ext>
+              </a:extLst>
+            </p:cNvPr>
+            <p:cNvSpPr/>
+            <p:nvPr/>
+          </p:nvSpPr>
+          <p:spPr>
+            <a:xfrm>
+              <a:off x="12719974" y="7466645"/>
+              <a:ext cx="180020" cy="173024"/>
+            </a:xfrm>
+            <a:prstGeom prst="rect">
+              <a:avLst/>
+            </a:prstGeom>
+            <a:solidFill>
+              <a:srgbClr val="17FF7E"/>
+            </a:solidFill>
+            <a:ln w="12700"/>
+          </p:spPr>
+          <p:style>
+            <a:lnRef idx="2">
+              <a:schemeClr val="accent1">
+                <a:shade val="15000"/>
+              </a:schemeClr>
+            </a:lnRef>
+            <a:fillRef idx="1">
+              <a:schemeClr val="accent1"/>
+            </a:fillRef>
+            <a:effectRef idx="0">
+              <a:schemeClr val="accent1"/>
+            </a:effectRef>
+            <a:fontRef idx="minor">
+              <a:schemeClr val="lt1"/>
+            </a:fontRef>
+          </p:style>
+          <p:txBody>
+            <a:bodyPr rtlCol="0" anchor="ctr"/>
+            <a:lstStyle/>
+            <a:p>
+              <a:pPr algn="ctr"/>
+              <a:endParaRPr lang="en-US"/>
+            </a:p>
+          </p:txBody>
+        </p:sp>
+        <p:sp>
+          <p:nvSpPr>
+            <p:cNvPr id="17" name="Rectangle 16">
+              <a:extLst>
+                <a:ext uri="{FF2B5EF4-FFF2-40B4-BE49-F238E27FC236}">
+                  <a16:creationId xmlns:a16="http://schemas.microsoft.com/office/drawing/2014/main" id="{671A1061-E520-DEB3-7B5B-0159FE886A1C}"/>
+                </a:ext>
+              </a:extLst>
+            </p:cNvPr>
+            <p:cNvSpPr/>
+            <p:nvPr/>
+          </p:nvSpPr>
+          <p:spPr>
+            <a:xfrm>
+              <a:off x="12719974" y="7727957"/>
+              <a:ext cx="180020" cy="173024"/>
+            </a:xfrm>
+            <a:prstGeom prst="rect">
+              <a:avLst/>
+            </a:prstGeom>
+            <a:solidFill>
+              <a:srgbClr val="1A79FF"/>
+            </a:solidFill>
+            <a:ln w="12700"/>
+          </p:spPr>
+          <p:style>
+            <a:lnRef idx="2">
+              <a:schemeClr val="accent1">
+                <a:shade val="15000"/>
+              </a:schemeClr>
+            </a:lnRef>
+            <a:fillRef idx="1">
+              <a:schemeClr val="accent1"/>
+            </a:fillRef>
+            <a:effectRef idx="0">
+              <a:schemeClr val="accent1"/>
+            </a:effectRef>
+            <a:fontRef idx="minor">
+              <a:schemeClr val="lt1"/>
+            </a:fontRef>
+          </p:style>
+          <p:txBody>
+            <a:bodyPr rtlCol="0" anchor="ctr"/>
+            <a:lstStyle/>
+            <a:p>
+              <a:pPr algn="ctr"/>
+              <a:endParaRPr lang="en-US"/>
+            </a:p>
+          </p:txBody>
+        </p:sp>
+      </p:grpSp>
+    </p:spTree>
+    <p:extLst>
+      <p:ext uri="{BB962C8B-B14F-4D97-AF65-F5344CB8AC3E}">
+        <p14:creationId xmlns:p14="http://schemas.microsoft.com/office/powerpoint/2010/main" val="2360873365"/>
+      </p:ext>
+    </p:extLst>
+  </p:cSld>
+  <p:clrMapOvr>
+    <a:masterClrMapping/>
+  </p:clrMapOvr>
+</p:sld>
+</file>
+
+<file path=ppt/slides/slide4.xml><?xml version="1.0" encoding="utf-8"?>
+<p:sld xmlns:a="http://schemas.openxmlformats.org/drawingml/2006/main" xmlns:r="http://schemas.openxmlformats.org/officeDocument/2006/relationships" xmlns:p="http://schemas.openxmlformats.org/presentationml/2006/main">
+  <p:cSld>
+    <p:spTree>
+      <p:nvGrpSpPr>
+        <p:cNvPr id="1" name="">
+          <a:extLst>
+            <a:ext uri="{FF2B5EF4-FFF2-40B4-BE49-F238E27FC236}">
+              <a16:creationId xmlns:a16="http://schemas.microsoft.com/office/drawing/2014/main" id="{3D1C3434-1AC4-28D0-EDDB-FAF03ADDCECE}"/>
+            </a:ext>
+          </a:extLst>
+        </p:cNvPr>
+        <p:cNvGrpSpPr/>
+        <p:nvPr/>
+      </p:nvGrpSpPr>
+      <p:grpSpPr>
+        <a:xfrm>
+          <a:off x="0" y="0"/>
+          <a:ext cx="0" cy="0"/>
+          <a:chOff x="0" y="0"/>
+          <a:chExt cx="0" cy="0"/>
+        </a:xfrm>
+      </p:grpSpPr>
+      <p:pic>
+        <p:nvPicPr>
+          <p:cNvPr id="16" name="Picture 15">
+            <a:extLst>
+              <a:ext uri="{FF2B5EF4-FFF2-40B4-BE49-F238E27FC236}">
+                <a16:creationId xmlns:a16="http://schemas.microsoft.com/office/drawing/2014/main" id="{277A6EBE-B1C4-C668-A153-1812FF9DAD71}"/>
+              </a:ext>
+            </a:extLst>
+          </p:cNvPr>
+          <p:cNvPicPr>
+            <a:picLocks noChangeAspect="1"/>
+          </p:cNvPicPr>
+          <p:nvPr/>
+        </p:nvPicPr>
+        <p:blipFill>
+          <a:blip r:embed="rId2"/>
+          <a:stretch>
+            <a:fillRect/>
+          </a:stretch>
+        </p:blipFill>
+        <p:spPr>
+          <a:xfrm>
+            <a:off x="6400800" y="11184961"/>
+            <a:ext cx="7772400" cy="5062078"/>
+          </a:xfrm>
+          <a:prstGeom prst="rect">
+            <a:avLst/>
+          </a:prstGeom>
+        </p:spPr>
+      </p:pic>
+    </p:spTree>
+    <p:extLst>
+      <p:ext uri="{BB962C8B-B14F-4D97-AF65-F5344CB8AC3E}">
+        <p14:creationId xmlns:p14="http://schemas.microsoft.com/office/powerpoint/2010/main" val="1409205359"/>
+      </p:ext>
+    </p:extLst>
+  </p:cSld>
+  <p:clrMapOvr>
+    <a:masterClrMapping/>
+  </p:clrMapOvr>
+</p:sld>
+</file>
+
+<file path=ppt/slides/slide5.xml><?xml version="1.0" encoding="utf-8"?>
+<p:sld xmlns:a="http://schemas.openxmlformats.org/drawingml/2006/main" xmlns:r="http://schemas.openxmlformats.org/officeDocument/2006/relationships" xmlns:p="http://schemas.openxmlformats.org/presentationml/2006/main">
+  <p:cSld>
+    <p:spTree>
+      <p:nvGrpSpPr>
+        <p:cNvPr id="1" name=""/>
+        <p:cNvGrpSpPr/>
+        <p:nvPr/>
+      </p:nvGrpSpPr>
+      <p:grpSpPr>
+        <a:xfrm>
+          <a:off x="0" y="0"/>
+          <a:ext cx="0" cy="0"/>
+          <a:chOff x="0" y="0"/>
+          <a:chExt cx="0" cy="0"/>
+        </a:xfrm>
+      </p:grpSpPr>
+      <p:pic>
+        <p:nvPicPr>
+          <p:cNvPr id="5" name="Picture 4">
+            <a:extLst>
+              <a:ext uri="{FF2B5EF4-FFF2-40B4-BE49-F238E27FC236}">
+                <a16:creationId xmlns:a16="http://schemas.microsoft.com/office/drawing/2014/main" id="{43C5BBBF-932F-8EC7-7784-6A4D748DA9C1}"/>
+              </a:ext>
+            </a:extLst>
+          </p:cNvPr>
+          <p:cNvPicPr>
+            <a:picLocks noChangeAspect="1"/>
+          </p:cNvPicPr>
+          <p:nvPr/>
+        </p:nvPicPr>
+        <p:blipFill>
+          <a:blip r:embed="rId2"/>
+          <a:stretch>
+            <a:fillRect/>
+          </a:stretch>
+        </p:blipFill>
+        <p:spPr>
+          <a:xfrm>
+            <a:off x="6400800" y="11184961"/>
+            <a:ext cx="7772400" cy="5062078"/>
+          </a:xfrm>
+          <a:prstGeom prst="rect">
+            <a:avLst/>
+          </a:prstGeom>
+        </p:spPr>
+      </p:pic>
+    </p:spTree>
+    <p:extLst>
+      <p:ext uri="{BB962C8B-B14F-4D97-AF65-F5344CB8AC3E}">
+        <p14:creationId xmlns:p14="http://schemas.microsoft.com/office/powerpoint/2010/main" val="1446251950"/>
+      </p:ext>
+    </p:extLst>
+  </p:cSld>
+  <p:clrMapOvr>
+    <a:masterClrMapping/>
+  </p:clrMapOvr>
+</p:sld>
+</file>
+
+<file path=ppt/slides/slide6.xml><?xml version="1.0" encoding="utf-8"?>
+<p:sld xmlns:a="http://schemas.openxmlformats.org/drawingml/2006/main" xmlns:r="http://schemas.openxmlformats.org/officeDocument/2006/relationships" xmlns:p="http://schemas.openxmlformats.org/presentationml/2006/main">
+  <p:cSld>
+    <p:spTree>
+      <p:nvGrpSpPr>
+        <p:cNvPr id="1" name=""/>
+        <p:cNvGrpSpPr/>
+        <p:nvPr/>
+      </p:nvGrpSpPr>
+      <p:grpSpPr>
+        <a:xfrm>
+          <a:off x="0" y="0"/>
+          <a:ext cx="0" cy="0"/>
+          <a:chOff x="0" y="0"/>
+          <a:chExt cx="0" cy="0"/>
+        </a:xfrm>
+      </p:grpSpPr>
+      <p:pic>
+        <p:nvPicPr>
+          <p:cNvPr id="23" name="Picture 22">
+            <a:extLst>
+              <a:ext uri="{FF2B5EF4-FFF2-40B4-BE49-F238E27FC236}">
+                <a16:creationId xmlns:a16="http://schemas.microsoft.com/office/drawing/2014/main" id="{E7E53A25-1C40-1D92-23FC-2925B8E04BB0}"/>
+              </a:ext>
+            </a:extLst>
+          </p:cNvPr>
+          <p:cNvPicPr>
+            <a:picLocks noChangeAspect="1"/>
+          </p:cNvPicPr>
+          <p:nvPr/>
+        </p:nvPicPr>
+        <p:blipFill>
+          <a:blip r:embed="rId2"/>
+          <a:srcRect r="21251"/>
+          <a:stretch>
+            <a:fillRect/>
+          </a:stretch>
+        </p:blipFill>
+        <p:spPr>
+          <a:xfrm>
+            <a:off x="1833267" y="10475639"/>
+            <a:ext cx="6120680" cy="5062078"/>
+          </a:xfrm>
+          <a:prstGeom prst="rect">
+            <a:avLst/>
+          </a:prstGeom>
+        </p:spPr>
+      </p:pic>
+      <p:pic>
+        <p:nvPicPr>
+          <p:cNvPr id="5" name="Picture 4">
+            <a:extLst>
+              <a:ext uri="{FF2B5EF4-FFF2-40B4-BE49-F238E27FC236}">
+                <a16:creationId xmlns:a16="http://schemas.microsoft.com/office/drawing/2014/main" id="{1D3196B2-5E38-8770-253B-B3F65DE8AB38}"/>
+              </a:ext>
+            </a:extLst>
+          </p:cNvPr>
+          <p:cNvPicPr>
+            <a:picLocks noChangeAspect="1"/>
+          </p:cNvPicPr>
+          <p:nvPr/>
+        </p:nvPicPr>
+        <p:blipFill>
+          <a:blip r:embed="rId3"/>
+          <a:srcRect r="21251"/>
+          <a:stretch>
+            <a:fillRect/>
+          </a:stretch>
+        </p:blipFill>
+        <p:spPr>
+          <a:xfrm>
+            <a:off x="8486800" y="10475640"/>
+            <a:ext cx="6120680" cy="5062078"/>
+          </a:xfrm>
+          <a:prstGeom prst="rect">
+            <a:avLst/>
+          </a:prstGeom>
+        </p:spPr>
+      </p:pic>
+      <p:sp>
+        <p:nvSpPr>
+          <p:cNvPr id="6" name="Rectangle 5">
+            <a:extLst>
+              <a:ext uri="{FF2B5EF4-FFF2-40B4-BE49-F238E27FC236}">
+                <a16:creationId xmlns:a16="http://schemas.microsoft.com/office/drawing/2014/main" id="{517FE153-138F-5037-73AC-9A49FA9A3851}"/>
               </a:ext>
             </a:extLst>
           </p:cNvPr>
@@ -2847,8 +3369,8 @@
         </p:nvSpPr>
         <p:spPr>
           <a:xfrm>
-            <a:off x="12591256" y="7158608"/>
-            <a:ext cx="1911388" cy="220688"/>
+            <a:off x="2366120" y="10223612"/>
+            <a:ext cx="5544616" cy="504056"/>
           </a:xfrm>
           <a:prstGeom prst="rect">
             <a:avLst/>
@@ -2882,6 +3404,302 @@
           <a:bodyPr rtlCol="0" anchor="ctr"/>
           <a:lstStyle/>
           <a:p>
+            <a:pPr marL="457200" indent="-457200">
+              <a:buAutoNum type="alphaUcParenBoth"/>
+            </a:pPr>
+            <a:r>
+              <a:rPr lang="en-US" sz="2400" dirty="0">
+                <a:solidFill>
+                  <a:schemeClr val="tx1"/>
+                </a:solidFill>
+              </a:rPr>
+              <a:t>MSX Prevalence in Common Gardens</a:t>
+            </a:r>
+          </a:p>
+          <a:p>
+            <a:r>
+              <a:rPr lang="en-US" sz="2400" dirty="0">
+                <a:solidFill>
+                  <a:schemeClr val="tx1"/>
+                </a:solidFill>
+              </a:rPr>
+              <a:t>       over Experimental Period</a:t>
+            </a:r>
+          </a:p>
+        </p:txBody>
+      </p:sp>
+      <p:sp>
+        <p:nvSpPr>
+          <p:cNvPr id="7" name="Rectangle 6">
+            <a:extLst>
+              <a:ext uri="{FF2B5EF4-FFF2-40B4-BE49-F238E27FC236}">
+                <a16:creationId xmlns:a16="http://schemas.microsoft.com/office/drawing/2014/main" id="{86FBDB0B-43F6-DF09-BD60-F2DD48B7EF2D}"/>
+              </a:ext>
+            </a:extLst>
+          </p:cNvPr>
+          <p:cNvSpPr/>
+          <p:nvPr/>
+        </p:nvSpPr>
+        <p:spPr>
+          <a:xfrm>
+            <a:off x="9062864" y="10223612"/>
+            <a:ext cx="5544616" cy="504056"/>
+          </a:xfrm>
+          <a:prstGeom prst="rect">
+            <a:avLst/>
+          </a:prstGeom>
+          <a:solidFill>
+            <a:schemeClr val="bg1"/>
+          </a:solidFill>
+          <a:ln>
+            <a:solidFill>
+              <a:schemeClr val="bg1"/>
+            </a:solidFill>
+          </a:ln>
+        </p:spPr>
+        <p:style>
+          <a:lnRef idx="2">
+            <a:schemeClr val="accent1">
+              <a:shade val="15000"/>
+            </a:schemeClr>
+          </a:lnRef>
+          <a:fillRef idx="1">
+            <a:schemeClr val="accent1"/>
+          </a:fillRef>
+          <a:effectRef idx="0">
+            <a:schemeClr val="accent1"/>
+          </a:effectRef>
+          <a:fontRef idx="minor">
+            <a:schemeClr val="lt1"/>
+          </a:fontRef>
+        </p:style>
+        <p:txBody>
+          <a:bodyPr rtlCol="0" anchor="ctr"/>
+          <a:lstStyle/>
+          <a:p>
+            <a:r>
+              <a:rPr lang="en-US" sz="2400" dirty="0">
+                <a:solidFill>
+                  <a:schemeClr val="tx1"/>
+                </a:solidFill>
+              </a:rPr>
+              <a:t>(B) Dermo Prevalence in Common Gardens</a:t>
+            </a:r>
+          </a:p>
+          <a:p>
+            <a:r>
+              <a:rPr lang="en-US" sz="2400" dirty="0">
+                <a:solidFill>
+                  <a:schemeClr val="tx1"/>
+                </a:solidFill>
+              </a:rPr>
+              <a:t>       over Experimental Period</a:t>
+            </a:r>
+          </a:p>
+        </p:txBody>
+      </p:sp>
+      <p:sp>
+        <p:nvSpPr>
+          <p:cNvPr id="8" name="Rectangle 7">
+            <a:extLst>
+              <a:ext uri="{FF2B5EF4-FFF2-40B4-BE49-F238E27FC236}">
+                <a16:creationId xmlns:a16="http://schemas.microsoft.com/office/drawing/2014/main" id="{848E700F-0EF8-5456-DDDD-C6AE43DDAA7B}"/>
+              </a:ext>
+            </a:extLst>
+          </p:cNvPr>
+          <p:cNvSpPr/>
+          <p:nvPr/>
+        </p:nvSpPr>
+        <p:spPr>
+          <a:xfrm rot="16200000">
+            <a:off x="1003453" y="12754651"/>
+            <a:ext cx="1861238" cy="504056"/>
+          </a:xfrm>
+          <a:prstGeom prst="rect">
+            <a:avLst/>
+          </a:prstGeom>
+          <a:solidFill>
+            <a:schemeClr val="bg1"/>
+          </a:solidFill>
+          <a:ln>
+            <a:solidFill>
+              <a:schemeClr val="bg1"/>
+            </a:solidFill>
+          </a:ln>
+        </p:spPr>
+        <p:style>
+          <a:lnRef idx="2">
+            <a:schemeClr val="accent1">
+              <a:shade val="15000"/>
+            </a:schemeClr>
+          </a:lnRef>
+          <a:fillRef idx="1">
+            <a:schemeClr val="accent1"/>
+          </a:fillRef>
+          <a:effectRef idx="0">
+            <a:schemeClr val="accent1"/>
+          </a:effectRef>
+          <a:fontRef idx="minor">
+            <a:schemeClr val="lt1"/>
+          </a:fontRef>
+        </p:style>
+        <p:txBody>
+          <a:bodyPr rtlCol="0" anchor="ctr"/>
+          <a:lstStyle/>
+          <a:p>
+            <a:pPr algn="ctr"/>
+            <a:r>
+              <a:rPr lang="en-US" sz="1800" dirty="0">
+                <a:solidFill>
+                  <a:schemeClr val="tx1"/>
+                </a:solidFill>
+              </a:rPr>
+              <a:t>MSX Prevalence</a:t>
+            </a:r>
+          </a:p>
+        </p:txBody>
+      </p:sp>
+      <p:sp>
+        <p:nvSpPr>
+          <p:cNvPr id="9" name="Rectangle 8">
+            <a:extLst>
+              <a:ext uri="{FF2B5EF4-FFF2-40B4-BE49-F238E27FC236}">
+                <a16:creationId xmlns:a16="http://schemas.microsoft.com/office/drawing/2014/main" id="{CBDCFE68-8327-CBBF-9940-8C3FF8FA4A83}"/>
+              </a:ext>
+            </a:extLst>
+          </p:cNvPr>
+          <p:cNvSpPr/>
+          <p:nvPr/>
+        </p:nvSpPr>
+        <p:spPr>
+          <a:xfrm rot="16200000">
+            <a:off x="7479981" y="12754651"/>
+            <a:ext cx="2013638" cy="504056"/>
+          </a:xfrm>
+          <a:prstGeom prst="rect">
+            <a:avLst/>
+          </a:prstGeom>
+          <a:solidFill>
+            <a:schemeClr val="bg1"/>
+          </a:solidFill>
+          <a:ln>
+            <a:solidFill>
+              <a:schemeClr val="bg1"/>
+            </a:solidFill>
+          </a:ln>
+        </p:spPr>
+        <p:style>
+          <a:lnRef idx="2">
+            <a:schemeClr val="accent1">
+              <a:shade val="15000"/>
+            </a:schemeClr>
+          </a:lnRef>
+          <a:fillRef idx="1">
+            <a:schemeClr val="accent1"/>
+          </a:fillRef>
+          <a:effectRef idx="0">
+            <a:schemeClr val="accent1"/>
+          </a:effectRef>
+          <a:fontRef idx="minor">
+            <a:schemeClr val="lt1"/>
+          </a:fontRef>
+        </p:style>
+        <p:txBody>
+          <a:bodyPr rtlCol="0" anchor="ctr"/>
+          <a:lstStyle/>
+          <a:p>
+            <a:pPr algn="ctr"/>
+            <a:r>
+              <a:rPr lang="en-US" sz="1800" dirty="0">
+                <a:solidFill>
+                  <a:schemeClr val="tx1"/>
+                </a:solidFill>
+              </a:rPr>
+              <a:t>Dermo Prevalence</a:t>
+            </a:r>
+          </a:p>
+        </p:txBody>
+      </p:sp>
+      <p:pic>
+        <p:nvPicPr>
+          <p:cNvPr id="11" name="Picture 10">
+            <a:extLst>
+              <a:ext uri="{FF2B5EF4-FFF2-40B4-BE49-F238E27FC236}">
+                <a16:creationId xmlns:a16="http://schemas.microsoft.com/office/drawing/2014/main" id="{7D53A8DB-AFFB-CE30-C4F8-FBF259979F9E}"/>
+              </a:ext>
+            </a:extLst>
+          </p:cNvPr>
+          <p:cNvPicPr>
+            <a:picLocks noChangeAspect="1"/>
+          </p:cNvPicPr>
+          <p:nvPr/>
+        </p:nvPicPr>
+        <p:blipFill>
+          <a:blip r:embed="rId4"/>
+          <a:srcRect l="80573" t="40042" b="41465"/>
+          <a:stretch>
+            <a:fillRect/>
+          </a:stretch>
+        </p:blipFill>
+        <p:spPr>
+          <a:xfrm>
+            <a:off x="14695575" y="11063755"/>
+            <a:ext cx="1509936" cy="936105"/>
+          </a:xfrm>
+          <a:prstGeom prst="rect">
+            <a:avLst/>
+          </a:prstGeom>
+        </p:spPr>
+      </p:pic>
+      <p:sp>
+        <p:nvSpPr>
+          <p:cNvPr id="12" name="Rectangle 11">
+            <a:extLst>
+              <a:ext uri="{FF2B5EF4-FFF2-40B4-BE49-F238E27FC236}">
+                <a16:creationId xmlns:a16="http://schemas.microsoft.com/office/drawing/2014/main" id="{13D705FC-818C-E749-F479-1B13F50D427C}"/>
+              </a:ext>
+            </a:extLst>
+          </p:cNvPr>
+          <p:cNvSpPr/>
+          <p:nvPr/>
+        </p:nvSpPr>
+        <p:spPr>
+          <a:xfrm>
+            <a:off x="14623567" y="10775020"/>
+            <a:ext cx="1911388" cy="504056"/>
+          </a:xfrm>
+          <a:prstGeom prst="rect">
+            <a:avLst/>
+          </a:prstGeom>
+          <a:solidFill>
+            <a:schemeClr val="bg1"/>
+          </a:solidFill>
+          <a:ln>
+            <a:solidFill>
+              <a:schemeClr val="bg1"/>
+            </a:solidFill>
+          </a:ln>
+        </p:spPr>
+        <p:style>
+          <a:lnRef idx="2">
+            <a:schemeClr val="accent1">
+              <a:shade val="15000"/>
+            </a:schemeClr>
+          </a:lnRef>
+          <a:fillRef idx="1">
+            <a:schemeClr val="accent1"/>
+          </a:fillRef>
+          <a:effectRef idx="0">
+            <a:schemeClr val="accent1"/>
+          </a:effectRef>
+          <a:fontRef idx="minor">
+            <a:schemeClr val="lt1"/>
+          </a:fontRef>
+        </p:style>
+        <p:txBody>
+          <a:bodyPr rtlCol="0" anchor="ctr"/>
+          <a:lstStyle/>
+          <a:p>
             <a:r>
               <a:rPr lang="en-US" sz="1800" dirty="0">
                 <a:solidFill>
@@ -2898,7 +3716,7 @@
           <p:cNvPr id="13" name="Rectangle 12">
             <a:extLst>
               <a:ext uri="{FF2B5EF4-FFF2-40B4-BE49-F238E27FC236}">
-                <a16:creationId xmlns:a16="http://schemas.microsoft.com/office/drawing/2014/main" id="{E8472DED-9560-BF65-1E25-A67B0403DBE6}"/>
+                <a16:creationId xmlns:a16="http://schemas.microsoft.com/office/drawing/2014/main" id="{80BB86C2-778A-5741-1BB6-E10469737AC5}"/>
               </a:ext>
             </a:extLst>
           </p:cNvPr>
@@ -2907,7 +3725,7 @@
         </p:nvSpPr>
         <p:spPr>
           <a:xfrm>
-            <a:off x="12915292" y="7442813"/>
+            <a:off x="15075532" y="11343296"/>
             <a:ext cx="1188132" cy="220688"/>
           </a:xfrm>
           <a:prstGeom prst="rect">
@@ -2958,7 +3776,7 @@
           <p:cNvPr id="14" name="Rectangle 13">
             <a:extLst>
               <a:ext uri="{FF2B5EF4-FFF2-40B4-BE49-F238E27FC236}">
-                <a16:creationId xmlns:a16="http://schemas.microsoft.com/office/drawing/2014/main" id="{0C697CFC-8144-422B-9249-87AAF57E0972}"/>
+                <a16:creationId xmlns:a16="http://schemas.microsoft.com/office/drawing/2014/main" id="{B24EF363-8867-5EA1-46FF-5D2FF7DB813D}"/>
               </a:ext>
             </a:extLst>
           </p:cNvPr>
@@ -2967,7 +3785,7 @@
         </p:nvSpPr>
         <p:spPr>
           <a:xfrm>
-            <a:off x="12915292" y="7696336"/>
+            <a:off x="15075532" y="11691120"/>
             <a:ext cx="1188132" cy="220688"/>
           </a:xfrm>
           <a:prstGeom prst="rect">
@@ -3015,10 +3833,10 @@
       </p:sp>
       <p:sp>
         <p:nvSpPr>
-          <p:cNvPr id="15" name="Rectangle 14">
+          <p:cNvPr id="18" name="Rectangle 17">
             <a:extLst>
               <a:ext uri="{FF2B5EF4-FFF2-40B4-BE49-F238E27FC236}">
-                <a16:creationId xmlns:a16="http://schemas.microsoft.com/office/drawing/2014/main" id="{D0CBB124-67C4-06F0-28E8-F4003F27691A}"/>
+                <a16:creationId xmlns:a16="http://schemas.microsoft.com/office/drawing/2014/main" id="{B96F4F35-B256-A04C-C1E9-8CD700735543}"/>
               </a:ext>
             </a:extLst>
           </p:cNvPr>
@@ -3027,7 +3845,179 @@
         </p:nvSpPr>
         <p:spPr>
           <a:xfrm>
-            <a:off x="12719974" y="7466645"/>
+            <a:off x="4063793" y="15285690"/>
+            <a:ext cx="1861238" cy="504056"/>
+          </a:xfrm>
+          <a:prstGeom prst="rect">
+            <a:avLst/>
+          </a:prstGeom>
+          <a:solidFill>
+            <a:schemeClr val="bg1"/>
+          </a:solidFill>
+          <a:ln>
+            <a:solidFill>
+              <a:schemeClr val="bg1"/>
+            </a:solidFill>
+          </a:ln>
+        </p:spPr>
+        <p:style>
+          <a:lnRef idx="2">
+            <a:schemeClr val="accent1">
+              <a:shade val="15000"/>
+            </a:schemeClr>
+          </a:lnRef>
+          <a:fillRef idx="1">
+            <a:schemeClr val="accent1"/>
+          </a:fillRef>
+          <a:effectRef idx="0">
+            <a:schemeClr val="accent1"/>
+          </a:effectRef>
+          <a:fontRef idx="minor">
+            <a:schemeClr val="lt1"/>
+          </a:fontRef>
+        </p:style>
+        <p:txBody>
+          <a:bodyPr rtlCol="0" anchor="ctr"/>
+          <a:lstStyle/>
+          <a:p>
+            <a:pPr algn="ctr"/>
+            <a:r>
+              <a:rPr lang="en-US" sz="1800" dirty="0">
+                <a:solidFill>
+                  <a:schemeClr val="tx1"/>
+                </a:solidFill>
+              </a:rPr>
+              <a:t>Date</a:t>
+            </a:r>
+          </a:p>
+        </p:txBody>
+      </p:sp>
+      <p:sp>
+        <p:nvSpPr>
+          <p:cNvPr id="19" name="Rectangle 18">
+            <a:extLst>
+              <a:ext uri="{FF2B5EF4-FFF2-40B4-BE49-F238E27FC236}">
+                <a16:creationId xmlns:a16="http://schemas.microsoft.com/office/drawing/2014/main" id="{E950C191-6378-8F50-B5C2-16554B72D4E0}"/>
+              </a:ext>
+            </a:extLst>
+          </p:cNvPr>
+          <p:cNvSpPr/>
+          <p:nvPr/>
+        </p:nvSpPr>
+        <p:spPr>
+          <a:xfrm>
+            <a:off x="10724533" y="15285690"/>
+            <a:ext cx="1861238" cy="504056"/>
+          </a:xfrm>
+          <a:prstGeom prst="rect">
+            <a:avLst/>
+          </a:prstGeom>
+          <a:solidFill>
+            <a:schemeClr val="bg1"/>
+          </a:solidFill>
+          <a:ln>
+            <a:solidFill>
+              <a:schemeClr val="bg1"/>
+            </a:solidFill>
+          </a:ln>
+        </p:spPr>
+        <p:style>
+          <a:lnRef idx="2">
+            <a:schemeClr val="accent1">
+              <a:shade val="15000"/>
+            </a:schemeClr>
+          </a:lnRef>
+          <a:fillRef idx="1">
+            <a:schemeClr val="accent1"/>
+          </a:fillRef>
+          <a:effectRef idx="0">
+            <a:schemeClr val="accent1"/>
+          </a:effectRef>
+          <a:fontRef idx="minor">
+            <a:schemeClr val="lt1"/>
+          </a:fontRef>
+        </p:style>
+        <p:txBody>
+          <a:bodyPr rtlCol="0" anchor="ctr"/>
+          <a:lstStyle/>
+          <a:p>
+            <a:pPr algn="ctr"/>
+            <a:r>
+              <a:rPr lang="en-US" sz="1800" dirty="0">
+                <a:solidFill>
+                  <a:schemeClr val="tx1"/>
+                </a:solidFill>
+              </a:rPr>
+              <a:t>Date</a:t>
+            </a:r>
+          </a:p>
+        </p:txBody>
+      </p:sp>
+      <p:sp>
+        <p:nvSpPr>
+          <p:cNvPr id="16" name="Rectangle 15">
+            <a:extLst>
+              <a:ext uri="{FF2B5EF4-FFF2-40B4-BE49-F238E27FC236}">
+                <a16:creationId xmlns:a16="http://schemas.microsoft.com/office/drawing/2014/main" id="{F9413902-5562-5AA6-653F-D154E7BBE925}"/>
+              </a:ext>
+            </a:extLst>
+          </p:cNvPr>
+          <p:cNvSpPr/>
+          <p:nvPr/>
+        </p:nvSpPr>
+        <p:spPr>
+          <a:xfrm>
+            <a:off x="14752285" y="11628440"/>
+            <a:ext cx="180020" cy="173024"/>
+          </a:xfrm>
+          <a:prstGeom prst="rect">
+            <a:avLst/>
+          </a:prstGeom>
+          <a:solidFill>
+            <a:srgbClr val="1A79FF"/>
+          </a:solidFill>
+          <a:ln w="12700"/>
+        </p:spPr>
+        <p:style>
+          <a:lnRef idx="2">
+            <a:schemeClr val="accent1">
+              <a:shade val="15000"/>
+            </a:schemeClr>
+          </a:lnRef>
+          <a:fillRef idx="1">
+            <a:schemeClr val="accent1"/>
+          </a:fillRef>
+          <a:effectRef idx="0">
+            <a:schemeClr val="accent1"/>
+          </a:effectRef>
+          <a:fontRef idx="minor">
+            <a:schemeClr val="lt1"/>
+          </a:fontRef>
+        </p:style>
+        <p:txBody>
+          <a:bodyPr rtlCol="0" anchor="ctr"/>
+          <a:lstStyle/>
+          <a:p>
+            <a:pPr algn="ctr"/>
+            <a:endParaRPr lang="en-US"/>
+          </a:p>
+        </p:txBody>
+      </p:sp>
+      <p:sp>
+        <p:nvSpPr>
+          <p:cNvPr id="15" name="Rectangle 14">
+            <a:extLst>
+              <a:ext uri="{FF2B5EF4-FFF2-40B4-BE49-F238E27FC236}">
+                <a16:creationId xmlns:a16="http://schemas.microsoft.com/office/drawing/2014/main" id="{F51DCC6A-F960-7A05-075E-0F4DC1EC042C}"/>
+              </a:ext>
+            </a:extLst>
+          </p:cNvPr>
+          <p:cNvSpPr/>
+          <p:nvPr/>
+        </p:nvSpPr>
+        <p:spPr>
+          <a:xfrm>
+            <a:off x="14752285" y="11367128"/>
             <a:ext cx="180020" cy="173024"/>
           </a:xfrm>
           <a:prstGeom prst="rect">
@@ -3065,10 +4055,10 @@
       </p:sp>
       <p:sp>
         <p:nvSpPr>
-          <p:cNvPr id="17" name="Rectangle 16">
+          <p:cNvPr id="30" name="Rectangle 29">
             <a:extLst>
               <a:ext uri="{FF2B5EF4-FFF2-40B4-BE49-F238E27FC236}">
-                <a16:creationId xmlns:a16="http://schemas.microsoft.com/office/drawing/2014/main" id="{671A1061-E520-DEB3-7B5B-0159FE886A1C}"/>
+                <a16:creationId xmlns:a16="http://schemas.microsoft.com/office/drawing/2014/main" id="{1FB5CC8C-473E-A0DF-E263-34499A30C267}"/>
               </a:ext>
             </a:extLst>
           </p:cNvPr>
@@ -3077,8 +4067,58 @@
         </p:nvSpPr>
         <p:spPr>
           <a:xfrm>
-            <a:off x="12719974" y="7727957"/>
-            <a:ext cx="180020" cy="173024"/>
+            <a:off x="14679488" y="11276331"/>
+            <a:ext cx="338328" cy="334418"/>
+          </a:xfrm>
+          <a:prstGeom prst="rect">
+            <a:avLst/>
+          </a:prstGeom>
+          <a:solidFill>
+            <a:srgbClr val="17FF7E"/>
+          </a:solidFill>
+          <a:ln w="12700"/>
+        </p:spPr>
+        <p:style>
+          <a:lnRef idx="2">
+            <a:schemeClr val="accent1">
+              <a:shade val="15000"/>
+            </a:schemeClr>
+          </a:lnRef>
+          <a:fillRef idx="1">
+            <a:schemeClr val="accent1"/>
+          </a:fillRef>
+          <a:effectRef idx="0">
+            <a:schemeClr val="accent1"/>
+          </a:effectRef>
+          <a:fontRef idx="minor">
+            <a:schemeClr val="lt1"/>
+          </a:fontRef>
+        </p:style>
+        <p:txBody>
+          <a:bodyPr rtlCol="0" anchor="ctr"/>
+          <a:lstStyle/>
+          <a:p>
+            <a:pPr algn="ctr"/>
+            <a:endParaRPr lang="en-US"/>
+          </a:p>
+        </p:txBody>
+      </p:sp>
+      <p:sp>
+        <p:nvSpPr>
+          <p:cNvPr id="31" name="Rectangle 30">
+            <a:extLst>
+              <a:ext uri="{FF2B5EF4-FFF2-40B4-BE49-F238E27FC236}">
+                <a16:creationId xmlns:a16="http://schemas.microsoft.com/office/drawing/2014/main" id="{1BD2B97F-10BD-A100-9EDE-FB0184035C5A}"/>
+              </a:ext>
+            </a:extLst>
+          </p:cNvPr>
+          <p:cNvSpPr/>
+          <p:nvPr/>
+        </p:nvSpPr>
+        <p:spPr>
+          <a:xfrm>
+            <a:off x="14679488" y="11624037"/>
+            <a:ext cx="338328" cy="334418"/>
           </a:xfrm>
           <a:prstGeom prst="rect">
             <a:avLst/>
@@ -3113,10 +4153,579 @@
           </a:p>
         </p:txBody>
       </p:sp>
+      <p:grpSp>
+        <p:nvGrpSpPr>
+          <p:cNvPr id="35" name="Group 34">
+            <a:extLst>
+              <a:ext uri="{FF2B5EF4-FFF2-40B4-BE49-F238E27FC236}">
+                <a16:creationId xmlns:a16="http://schemas.microsoft.com/office/drawing/2014/main" id="{3B685F93-01E0-04D8-399E-5745C28B6CF6}"/>
+              </a:ext>
+            </a:extLst>
+          </p:cNvPr>
+          <p:cNvGrpSpPr/>
+          <p:nvPr/>
+        </p:nvGrpSpPr>
+        <p:grpSpPr>
+          <a:xfrm>
+            <a:off x="1248943" y="15625067"/>
+            <a:ext cx="15059220" cy="10188277"/>
+            <a:chOff x="1248943" y="15625067"/>
+            <a:chExt cx="15059220" cy="10995706"/>
+          </a:xfrm>
+        </p:grpSpPr>
+        <p:pic>
+          <p:nvPicPr>
+            <p:cNvPr id="3076" name="Picture 4">
+              <a:extLst>
+                <a:ext uri="{FF2B5EF4-FFF2-40B4-BE49-F238E27FC236}">
+                  <a16:creationId xmlns:a16="http://schemas.microsoft.com/office/drawing/2014/main" id="{F6D93FDB-3310-08E6-8320-61ACF7510E4F}"/>
+                </a:ext>
+              </a:extLst>
+            </p:cNvPr>
+            <p:cNvPicPr>
+              <a:picLocks noChangeAspect="1" noChangeArrowheads="1"/>
+            </p:cNvPicPr>
+            <p:nvPr/>
+          </p:nvPicPr>
+          <p:blipFill rotWithShape="1">
+            <a:blip r:embed="rId5">
+              <a:extLst>
+                <a:ext uri="{28A0092B-C50C-407E-A947-70E740481C1C}">
+                  <a14:useLocalDpi xmlns:a14="http://schemas.microsoft.com/office/drawing/2010/main" val="0"/>
+                </a:ext>
+              </a:extLst>
+            </a:blip>
+            <a:srcRect r="16490"/>
+            <a:stretch>
+              <a:fillRect/>
+            </a:stretch>
+          </p:blipFill>
+          <p:spPr bwMode="auto">
+            <a:xfrm>
+              <a:off x="1248943" y="15625067"/>
+              <a:ext cx="11846368" cy="10743678"/>
+            </a:xfrm>
+            <a:prstGeom prst="rect">
+              <a:avLst/>
+            </a:prstGeom>
+            <a:noFill/>
+            <a:extLst>
+              <a:ext uri="{909E8E84-426E-40DD-AFC4-6F175D3DCCD1}">
+                <a14:hiddenFill xmlns:a14="http://schemas.microsoft.com/office/drawing/2010/main">
+                  <a:solidFill>
+                    <a:srgbClr val="FFFFFF"/>
+                  </a:solidFill>
+                </a14:hiddenFill>
+              </a:ext>
+            </a:extLst>
+          </p:spPr>
+        </p:pic>
+        <p:sp>
+          <p:nvSpPr>
+            <p:cNvPr id="20" name="Rectangle 19">
+              <a:extLst>
+                <a:ext uri="{FF2B5EF4-FFF2-40B4-BE49-F238E27FC236}">
+                  <a16:creationId xmlns:a16="http://schemas.microsoft.com/office/drawing/2014/main" id="{973C567E-A26E-786B-C29F-605FE95B1F4A}"/>
+                </a:ext>
+              </a:extLst>
+            </p:cNvPr>
+            <p:cNvSpPr/>
+            <p:nvPr/>
+          </p:nvSpPr>
+          <p:spPr>
+            <a:xfrm>
+              <a:off x="2517049" y="15789746"/>
+              <a:ext cx="12235236" cy="504056"/>
+            </a:xfrm>
+            <a:prstGeom prst="rect">
+              <a:avLst/>
+            </a:prstGeom>
+            <a:solidFill>
+              <a:schemeClr val="bg1"/>
+            </a:solidFill>
+            <a:ln>
+              <a:solidFill>
+                <a:schemeClr val="bg1"/>
+              </a:solidFill>
+            </a:ln>
+          </p:spPr>
+          <p:style>
+            <a:lnRef idx="2">
+              <a:schemeClr val="accent1">
+                <a:shade val="15000"/>
+              </a:schemeClr>
+            </a:lnRef>
+            <a:fillRef idx="1">
+              <a:schemeClr val="accent1"/>
+            </a:fillRef>
+            <a:effectRef idx="0">
+              <a:schemeClr val="accent1"/>
+            </a:effectRef>
+            <a:fontRef idx="minor">
+              <a:schemeClr val="lt1"/>
+            </a:fontRef>
+          </p:style>
+          <p:txBody>
+            <a:bodyPr rtlCol="0" anchor="ctr"/>
+            <a:lstStyle/>
+            <a:p>
+              <a:r>
+                <a:rPr lang="en-US" sz="2400" dirty="0">
+                  <a:solidFill>
+                    <a:schemeClr val="tx1"/>
+                  </a:solidFill>
+                </a:rPr>
+                <a:t>(C) Median Disease Pressure By Common Garden Site</a:t>
+              </a:r>
+            </a:p>
+          </p:txBody>
+        </p:sp>
+        <p:sp>
+          <p:nvSpPr>
+            <p:cNvPr id="24" name="Rectangle 23">
+              <a:extLst>
+                <a:ext uri="{FF2B5EF4-FFF2-40B4-BE49-F238E27FC236}">
+                  <a16:creationId xmlns:a16="http://schemas.microsoft.com/office/drawing/2014/main" id="{F0420000-4144-D14F-B365-BFC7642A389E}"/>
+                </a:ext>
+              </a:extLst>
+            </p:cNvPr>
+            <p:cNvSpPr/>
+            <p:nvPr/>
+          </p:nvSpPr>
+          <p:spPr>
+            <a:xfrm rot="16200000">
+              <a:off x="-1184948" y="20744878"/>
+              <a:ext cx="5371839" cy="504056"/>
+            </a:xfrm>
+            <a:prstGeom prst="rect">
+              <a:avLst/>
+            </a:prstGeom>
+            <a:solidFill>
+              <a:schemeClr val="bg1"/>
+            </a:solidFill>
+            <a:ln>
+              <a:solidFill>
+                <a:schemeClr val="bg1"/>
+              </a:solidFill>
+            </a:ln>
+          </p:spPr>
+          <p:style>
+            <a:lnRef idx="2">
+              <a:schemeClr val="accent1">
+                <a:shade val="15000"/>
+              </a:schemeClr>
+            </a:lnRef>
+            <a:fillRef idx="1">
+              <a:schemeClr val="accent1"/>
+            </a:fillRef>
+            <a:effectRef idx="0">
+              <a:schemeClr val="accent1"/>
+            </a:effectRef>
+            <a:fontRef idx="minor">
+              <a:schemeClr val="lt1"/>
+            </a:fontRef>
+          </p:style>
+          <p:txBody>
+            <a:bodyPr rtlCol="0" anchor="ctr"/>
+            <a:lstStyle/>
+            <a:p>
+              <a:pPr algn="ctr"/>
+              <a:r>
+                <a:rPr lang="en-US" sz="1800" dirty="0">
+                  <a:solidFill>
+                    <a:schemeClr val="tx1"/>
+                  </a:solidFill>
+                </a:rPr>
+                <a:t>Disease Prevalence</a:t>
+              </a:r>
+            </a:p>
+          </p:txBody>
+        </p:sp>
+        <p:pic>
+          <p:nvPicPr>
+            <p:cNvPr id="25" name="Picture 4">
+              <a:extLst>
+                <a:ext uri="{FF2B5EF4-FFF2-40B4-BE49-F238E27FC236}">
+                  <a16:creationId xmlns:a16="http://schemas.microsoft.com/office/drawing/2014/main" id="{A85BCA85-A8CA-E9D2-74A9-9404749B3BC5}"/>
+                </a:ext>
+              </a:extLst>
+            </p:cNvPr>
+            <p:cNvPicPr>
+              <a:picLocks noChangeAspect="1" noChangeArrowheads="1"/>
+            </p:cNvPicPr>
+            <p:nvPr/>
+          </p:nvPicPr>
+          <p:blipFill rotWithShape="1">
+            <a:blip r:embed="rId5">
+              <a:extLst>
+                <a:ext uri="{28A0092B-C50C-407E-A947-70E740481C1C}">
+                  <a14:useLocalDpi xmlns:a14="http://schemas.microsoft.com/office/drawing/2010/main" val="0"/>
+                </a:ext>
+              </a:extLst>
+            </a:blip>
+            <a:srcRect l="82436" t="38214" b="39430"/>
+            <a:stretch>
+              <a:fillRect/>
+            </a:stretch>
+          </p:blipFill>
+          <p:spPr bwMode="auto">
+            <a:xfrm>
+              <a:off x="14695575" y="16426681"/>
+              <a:ext cx="1612588" cy="1554559"/>
+            </a:xfrm>
+            <a:prstGeom prst="rect">
+              <a:avLst/>
+            </a:prstGeom>
+            <a:noFill/>
+            <a:extLst>
+              <a:ext uri="{909E8E84-426E-40DD-AFC4-6F175D3DCCD1}">
+                <a14:hiddenFill xmlns:a14="http://schemas.microsoft.com/office/drawing/2010/main">
+                  <a:solidFill>
+                    <a:srgbClr val="FFFFFF"/>
+                  </a:solidFill>
+                </a14:hiddenFill>
+              </a:ext>
+            </a:extLst>
+          </p:spPr>
+        </p:pic>
+        <p:sp>
+          <p:nvSpPr>
+            <p:cNvPr id="26" name="Rectangle 25">
+              <a:extLst>
+                <a:ext uri="{FF2B5EF4-FFF2-40B4-BE49-F238E27FC236}">
+                  <a16:creationId xmlns:a16="http://schemas.microsoft.com/office/drawing/2014/main" id="{8A70AE1D-8B2A-765F-39A6-3F3BD09D5C55}"/>
+                </a:ext>
+              </a:extLst>
+            </p:cNvPr>
+            <p:cNvSpPr/>
+            <p:nvPr/>
+          </p:nvSpPr>
+          <p:spPr>
+            <a:xfrm>
+              <a:off x="14877288" y="16797528"/>
+              <a:ext cx="338328" cy="334418"/>
+            </a:xfrm>
+            <a:prstGeom prst="rect">
+              <a:avLst/>
+            </a:prstGeom>
+            <a:solidFill>
+              <a:srgbClr val="FA2F39"/>
+            </a:solidFill>
+            <a:ln w="12700"/>
+          </p:spPr>
+          <p:style>
+            <a:lnRef idx="2">
+              <a:schemeClr val="accent1">
+                <a:shade val="15000"/>
+              </a:schemeClr>
+            </a:lnRef>
+            <a:fillRef idx="1">
+              <a:schemeClr val="accent1"/>
+            </a:fillRef>
+            <a:effectRef idx="0">
+              <a:schemeClr val="accent1"/>
+            </a:effectRef>
+            <a:fontRef idx="minor">
+              <a:schemeClr val="lt1"/>
+            </a:fontRef>
+          </p:style>
+          <p:txBody>
+            <a:bodyPr rtlCol="0" anchor="ctr"/>
+            <a:lstStyle/>
+            <a:p>
+              <a:pPr algn="ctr"/>
+              <a:endParaRPr lang="en-US"/>
+            </a:p>
+          </p:txBody>
+        </p:sp>
+        <p:sp>
+          <p:nvSpPr>
+            <p:cNvPr id="27" name="Rectangle 26">
+              <a:extLst>
+                <a:ext uri="{FF2B5EF4-FFF2-40B4-BE49-F238E27FC236}">
+                  <a16:creationId xmlns:a16="http://schemas.microsoft.com/office/drawing/2014/main" id="{3C3BB425-0EBF-10DA-3D83-CF4F390350BF}"/>
+                </a:ext>
+              </a:extLst>
+            </p:cNvPr>
+            <p:cNvSpPr/>
+            <p:nvPr/>
+          </p:nvSpPr>
+          <p:spPr>
+            <a:xfrm>
+              <a:off x="14877288" y="17145234"/>
+              <a:ext cx="338328" cy="334418"/>
+            </a:xfrm>
+            <a:prstGeom prst="rect">
+              <a:avLst/>
+            </a:prstGeom>
+            <a:solidFill>
+              <a:srgbClr val="FED154"/>
+            </a:solidFill>
+            <a:ln w="12700"/>
+          </p:spPr>
+          <p:style>
+            <a:lnRef idx="2">
+              <a:schemeClr val="accent1">
+                <a:shade val="15000"/>
+              </a:schemeClr>
+            </a:lnRef>
+            <a:fillRef idx="1">
+              <a:schemeClr val="accent1"/>
+            </a:fillRef>
+            <a:effectRef idx="0">
+              <a:schemeClr val="accent1"/>
+            </a:effectRef>
+            <a:fontRef idx="minor">
+              <a:schemeClr val="lt1"/>
+            </a:fontRef>
+          </p:style>
+          <p:txBody>
+            <a:bodyPr rtlCol="0" anchor="ctr"/>
+            <a:lstStyle/>
+            <a:p>
+              <a:pPr algn="ctr"/>
+              <a:endParaRPr lang="en-US"/>
+            </a:p>
+          </p:txBody>
+        </p:sp>
+        <p:sp>
+          <p:nvSpPr>
+            <p:cNvPr id="28" name="Rectangle 27">
+              <a:extLst>
+                <a:ext uri="{FF2B5EF4-FFF2-40B4-BE49-F238E27FC236}">
+                  <a16:creationId xmlns:a16="http://schemas.microsoft.com/office/drawing/2014/main" id="{BBBDF8AB-D751-4B6D-C3FA-7C4D3D2527B3}"/>
+                </a:ext>
+              </a:extLst>
+            </p:cNvPr>
+            <p:cNvSpPr/>
+            <p:nvPr/>
+          </p:nvSpPr>
+          <p:spPr>
+            <a:xfrm>
+              <a:off x="14877288" y="17492940"/>
+              <a:ext cx="338328" cy="334418"/>
+            </a:xfrm>
+            <a:prstGeom prst="rect">
+              <a:avLst/>
+            </a:prstGeom>
+            <a:solidFill>
+              <a:srgbClr val="118EA8"/>
+            </a:solidFill>
+            <a:ln w="12700"/>
+          </p:spPr>
+          <p:style>
+            <a:lnRef idx="2">
+              <a:schemeClr val="accent1">
+                <a:shade val="15000"/>
+              </a:schemeClr>
+            </a:lnRef>
+            <a:fillRef idx="1">
+              <a:schemeClr val="accent1"/>
+            </a:fillRef>
+            <a:effectRef idx="0">
+              <a:schemeClr val="accent1"/>
+            </a:effectRef>
+            <a:fontRef idx="minor">
+              <a:schemeClr val="lt1"/>
+            </a:fontRef>
+          </p:style>
+          <p:txBody>
+            <a:bodyPr rtlCol="0" anchor="ctr"/>
+            <a:lstStyle/>
+            <a:p>
+              <a:pPr algn="ctr"/>
+              <a:endParaRPr lang="en-US"/>
+            </a:p>
+          </p:txBody>
+        </p:sp>
+        <p:sp>
+          <p:nvSpPr>
+            <p:cNvPr id="32" name="Rectangle 31">
+              <a:extLst>
+                <a:ext uri="{FF2B5EF4-FFF2-40B4-BE49-F238E27FC236}">
+                  <a16:creationId xmlns:a16="http://schemas.microsoft.com/office/drawing/2014/main" id="{795802A6-DCAC-04B2-21F4-8BE8E372DD2B}"/>
+                </a:ext>
+              </a:extLst>
+            </p:cNvPr>
+            <p:cNvSpPr/>
+            <p:nvPr/>
+          </p:nvSpPr>
+          <p:spPr>
+            <a:xfrm>
+              <a:off x="4993843" y="25813344"/>
+              <a:ext cx="5371839" cy="807429"/>
+            </a:xfrm>
+            <a:prstGeom prst="rect">
+              <a:avLst/>
+            </a:prstGeom>
+            <a:solidFill>
+              <a:schemeClr val="bg1"/>
+            </a:solidFill>
+            <a:ln>
+              <a:solidFill>
+                <a:schemeClr val="bg1"/>
+              </a:solidFill>
+            </a:ln>
+          </p:spPr>
+          <p:style>
+            <a:lnRef idx="2">
+              <a:schemeClr val="accent1">
+                <a:shade val="15000"/>
+              </a:schemeClr>
+            </a:lnRef>
+            <a:fillRef idx="1">
+              <a:schemeClr val="accent1"/>
+            </a:fillRef>
+            <a:effectRef idx="0">
+              <a:schemeClr val="accent1"/>
+            </a:effectRef>
+            <a:fontRef idx="minor">
+              <a:schemeClr val="lt1"/>
+            </a:fontRef>
+          </p:style>
+          <p:txBody>
+            <a:bodyPr rtlCol="0" anchor="ctr"/>
+            <a:lstStyle/>
+            <a:p>
+              <a:pPr algn="ctr"/>
+              <a:r>
+                <a:rPr lang="en-US" sz="1800" dirty="0">
+                  <a:solidFill>
+                    <a:schemeClr val="tx1"/>
+                  </a:solidFill>
+                </a:rPr>
+                <a:t>Common Garden Site</a:t>
+              </a:r>
+            </a:p>
+          </p:txBody>
+        </p:sp>
+        <p:sp>
+          <p:nvSpPr>
+            <p:cNvPr id="33" name="Rectangle 32">
+              <a:extLst>
+                <a:ext uri="{FF2B5EF4-FFF2-40B4-BE49-F238E27FC236}">
+                  <a16:creationId xmlns:a16="http://schemas.microsoft.com/office/drawing/2014/main" id="{FD622416-87C8-F692-028A-58BAFC9CB925}"/>
+                </a:ext>
+              </a:extLst>
+            </p:cNvPr>
+            <p:cNvSpPr/>
+            <p:nvPr/>
+          </p:nvSpPr>
+          <p:spPr>
+            <a:xfrm>
+              <a:off x="2538897" y="25525312"/>
+              <a:ext cx="5371839" cy="403715"/>
+            </a:xfrm>
+            <a:prstGeom prst="rect">
+              <a:avLst/>
+            </a:prstGeom>
+            <a:solidFill>
+              <a:schemeClr val="bg1"/>
+            </a:solidFill>
+            <a:ln>
+              <a:solidFill>
+                <a:schemeClr val="bg1"/>
+              </a:solidFill>
+            </a:ln>
+          </p:spPr>
+          <p:style>
+            <a:lnRef idx="2">
+              <a:schemeClr val="accent1">
+                <a:shade val="15000"/>
+              </a:schemeClr>
+            </a:lnRef>
+            <a:fillRef idx="1">
+              <a:schemeClr val="accent1"/>
+            </a:fillRef>
+            <a:effectRef idx="0">
+              <a:schemeClr val="accent1"/>
+            </a:effectRef>
+            <a:fontRef idx="minor">
+              <a:schemeClr val="lt1"/>
+            </a:fontRef>
+          </p:style>
+          <p:txBody>
+            <a:bodyPr rtlCol="0" anchor="ctr"/>
+            <a:lstStyle/>
+            <a:p>
+              <a:pPr algn="ctr"/>
+              <a:r>
+                <a:rPr lang="en-US" sz="1800" dirty="0">
+                  <a:solidFill>
+                    <a:schemeClr val="tx1"/>
+                  </a:solidFill>
+                </a:rPr>
+                <a:t>Lewisetta</a:t>
+              </a:r>
+            </a:p>
+          </p:txBody>
+        </p:sp>
+        <p:sp>
+          <p:nvSpPr>
+            <p:cNvPr id="34" name="Rectangle 33">
+              <a:extLst>
+                <a:ext uri="{FF2B5EF4-FFF2-40B4-BE49-F238E27FC236}">
+                  <a16:creationId xmlns:a16="http://schemas.microsoft.com/office/drawing/2014/main" id="{8B4077A6-CB69-03EA-3956-F08D2681C364}"/>
+                </a:ext>
+              </a:extLst>
+            </p:cNvPr>
+            <p:cNvSpPr/>
+            <p:nvPr/>
+          </p:nvSpPr>
+          <p:spPr>
+            <a:xfrm>
+              <a:off x="7177990" y="25543313"/>
+              <a:ext cx="5371839" cy="403715"/>
+            </a:xfrm>
+            <a:prstGeom prst="rect">
+              <a:avLst/>
+            </a:prstGeom>
+            <a:solidFill>
+              <a:schemeClr val="bg1"/>
+            </a:solidFill>
+            <a:ln>
+              <a:solidFill>
+                <a:schemeClr val="bg1"/>
+              </a:solidFill>
+            </a:ln>
+          </p:spPr>
+          <p:style>
+            <a:lnRef idx="2">
+              <a:schemeClr val="accent1">
+                <a:shade val="15000"/>
+              </a:schemeClr>
+            </a:lnRef>
+            <a:fillRef idx="1">
+              <a:schemeClr val="accent1"/>
+            </a:fillRef>
+            <a:effectRef idx="0">
+              <a:schemeClr val="accent1"/>
+            </a:effectRef>
+            <a:fontRef idx="minor">
+              <a:schemeClr val="lt1"/>
+            </a:fontRef>
+          </p:style>
+          <p:txBody>
+            <a:bodyPr rtlCol="0" anchor="ctr"/>
+            <a:lstStyle/>
+            <a:p>
+              <a:pPr algn="ctr"/>
+              <a:r>
+                <a:rPr lang="en-US" sz="1800" dirty="0">
+                  <a:solidFill>
+                    <a:schemeClr val="tx1"/>
+                  </a:solidFill>
+                </a:rPr>
+                <a:t>York River</a:t>
+              </a:r>
+            </a:p>
+          </p:txBody>
+        </p:sp>
+      </p:grpSp>
     </p:spTree>
     <p:extLst>
       <p:ext uri="{BB962C8B-B14F-4D97-AF65-F5344CB8AC3E}">
-        <p14:creationId xmlns:p14="http://schemas.microsoft.com/office/powerpoint/2010/main" val="2360873365"/>
+        <p14:creationId xmlns:p14="http://schemas.microsoft.com/office/powerpoint/2010/main" val="4257504770"/>
       </p:ext>
     </p:extLst>
   </p:cSld>

</xml_diff>

<commit_message>
figure edits characterizing experiment
</commit_message>
<xml_diff>
--- a/results/figures/envexp_timeseries_edited.pptx
+++ b/results/figures/envexp_timeseries_edited.pptx
@@ -12,7 +12,7 @@
     <p:sldId id="260" r:id="rId6"/>
     <p:sldId id="261" r:id="rId7"/>
   </p:sldIdLst>
-  <p:sldSz cx="20574000" cy="27432000"/>
+  <p:sldSz cx="15544800" cy="20116800"/>
   <p:notesSz cx="6858000" cy="9144000"/>
   <p:custDataLst>
     <p:tags r:id="rId8"/>
@@ -21,8 +21,8 @@
     <a:defPPr>
       <a:defRPr lang="en-US"/>
     </a:defPPr>
-    <a:lvl1pPr marL="0" algn="l" defTabSz="2743200" rtl="0" eaLnBrk="1" latinLnBrk="0" hangingPunct="1">
-      <a:defRPr sz="5400" kern="1200">
+    <a:lvl1pPr marL="0" algn="l" defTabSz="2037272" rtl="0" eaLnBrk="1" latinLnBrk="0" hangingPunct="1">
+      <a:defRPr sz="4011" kern="1200">
         <a:solidFill>
           <a:schemeClr val="tx1"/>
         </a:solidFill>
@@ -31,8 +31,8 @@
         <a:cs typeface="+mn-cs"/>
       </a:defRPr>
     </a:lvl1pPr>
-    <a:lvl2pPr marL="1371600" algn="l" defTabSz="2743200" rtl="0" eaLnBrk="1" latinLnBrk="0" hangingPunct="1">
-      <a:defRPr sz="5400" kern="1200">
+    <a:lvl2pPr marL="1018636" algn="l" defTabSz="2037272" rtl="0" eaLnBrk="1" latinLnBrk="0" hangingPunct="1">
+      <a:defRPr sz="4011" kern="1200">
         <a:solidFill>
           <a:schemeClr val="tx1"/>
         </a:solidFill>
@@ -41,8 +41,8 @@
         <a:cs typeface="+mn-cs"/>
       </a:defRPr>
     </a:lvl2pPr>
-    <a:lvl3pPr marL="2743200" algn="l" defTabSz="2743200" rtl="0" eaLnBrk="1" latinLnBrk="0" hangingPunct="1">
-      <a:defRPr sz="5400" kern="1200">
+    <a:lvl3pPr marL="2037272" algn="l" defTabSz="2037272" rtl="0" eaLnBrk="1" latinLnBrk="0" hangingPunct="1">
+      <a:defRPr sz="4011" kern="1200">
         <a:solidFill>
           <a:schemeClr val="tx1"/>
         </a:solidFill>
@@ -51,8 +51,8 @@
         <a:cs typeface="+mn-cs"/>
       </a:defRPr>
     </a:lvl3pPr>
-    <a:lvl4pPr marL="4114800" algn="l" defTabSz="2743200" rtl="0" eaLnBrk="1" latinLnBrk="0" hangingPunct="1">
-      <a:defRPr sz="5400" kern="1200">
+    <a:lvl4pPr marL="3055907" algn="l" defTabSz="2037272" rtl="0" eaLnBrk="1" latinLnBrk="0" hangingPunct="1">
+      <a:defRPr sz="4011" kern="1200">
         <a:solidFill>
           <a:schemeClr val="tx1"/>
         </a:solidFill>
@@ -61,8 +61,8 @@
         <a:cs typeface="+mn-cs"/>
       </a:defRPr>
     </a:lvl4pPr>
-    <a:lvl5pPr marL="5486400" algn="l" defTabSz="2743200" rtl="0" eaLnBrk="1" latinLnBrk="0" hangingPunct="1">
-      <a:defRPr sz="5400" kern="1200">
+    <a:lvl5pPr marL="4074545" algn="l" defTabSz="2037272" rtl="0" eaLnBrk="1" latinLnBrk="0" hangingPunct="1">
+      <a:defRPr sz="4011" kern="1200">
         <a:solidFill>
           <a:schemeClr val="tx1"/>
         </a:solidFill>
@@ -71,8 +71,8 @@
         <a:cs typeface="+mn-cs"/>
       </a:defRPr>
     </a:lvl5pPr>
-    <a:lvl6pPr marL="6858000" algn="l" defTabSz="2743200" rtl="0" eaLnBrk="1" latinLnBrk="0" hangingPunct="1">
-      <a:defRPr sz="5400" kern="1200">
+    <a:lvl6pPr marL="5093181" algn="l" defTabSz="2037272" rtl="0" eaLnBrk="1" latinLnBrk="0" hangingPunct="1">
+      <a:defRPr sz="4011" kern="1200">
         <a:solidFill>
           <a:schemeClr val="tx1"/>
         </a:solidFill>
@@ -81,8 +81,8 @@
         <a:cs typeface="+mn-cs"/>
       </a:defRPr>
     </a:lvl6pPr>
-    <a:lvl7pPr marL="8229600" algn="l" defTabSz="2743200" rtl="0" eaLnBrk="1" latinLnBrk="0" hangingPunct="1">
-      <a:defRPr sz="5400" kern="1200">
+    <a:lvl7pPr marL="6111818" algn="l" defTabSz="2037272" rtl="0" eaLnBrk="1" latinLnBrk="0" hangingPunct="1">
+      <a:defRPr sz="4011" kern="1200">
         <a:solidFill>
           <a:schemeClr val="tx1"/>
         </a:solidFill>
@@ -91,8 +91,8 @@
         <a:cs typeface="+mn-cs"/>
       </a:defRPr>
     </a:lvl7pPr>
-    <a:lvl8pPr marL="9601200" algn="l" defTabSz="2743200" rtl="0" eaLnBrk="1" latinLnBrk="0" hangingPunct="1">
-      <a:defRPr sz="5400" kern="1200">
+    <a:lvl8pPr marL="7130454" algn="l" defTabSz="2037272" rtl="0" eaLnBrk="1" latinLnBrk="0" hangingPunct="1">
+      <a:defRPr sz="4011" kern="1200">
         <a:solidFill>
           <a:schemeClr val="tx1"/>
         </a:solidFill>
@@ -101,8 +101,8 @@
         <a:cs typeface="+mn-cs"/>
       </a:defRPr>
     </a:lvl8pPr>
-    <a:lvl9pPr marL="10972800" algn="l" defTabSz="2743200" rtl="0" eaLnBrk="1" latinLnBrk="0" hangingPunct="1">
-      <a:defRPr sz="5400" kern="1200">
+    <a:lvl9pPr marL="8149089" algn="l" defTabSz="2037272" rtl="0" eaLnBrk="1" latinLnBrk="0" hangingPunct="1">
+      <a:defRPr sz="4011" kern="1200">
         <a:solidFill>
           <a:schemeClr val="tx1"/>
         </a:solidFill>
@@ -115,12 +115,12 @@
   <p:extLst>
     <p:ext uri="{EFAFB233-063F-42B5-8137-9DF3F51BA10A}">
       <p15:sldGuideLst xmlns:p15="http://schemas.microsoft.com/office/powerpoint/2012/main">
-        <p15:guide id="1" orient="horz" pos="8640" userDrawn="1">
+        <p15:guide id="1" orient="horz" pos="6336" userDrawn="1">
           <p15:clr>
             <a:srgbClr val="A4A3A4"/>
           </p15:clr>
         </p15:guide>
-        <p15:guide id="2" pos="6480" userDrawn="1">
+        <p15:guide id="2" pos="4896" userDrawn="1">
           <p15:clr>
             <a:srgbClr val="A4A3A4"/>
           </p15:clr>
@@ -160,8 +160,8 @@
         </p:nvSpPr>
         <p:spPr>
           <a:xfrm>
-            <a:off x="1543050" y="8521702"/>
-            <a:ext cx="17487900" cy="5880100"/>
+            <a:off x="1165860" y="6249250"/>
+            <a:ext cx="13213080" cy="4312073"/>
           </a:xfrm>
         </p:spPr>
         <p:txBody>
@@ -188,8 +188,8 @@
         </p:nvSpPr>
         <p:spPr>
           <a:xfrm>
-            <a:off x="3086100" y="15544800"/>
-            <a:ext cx="14401800" cy="7010400"/>
+            <a:off x="2331720" y="11399520"/>
+            <a:ext cx="10881360" cy="5140960"/>
           </a:xfrm>
         </p:spPr>
         <p:txBody>
@@ -205,7 +205,7 @@
                 </a:solidFill>
               </a:defRPr>
             </a:lvl1pPr>
-            <a:lvl2pPr marL="457200" indent="0" algn="ctr">
+            <a:lvl2pPr marL="388620" indent="0" algn="ctr">
               <a:buNone/>
               <a:defRPr>
                 <a:solidFill>
@@ -215,7 +215,7 @@
                 </a:solidFill>
               </a:defRPr>
             </a:lvl2pPr>
-            <a:lvl3pPr marL="914400" indent="0" algn="ctr">
+            <a:lvl3pPr marL="777240" indent="0" algn="ctr">
               <a:buNone/>
               <a:defRPr>
                 <a:solidFill>
@@ -225,7 +225,7 @@
                 </a:solidFill>
               </a:defRPr>
             </a:lvl3pPr>
-            <a:lvl4pPr marL="1371600" indent="0" algn="ctr">
+            <a:lvl4pPr marL="1165860" indent="0" algn="ctr">
               <a:buNone/>
               <a:defRPr>
                 <a:solidFill>
@@ -235,7 +235,7 @@
                 </a:solidFill>
               </a:defRPr>
             </a:lvl4pPr>
-            <a:lvl5pPr marL="1828800" indent="0" algn="ctr">
+            <a:lvl5pPr marL="1554480" indent="0" algn="ctr">
               <a:buNone/>
               <a:defRPr>
                 <a:solidFill>
@@ -245,7 +245,7 @@
                 </a:solidFill>
               </a:defRPr>
             </a:lvl5pPr>
-            <a:lvl6pPr marL="2286000" indent="0" algn="ctr">
+            <a:lvl6pPr marL="1943100" indent="0" algn="ctr">
               <a:buNone/>
               <a:defRPr>
                 <a:solidFill>
@@ -255,7 +255,7 @@
                 </a:solidFill>
               </a:defRPr>
             </a:lvl6pPr>
-            <a:lvl7pPr marL="2743200" indent="0" algn="ctr">
+            <a:lvl7pPr marL="2331720" indent="0" algn="ctr">
               <a:buNone/>
               <a:defRPr>
                 <a:solidFill>
@@ -265,7 +265,7 @@
                 </a:solidFill>
               </a:defRPr>
             </a:lvl7pPr>
-            <a:lvl8pPr marL="3200400" indent="0" algn="ctr">
+            <a:lvl8pPr marL="2720340" indent="0" algn="ctr">
               <a:buNone/>
               <a:defRPr>
                 <a:solidFill>
@@ -275,7 +275,7 @@
                 </a:solidFill>
               </a:defRPr>
             </a:lvl8pPr>
-            <a:lvl9pPr marL="3657600" indent="0" algn="ctr">
+            <a:lvl9pPr marL="3108960" indent="0" algn="ctr">
               <a:buNone/>
               <a:defRPr>
                 <a:solidFill>
@@ -312,7 +312,7 @@
           <a:p>
             <a:fld id="{E6744CE3-0875-4B69-89C0-6F72D8139561}" type="datetimeFigureOut">
               <a:rPr lang="en-GB" smtClean="0"/>
-              <a:t>01/02/2026</a:t>
+              <a:t>05/05/2026</a:t>
             </a:fld>
             <a:endParaRPr lang="en-GB"/>
           </a:p>
@@ -482,7 +482,7 @@
           <a:p>
             <a:fld id="{E6744CE3-0875-4B69-89C0-6F72D8139561}" type="datetimeFigureOut">
               <a:rPr lang="en-GB" smtClean="0"/>
-              <a:t>01/02/2026</a:t>
+              <a:t>05/05/2026</a:t>
             </a:fld>
             <a:endParaRPr lang="en-GB"/>
           </a:p>
@@ -572,15 +572,15 @@
         </p:nvSpPr>
         <p:spPr>
           <a:xfrm>
-            <a:off x="1625204" y="17627602"/>
-            <a:ext cx="17487900" cy="5448300"/>
+            <a:off x="1227932" y="12926909"/>
+            <a:ext cx="13213080" cy="3995420"/>
           </a:xfrm>
         </p:spPr>
         <p:txBody>
           <a:bodyPr anchor="t"/>
           <a:lstStyle>
             <a:lvl1pPr algn="l">
-              <a:defRPr sz="4000" b="1" cap="all"/>
+              <a:defRPr sz="3400" b="1" cap="all"/>
             </a:lvl1pPr>
           </a:lstStyle>
           <a:p>
@@ -604,8 +604,8 @@
         </p:nvSpPr>
         <p:spPr>
           <a:xfrm>
-            <a:off x="1625204" y="11626854"/>
-            <a:ext cx="17487900" cy="6000748"/>
+            <a:off x="1227932" y="8526360"/>
+            <a:ext cx="13213080" cy="4400548"/>
           </a:xfrm>
         </p:spPr>
         <p:txBody>
@@ -613,7 +613,7 @@
           <a:lstStyle>
             <a:lvl1pPr marL="0" indent="0">
               <a:buNone/>
-              <a:defRPr sz="2000">
+              <a:defRPr sz="1700">
                 <a:solidFill>
                   <a:schemeClr val="tx1">
                     <a:tint val="75000"/>
@@ -621,9 +621,9 @@
                 </a:solidFill>
               </a:defRPr>
             </a:lvl1pPr>
-            <a:lvl2pPr marL="457200" indent="0">
+            <a:lvl2pPr marL="388620" indent="0">
               <a:buNone/>
-              <a:defRPr sz="1800">
+              <a:defRPr sz="1530">
                 <a:solidFill>
                   <a:schemeClr val="tx1">
                     <a:tint val="75000"/>
@@ -631,9 +631,9 @@
                 </a:solidFill>
               </a:defRPr>
             </a:lvl2pPr>
-            <a:lvl3pPr marL="914400" indent="0">
+            <a:lvl3pPr marL="777240" indent="0">
               <a:buNone/>
-              <a:defRPr sz="1600">
+              <a:defRPr sz="1360">
                 <a:solidFill>
                   <a:schemeClr val="tx1">
                     <a:tint val="75000"/>
@@ -641,9 +641,9 @@
                 </a:solidFill>
               </a:defRPr>
             </a:lvl3pPr>
-            <a:lvl4pPr marL="1371600" indent="0">
+            <a:lvl4pPr marL="1165860" indent="0">
               <a:buNone/>
-              <a:defRPr sz="1400">
+              <a:defRPr sz="1190">
                 <a:solidFill>
                   <a:schemeClr val="tx1">
                     <a:tint val="75000"/>
@@ -651,9 +651,9 @@
                 </a:solidFill>
               </a:defRPr>
             </a:lvl4pPr>
-            <a:lvl5pPr marL="1828800" indent="0">
+            <a:lvl5pPr marL="1554480" indent="0">
               <a:buNone/>
-              <a:defRPr sz="1400">
+              <a:defRPr sz="1190">
                 <a:solidFill>
                   <a:schemeClr val="tx1">
                     <a:tint val="75000"/>
@@ -661,9 +661,9 @@
                 </a:solidFill>
               </a:defRPr>
             </a:lvl5pPr>
-            <a:lvl6pPr marL="2286000" indent="0">
+            <a:lvl6pPr marL="1943100" indent="0">
               <a:buNone/>
-              <a:defRPr sz="1400">
+              <a:defRPr sz="1190">
                 <a:solidFill>
                   <a:schemeClr val="tx1">
                     <a:tint val="75000"/>
@@ -671,9 +671,9 @@
                 </a:solidFill>
               </a:defRPr>
             </a:lvl6pPr>
-            <a:lvl7pPr marL="2743200" indent="0">
+            <a:lvl7pPr marL="2331720" indent="0">
               <a:buNone/>
-              <a:defRPr sz="1400">
+              <a:defRPr sz="1190">
                 <a:solidFill>
                   <a:schemeClr val="tx1">
                     <a:tint val="75000"/>
@@ -681,9 +681,9 @@
                 </a:solidFill>
               </a:defRPr>
             </a:lvl7pPr>
-            <a:lvl8pPr marL="3200400" indent="0">
+            <a:lvl8pPr marL="2720340" indent="0">
               <a:buNone/>
-              <a:defRPr sz="1400">
+              <a:defRPr sz="1190">
                 <a:solidFill>
                   <a:schemeClr val="tx1">
                     <a:tint val="75000"/>
@@ -691,9 +691,9 @@
                 </a:solidFill>
               </a:defRPr>
             </a:lvl8pPr>
-            <a:lvl9pPr marL="3657600" indent="0">
+            <a:lvl9pPr marL="3108960" indent="0">
               <a:buNone/>
-              <a:defRPr sz="1400">
+              <a:defRPr sz="1190">
                 <a:solidFill>
                   <a:schemeClr val="tx1">
                     <a:tint val="75000"/>
@@ -728,7 +728,7 @@
           <a:p>
             <a:fld id="{E6744CE3-0875-4B69-89C0-6F72D8139561}" type="datetimeFigureOut">
               <a:rPr lang="en-GB" smtClean="0"/>
-              <a:t>01/02/2026</a:t>
+              <a:t>05/05/2026</a:t>
             </a:fld>
             <a:endParaRPr lang="en-GB"/>
           </a:p>
@@ -841,39 +841,39 @@
         </p:nvSpPr>
         <p:spPr>
           <a:xfrm>
-            <a:off x="1028700" y="6400802"/>
-            <a:ext cx="9086850" cy="18103852"/>
+            <a:off x="777240" y="4693922"/>
+            <a:ext cx="6865620" cy="13276159"/>
           </a:xfrm>
         </p:spPr>
         <p:txBody>
           <a:bodyPr/>
           <a:lstStyle>
             <a:lvl1pPr>
-              <a:defRPr sz="2800"/>
+              <a:defRPr sz="2380"/>
             </a:lvl1pPr>
             <a:lvl2pPr>
-              <a:defRPr sz="2400"/>
+              <a:defRPr sz="2040"/>
             </a:lvl2pPr>
             <a:lvl3pPr>
-              <a:defRPr sz="2000"/>
+              <a:defRPr sz="1700"/>
             </a:lvl3pPr>
             <a:lvl4pPr>
-              <a:defRPr sz="1800"/>
+              <a:defRPr sz="1530"/>
             </a:lvl4pPr>
             <a:lvl5pPr>
-              <a:defRPr sz="1800"/>
+              <a:defRPr sz="1530"/>
             </a:lvl5pPr>
             <a:lvl6pPr>
-              <a:defRPr sz="1800"/>
+              <a:defRPr sz="1530"/>
             </a:lvl6pPr>
             <a:lvl7pPr>
-              <a:defRPr sz="1800"/>
+              <a:defRPr sz="1530"/>
             </a:lvl7pPr>
             <a:lvl8pPr>
-              <a:defRPr sz="1800"/>
+              <a:defRPr sz="1530"/>
             </a:lvl8pPr>
             <a:lvl9pPr>
-              <a:defRPr sz="1800"/>
+              <a:defRPr sz="1530"/>
             </a:lvl9pPr>
           </a:lstStyle>
           <a:p>
@@ -926,39 +926,39 @@
         </p:nvSpPr>
         <p:spPr>
           <a:xfrm>
-            <a:off x="10458450" y="6400802"/>
-            <a:ext cx="9086850" cy="18103852"/>
+            <a:off x="7901940" y="4693922"/>
+            <a:ext cx="6865620" cy="13276159"/>
           </a:xfrm>
         </p:spPr>
         <p:txBody>
           <a:bodyPr/>
           <a:lstStyle>
             <a:lvl1pPr>
-              <a:defRPr sz="2800"/>
+              <a:defRPr sz="2380"/>
             </a:lvl1pPr>
             <a:lvl2pPr>
-              <a:defRPr sz="2400"/>
+              <a:defRPr sz="2040"/>
             </a:lvl2pPr>
             <a:lvl3pPr>
-              <a:defRPr sz="2000"/>
+              <a:defRPr sz="1700"/>
             </a:lvl3pPr>
             <a:lvl4pPr>
-              <a:defRPr sz="1800"/>
+              <a:defRPr sz="1530"/>
             </a:lvl4pPr>
             <a:lvl5pPr>
-              <a:defRPr sz="1800"/>
+              <a:defRPr sz="1530"/>
             </a:lvl5pPr>
             <a:lvl6pPr>
-              <a:defRPr sz="1800"/>
+              <a:defRPr sz="1530"/>
             </a:lvl6pPr>
             <a:lvl7pPr>
-              <a:defRPr sz="1800"/>
+              <a:defRPr sz="1530"/>
             </a:lvl7pPr>
             <a:lvl8pPr>
-              <a:defRPr sz="1800"/>
+              <a:defRPr sz="1530"/>
             </a:lvl8pPr>
             <a:lvl9pPr>
-              <a:defRPr sz="1800"/>
+              <a:defRPr sz="1530"/>
             </a:lvl9pPr>
           </a:lstStyle>
           <a:p>
@@ -1016,7 +1016,7 @@
           <a:p>
             <a:fld id="{E6744CE3-0875-4B69-89C0-6F72D8139561}" type="datetimeFigureOut">
               <a:rPr lang="en-GB" smtClean="0"/>
-              <a:t>01/02/2026</a:t>
+              <a:t>05/05/2026</a:t>
             </a:fld>
             <a:endParaRPr lang="en-GB"/>
           </a:p>
@@ -1133,8 +1133,8 @@
         </p:nvSpPr>
         <p:spPr>
           <a:xfrm>
-            <a:off x="1028700" y="6140452"/>
-            <a:ext cx="9090423" cy="2559048"/>
+            <a:off x="777240" y="4502998"/>
+            <a:ext cx="6868320" cy="1876635"/>
           </a:xfrm>
         </p:spPr>
         <p:txBody>
@@ -1142,39 +1142,39 @@
           <a:lstStyle>
             <a:lvl1pPr marL="0" indent="0">
               <a:buNone/>
-              <a:defRPr sz="2400" b="1"/>
+              <a:defRPr sz="2040" b="1"/>
             </a:lvl1pPr>
-            <a:lvl2pPr marL="457200" indent="0">
+            <a:lvl2pPr marL="388620" indent="0">
               <a:buNone/>
-              <a:defRPr sz="2000" b="1"/>
+              <a:defRPr sz="1700" b="1"/>
             </a:lvl2pPr>
-            <a:lvl3pPr marL="914400" indent="0">
+            <a:lvl3pPr marL="777240" indent="0">
               <a:buNone/>
-              <a:defRPr sz="1800" b="1"/>
+              <a:defRPr sz="1530" b="1"/>
             </a:lvl3pPr>
-            <a:lvl4pPr marL="1371600" indent="0">
+            <a:lvl4pPr marL="1165860" indent="0">
               <a:buNone/>
-              <a:defRPr sz="1600" b="1"/>
+              <a:defRPr sz="1360" b="1"/>
             </a:lvl4pPr>
-            <a:lvl5pPr marL="1828800" indent="0">
+            <a:lvl5pPr marL="1554480" indent="0">
               <a:buNone/>
-              <a:defRPr sz="1600" b="1"/>
+              <a:defRPr sz="1360" b="1"/>
             </a:lvl5pPr>
-            <a:lvl6pPr marL="2286000" indent="0">
+            <a:lvl6pPr marL="1943100" indent="0">
               <a:buNone/>
-              <a:defRPr sz="1600" b="1"/>
+              <a:defRPr sz="1360" b="1"/>
             </a:lvl6pPr>
-            <a:lvl7pPr marL="2743200" indent="0">
+            <a:lvl7pPr marL="2331720" indent="0">
               <a:buNone/>
-              <a:defRPr sz="1600" b="1"/>
+              <a:defRPr sz="1360" b="1"/>
             </a:lvl7pPr>
-            <a:lvl8pPr marL="3200400" indent="0">
+            <a:lvl8pPr marL="2720340" indent="0">
               <a:buNone/>
-              <a:defRPr sz="1600" b="1"/>
+              <a:defRPr sz="1360" b="1"/>
             </a:lvl8pPr>
-            <a:lvl9pPr marL="3657600" indent="0">
+            <a:lvl9pPr marL="3108960" indent="0">
               <a:buNone/>
-              <a:defRPr sz="1600" b="1"/>
+              <a:defRPr sz="1360" b="1"/>
             </a:lvl9pPr>
           </a:lstStyle>
           <a:p>
@@ -1198,39 +1198,39 @@
         </p:nvSpPr>
         <p:spPr>
           <a:xfrm>
-            <a:off x="1028700" y="8699500"/>
-            <a:ext cx="9090423" cy="15805152"/>
+            <a:off x="777240" y="6379633"/>
+            <a:ext cx="6868320" cy="11590445"/>
           </a:xfrm>
         </p:spPr>
         <p:txBody>
           <a:bodyPr/>
           <a:lstStyle>
             <a:lvl1pPr>
-              <a:defRPr sz="2400"/>
+              <a:defRPr sz="2040"/>
             </a:lvl1pPr>
             <a:lvl2pPr>
-              <a:defRPr sz="2000"/>
+              <a:defRPr sz="1700"/>
             </a:lvl2pPr>
             <a:lvl3pPr>
-              <a:defRPr sz="1800"/>
+              <a:defRPr sz="1530"/>
             </a:lvl3pPr>
             <a:lvl4pPr>
-              <a:defRPr sz="1600"/>
+              <a:defRPr sz="1360"/>
             </a:lvl4pPr>
             <a:lvl5pPr>
-              <a:defRPr sz="1600"/>
+              <a:defRPr sz="1360"/>
             </a:lvl5pPr>
             <a:lvl6pPr>
-              <a:defRPr sz="1600"/>
+              <a:defRPr sz="1360"/>
             </a:lvl6pPr>
             <a:lvl7pPr>
-              <a:defRPr sz="1600"/>
+              <a:defRPr sz="1360"/>
             </a:lvl7pPr>
             <a:lvl8pPr>
-              <a:defRPr sz="1600"/>
+              <a:defRPr sz="1360"/>
             </a:lvl8pPr>
             <a:lvl9pPr>
-              <a:defRPr sz="1600"/>
+              <a:defRPr sz="1360"/>
             </a:lvl9pPr>
           </a:lstStyle>
           <a:p>
@@ -1283,8 +1283,8 @@
         </p:nvSpPr>
         <p:spPr>
           <a:xfrm>
-            <a:off x="10451307" y="6140452"/>
-            <a:ext cx="9093994" cy="2559048"/>
+            <a:off x="7896543" y="4502998"/>
+            <a:ext cx="6871018" cy="1876635"/>
           </a:xfrm>
         </p:spPr>
         <p:txBody>
@@ -1292,39 +1292,39 @@
           <a:lstStyle>
             <a:lvl1pPr marL="0" indent="0">
               <a:buNone/>
-              <a:defRPr sz="2400" b="1"/>
+              <a:defRPr sz="2040" b="1"/>
             </a:lvl1pPr>
-            <a:lvl2pPr marL="457200" indent="0">
+            <a:lvl2pPr marL="388620" indent="0">
               <a:buNone/>
-              <a:defRPr sz="2000" b="1"/>
+              <a:defRPr sz="1700" b="1"/>
             </a:lvl2pPr>
-            <a:lvl3pPr marL="914400" indent="0">
+            <a:lvl3pPr marL="777240" indent="0">
               <a:buNone/>
-              <a:defRPr sz="1800" b="1"/>
+              <a:defRPr sz="1530" b="1"/>
             </a:lvl3pPr>
-            <a:lvl4pPr marL="1371600" indent="0">
+            <a:lvl4pPr marL="1165860" indent="0">
               <a:buNone/>
-              <a:defRPr sz="1600" b="1"/>
+              <a:defRPr sz="1360" b="1"/>
             </a:lvl4pPr>
-            <a:lvl5pPr marL="1828800" indent="0">
+            <a:lvl5pPr marL="1554480" indent="0">
               <a:buNone/>
-              <a:defRPr sz="1600" b="1"/>
+              <a:defRPr sz="1360" b="1"/>
             </a:lvl5pPr>
-            <a:lvl6pPr marL="2286000" indent="0">
+            <a:lvl6pPr marL="1943100" indent="0">
               <a:buNone/>
-              <a:defRPr sz="1600" b="1"/>
+              <a:defRPr sz="1360" b="1"/>
             </a:lvl6pPr>
-            <a:lvl7pPr marL="2743200" indent="0">
+            <a:lvl7pPr marL="2331720" indent="0">
               <a:buNone/>
-              <a:defRPr sz="1600" b="1"/>
+              <a:defRPr sz="1360" b="1"/>
             </a:lvl7pPr>
-            <a:lvl8pPr marL="3200400" indent="0">
+            <a:lvl8pPr marL="2720340" indent="0">
               <a:buNone/>
-              <a:defRPr sz="1600" b="1"/>
+              <a:defRPr sz="1360" b="1"/>
             </a:lvl8pPr>
-            <a:lvl9pPr marL="3657600" indent="0">
+            <a:lvl9pPr marL="3108960" indent="0">
               <a:buNone/>
-              <a:defRPr sz="1600" b="1"/>
+              <a:defRPr sz="1360" b="1"/>
             </a:lvl9pPr>
           </a:lstStyle>
           <a:p>
@@ -1348,39 +1348,39 @@
         </p:nvSpPr>
         <p:spPr>
           <a:xfrm>
-            <a:off x="10451307" y="8699500"/>
-            <a:ext cx="9093994" cy="15805152"/>
+            <a:off x="7896543" y="6379633"/>
+            <a:ext cx="6871018" cy="11590445"/>
           </a:xfrm>
         </p:spPr>
         <p:txBody>
           <a:bodyPr/>
           <a:lstStyle>
             <a:lvl1pPr>
-              <a:defRPr sz="2400"/>
+              <a:defRPr sz="2040"/>
             </a:lvl1pPr>
             <a:lvl2pPr>
-              <a:defRPr sz="2000"/>
+              <a:defRPr sz="1700"/>
             </a:lvl2pPr>
             <a:lvl3pPr>
-              <a:defRPr sz="1800"/>
+              <a:defRPr sz="1530"/>
             </a:lvl3pPr>
             <a:lvl4pPr>
-              <a:defRPr sz="1600"/>
+              <a:defRPr sz="1360"/>
             </a:lvl4pPr>
             <a:lvl5pPr>
-              <a:defRPr sz="1600"/>
+              <a:defRPr sz="1360"/>
             </a:lvl5pPr>
             <a:lvl6pPr>
-              <a:defRPr sz="1600"/>
+              <a:defRPr sz="1360"/>
             </a:lvl6pPr>
             <a:lvl7pPr>
-              <a:defRPr sz="1600"/>
+              <a:defRPr sz="1360"/>
             </a:lvl7pPr>
             <a:lvl8pPr>
-              <a:defRPr sz="1600"/>
+              <a:defRPr sz="1360"/>
             </a:lvl8pPr>
             <a:lvl9pPr>
-              <a:defRPr sz="1600"/>
+              <a:defRPr sz="1360"/>
             </a:lvl9pPr>
           </a:lstStyle>
           <a:p>
@@ -1438,7 +1438,7 @@
           <a:p>
             <a:fld id="{E6744CE3-0875-4B69-89C0-6F72D8139561}" type="datetimeFigureOut">
               <a:rPr lang="en-GB" smtClean="0"/>
-              <a:t>01/02/2026</a:t>
+              <a:t>05/05/2026</a:t>
             </a:fld>
             <a:endParaRPr lang="en-GB"/>
           </a:p>
@@ -1556,7 +1556,7 @@
           <a:p>
             <a:fld id="{E6744CE3-0875-4B69-89C0-6F72D8139561}" type="datetimeFigureOut">
               <a:rPr lang="en-GB" smtClean="0"/>
-              <a:t>01/02/2026</a:t>
+              <a:t>05/05/2026</a:t>
             </a:fld>
             <a:endParaRPr lang="en-GB"/>
           </a:p>
@@ -1651,7 +1651,7 @@
           <a:p>
             <a:fld id="{E6744CE3-0875-4B69-89C0-6F72D8139561}" type="datetimeFigureOut">
               <a:rPr lang="en-GB" smtClean="0"/>
-              <a:t>01/02/2026</a:t>
+              <a:t>05/05/2026</a:t>
             </a:fld>
             <a:endParaRPr lang="en-GB"/>
           </a:p>
@@ -1746,8 +1746,8 @@
         </p:nvSpPr>
         <p:spPr>
           <a:xfrm>
-            <a:off x="1028700" y="1098552"/>
-            <a:ext cx="18516600" cy="4572000"/>
+            <a:off x="777240" y="805605"/>
+            <a:ext cx="13990320" cy="3352800"/>
           </a:xfrm>
           <a:prstGeom prst="rect">
             <a:avLst/>
@@ -1779,8 +1779,8 @@
         </p:nvSpPr>
         <p:spPr>
           <a:xfrm>
-            <a:off x="1028700" y="6400802"/>
-            <a:ext cx="18516600" cy="18103852"/>
+            <a:off x="777240" y="4693922"/>
+            <a:ext cx="13990320" cy="13276159"/>
           </a:xfrm>
           <a:prstGeom prst="rect">
             <a:avLst/>
@@ -1841,8 +1841,8 @@
         </p:nvSpPr>
         <p:spPr>
           <a:xfrm>
-            <a:off x="1028700" y="25425402"/>
-            <a:ext cx="4800600" cy="1460500"/>
+            <a:off x="777240" y="18645295"/>
+            <a:ext cx="3627120" cy="1071033"/>
           </a:xfrm>
           <a:prstGeom prst="rect">
             <a:avLst/>
@@ -1852,7 +1852,7 @@
           <a:bodyPr vert="horz" lIns="91440" tIns="45720" rIns="91440" bIns="45720" rtlCol="0" anchor="ctr"/>
           <a:lstStyle>
             <a:lvl1pPr algn="l">
-              <a:defRPr sz="1200">
+              <a:defRPr sz="1020">
                 <a:solidFill>
                   <a:schemeClr val="tx1">
                     <a:tint val="75000"/>
@@ -1864,7 +1864,7 @@
           <a:p>
             <a:fld id="{E6744CE3-0875-4B69-89C0-6F72D8139561}" type="datetimeFigureOut">
               <a:rPr lang="en-GB" smtClean="0"/>
-              <a:t>01/02/2026</a:t>
+              <a:t>05/05/2026</a:t>
             </a:fld>
             <a:endParaRPr lang="en-GB"/>
           </a:p>
@@ -1882,8 +1882,8 @@
         </p:nvSpPr>
         <p:spPr>
           <a:xfrm>
-            <a:off x="7029450" y="25425402"/>
-            <a:ext cx="6515100" cy="1460500"/>
+            <a:off x="5311140" y="18645295"/>
+            <a:ext cx="4922520" cy="1071033"/>
           </a:xfrm>
           <a:prstGeom prst="rect">
             <a:avLst/>
@@ -1893,7 +1893,7 @@
           <a:bodyPr vert="horz" lIns="91440" tIns="45720" rIns="91440" bIns="45720" rtlCol="0" anchor="ctr"/>
           <a:lstStyle>
             <a:lvl1pPr algn="ctr">
-              <a:defRPr sz="1200">
+              <a:defRPr sz="1020">
                 <a:solidFill>
                   <a:schemeClr val="tx1">
                     <a:tint val="75000"/>
@@ -1919,8 +1919,8 @@
         </p:nvSpPr>
         <p:spPr>
           <a:xfrm>
-            <a:off x="14744700" y="25425402"/>
-            <a:ext cx="4800600" cy="1460500"/>
+            <a:off x="11140440" y="18645295"/>
+            <a:ext cx="3627120" cy="1071033"/>
           </a:xfrm>
           <a:prstGeom prst="rect">
             <a:avLst/>
@@ -1930,7 +1930,7 @@
           <a:bodyPr vert="horz" lIns="91440" tIns="45720" rIns="91440" bIns="45720" rtlCol="0" anchor="ctr"/>
           <a:lstStyle>
             <a:lvl1pPr algn="r">
-              <a:defRPr sz="1200">
+              <a:defRPr sz="1020">
                 <a:solidFill>
                   <a:schemeClr val="tx1">
                     <a:tint val="75000"/>
@@ -1967,12 +1967,12 @@
   </p:sldLayoutIdLst>
   <p:txStyles>
     <p:titleStyle>
-      <a:lvl1pPr algn="ctr" defTabSz="914400" rtl="0" eaLnBrk="1" latinLnBrk="0" hangingPunct="1">
+      <a:lvl1pPr algn="ctr" defTabSz="777240" rtl="0" eaLnBrk="1" latinLnBrk="0" hangingPunct="1">
         <a:spcBef>
           <a:spcPct val="0"/>
         </a:spcBef>
         <a:buNone/>
-        <a:defRPr sz="4400" kern="1200">
+        <a:defRPr sz="3740" kern="1200">
           <a:solidFill>
             <a:schemeClr val="tx1"/>
           </a:solidFill>
@@ -1983,13 +1983,13 @@
       </a:lvl1pPr>
     </p:titleStyle>
     <p:bodyStyle>
-      <a:lvl1pPr marL="342900" indent="-342900" algn="l" defTabSz="914400" rtl="0" eaLnBrk="1" latinLnBrk="0" hangingPunct="1">
+      <a:lvl1pPr marL="291465" indent="-291465" algn="l" defTabSz="777240" rtl="0" eaLnBrk="1" latinLnBrk="0" hangingPunct="1">
         <a:spcBef>
           <a:spcPct val="20000"/>
         </a:spcBef>
         <a:buFont typeface="Arial" panose="020B0604020202020204" pitchFamily="34" charset="0"/>
         <a:buChar char="•"/>
-        <a:defRPr sz="3200" kern="1200">
+        <a:defRPr sz="2720" kern="1200">
           <a:solidFill>
             <a:schemeClr val="tx1"/>
           </a:solidFill>
@@ -1998,13 +1998,13 @@
           <a:cs typeface="+mn-cs"/>
         </a:defRPr>
       </a:lvl1pPr>
-      <a:lvl2pPr marL="742950" indent="-285750" algn="l" defTabSz="914400" rtl="0" eaLnBrk="1" latinLnBrk="0" hangingPunct="1">
+      <a:lvl2pPr marL="631508" indent="-242888" algn="l" defTabSz="777240" rtl="0" eaLnBrk="1" latinLnBrk="0" hangingPunct="1">
         <a:spcBef>
           <a:spcPct val="20000"/>
         </a:spcBef>
         <a:buFont typeface="Arial" panose="020B0604020202020204" pitchFamily="34" charset="0"/>
         <a:buChar char="–"/>
-        <a:defRPr sz="2800" kern="1200">
+        <a:defRPr sz="2380" kern="1200">
           <a:solidFill>
             <a:schemeClr val="tx1"/>
           </a:solidFill>
@@ -2013,13 +2013,13 @@
           <a:cs typeface="+mn-cs"/>
         </a:defRPr>
       </a:lvl2pPr>
-      <a:lvl3pPr marL="1143000" indent="-228600" algn="l" defTabSz="914400" rtl="0" eaLnBrk="1" latinLnBrk="0" hangingPunct="1">
+      <a:lvl3pPr marL="971550" indent="-194310" algn="l" defTabSz="777240" rtl="0" eaLnBrk="1" latinLnBrk="0" hangingPunct="1">
         <a:spcBef>
           <a:spcPct val="20000"/>
         </a:spcBef>
         <a:buFont typeface="Arial" panose="020B0604020202020204" pitchFamily="34" charset="0"/>
         <a:buChar char="•"/>
-        <a:defRPr sz="2400" kern="1200">
+        <a:defRPr sz="2040" kern="1200">
           <a:solidFill>
             <a:schemeClr val="tx1"/>
           </a:solidFill>
@@ -2028,13 +2028,13 @@
           <a:cs typeface="+mn-cs"/>
         </a:defRPr>
       </a:lvl3pPr>
-      <a:lvl4pPr marL="1600200" indent="-228600" algn="l" defTabSz="914400" rtl="0" eaLnBrk="1" latinLnBrk="0" hangingPunct="1">
+      <a:lvl4pPr marL="1360170" indent="-194310" algn="l" defTabSz="777240" rtl="0" eaLnBrk="1" latinLnBrk="0" hangingPunct="1">
         <a:spcBef>
           <a:spcPct val="20000"/>
         </a:spcBef>
         <a:buFont typeface="Arial" panose="020B0604020202020204" pitchFamily="34" charset="0"/>
         <a:buChar char="–"/>
-        <a:defRPr sz="2000" kern="1200">
+        <a:defRPr sz="1700" kern="1200">
           <a:solidFill>
             <a:schemeClr val="tx1"/>
           </a:solidFill>
@@ -2043,13 +2043,13 @@
           <a:cs typeface="+mn-cs"/>
         </a:defRPr>
       </a:lvl4pPr>
-      <a:lvl5pPr marL="2057400" indent="-228600" algn="l" defTabSz="914400" rtl="0" eaLnBrk="1" latinLnBrk="0" hangingPunct="1">
+      <a:lvl5pPr marL="1748790" indent="-194310" algn="l" defTabSz="777240" rtl="0" eaLnBrk="1" latinLnBrk="0" hangingPunct="1">
         <a:spcBef>
           <a:spcPct val="20000"/>
         </a:spcBef>
         <a:buFont typeface="Arial" panose="020B0604020202020204" pitchFamily="34" charset="0"/>
         <a:buChar char="»"/>
-        <a:defRPr sz="2000" kern="1200">
+        <a:defRPr sz="1700" kern="1200">
           <a:solidFill>
             <a:schemeClr val="tx1"/>
           </a:solidFill>
@@ -2058,13 +2058,13 @@
           <a:cs typeface="+mn-cs"/>
         </a:defRPr>
       </a:lvl5pPr>
-      <a:lvl6pPr marL="2514600" indent="-228600" algn="l" defTabSz="914400" rtl="0" eaLnBrk="1" latinLnBrk="0" hangingPunct="1">
+      <a:lvl6pPr marL="2137410" indent="-194310" algn="l" defTabSz="777240" rtl="0" eaLnBrk="1" latinLnBrk="0" hangingPunct="1">
         <a:spcBef>
           <a:spcPct val="20000"/>
         </a:spcBef>
         <a:buFont typeface="Arial" panose="020B0604020202020204" pitchFamily="34" charset="0"/>
         <a:buChar char="•"/>
-        <a:defRPr sz="2000" kern="1200">
+        <a:defRPr sz="1700" kern="1200">
           <a:solidFill>
             <a:schemeClr val="tx1"/>
           </a:solidFill>
@@ -2073,13 +2073,13 @@
           <a:cs typeface="+mn-cs"/>
         </a:defRPr>
       </a:lvl6pPr>
-      <a:lvl7pPr marL="2971800" indent="-228600" algn="l" defTabSz="914400" rtl="0" eaLnBrk="1" latinLnBrk="0" hangingPunct="1">
+      <a:lvl7pPr marL="2526030" indent="-194310" algn="l" defTabSz="777240" rtl="0" eaLnBrk="1" latinLnBrk="0" hangingPunct="1">
         <a:spcBef>
           <a:spcPct val="20000"/>
         </a:spcBef>
         <a:buFont typeface="Arial" panose="020B0604020202020204" pitchFamily="34" charset="0"/>
         <a:buChar char="•"/>
-        <a:defRPr sz="2000" kern="1200">
+        <a:defRPr sz="1700" kern="1200">
           <a:solidFill>
             <a:schemeClr val="tx1"/>
           </a:solidFill>
@@ -2088,13 +2088,13 @@
           <a:cs typeface="+mn-cs"/>
         </a:defRPr>
       </a:lvl7pPr>
-      <a:lvl8pPr marL="3429000" indent="-228600" algn="l" defTabSz="914400" rtl="0" eaLnBrk="1" latinLnBrk="0" hangingPunct="1">
+      <a:lvl8pPr marL="2914650" indent="-194310" algn="l" defTabSz="777240" rtl="0" eaLnBrk="1" latinLnBrk="0" hangingPunct="1">
         <a:spcBef>
           <a:spcPct val="20000"/>
         </a:spcBef>
         <a:buFont typeface="Arial" panose="020B0604020202020204" pitchFamily="34" charset="0"/>
         <a:buChar char="•"/>
-        <a:defRPr sz="2000" kern="1200">
+        <a:defRPr sz="1700" kern="1200">
           <a:solidFill>
             <a:schemeClr val="tx1"/>
           </a:solidFill>
@@ -2103,13 +2103,13 @@
           <a:cs typeface="+mn-cs"/>
         </a:defRPr>
       </a:lvl8pPr>
-      <a:lvl9pPr marL="3886200" indent="-228600" algn="l" defTabSz="914400" rtl="0" eaLnBrk="1" latinLnBrk="0" hangingPunct="1">
+      <a:lvl9pPr marL="3303270" indent="-194310" algn="l" defTabSz="777240" rtl="0" eaLnBrk="1" latinLnBrk="0" hangingPunct="1">
         <a:spcBef>
           <a:spcPct val="20000"/>
         </a:spcBef>
         <a:buFont typeface="Arial" panose="020B0604020202020204" pitchFamily="34" charset="0"/>
         <a:buChar char="•"/>
-        <a:defRPr sz="2000" kern="1200">
+        <a:defRPr sz="1700" kern="1200">
           <a:solidFill>
             <a:schemeClr val="tx1"/>
           </a:solidFill>
@@ -2123,8 +2123,8 @@
       <a:defPPr>
         <a:defRPr lang="en-US"/>
       </a:defPPr>
-      <a:lvl1pPr marL="0" algn="l" defTabSz="914400" rtl="0" eaLnBrk="1" latinLnBrk="0" hangingPunct="1">
-        <a:defRPr sz="1800" kern="1200">
+      <a:lvl1pPr marL="0" algn="l" defTabSz="777240" rtl="0" eaLnBrk="1" latinLnBrk="0" hangingPunct="1">
+        <a:defRPr sz="1530" kern="1200">
           <a:solidFill>
             <a:schemeClr val="tx1"/>
           </a:solidFill>
@@ -2133,8 +2133,8 @@
           <a:cs typeface="+mn-cs"/>
         </a:defRPr>
       </a:lvl1pPr>
-      <a:lvl2pPr marL="457200" algn="l" defTabSz="914400" rtl="0" eaLnBrk="1" latinLnBrk="0" hangingPunct="1">
-        <a:defRPr sz="1800" kern="1200">
+      <a:lvl2pPr marL="388620" algn="l" defTabSz="777240" rtl="0" eaLnBrk="1" latinLnBrk="0" hangingPunct="1">
+        <a:defRPr sz="1530" kern="1200">
           <a:solidFill>
             <a:schemeClr val="tx1"/>
           </a:solidFill>
@@ -2143,8 +2143,8 @@
           <a:cs typeface="+mn-cs"/>
         </a:defRPr>
       </a:lvl2pPr>
-      <a:lvl3pPr marL="914400" algn="l" defTabSz="914400" rtl="0" eaLnBrk="1" latinLnBrk="0" hangingPunct="1">
-        <a:defRPr sz="1800" kern="1200">
+      <a:lvl3pPr marL="777240" algn="l" defTabSz="777240" rtl="0" eaLnBrk="1" latinLnBrk="0" hangingPunct="1">
+        <a:defRPr sz="1530" kern="1200">
           <a:solidFill>
             <a:schemeClr val="tx1"/>
           </a:solidFill>
@@ -2153,8 +2153,8 @@
           <a:cs typeface="+mn-cs"/>
         </a:defRPr>
       </a:lvl3pPr>
-      <a:lvl4pPr marL="1371600" algn="l" defTabSz="914400" rtl="0" eaLnBrk="1" latinLnBrk="0" hangingPunct="1">
-        <a:defRPr sz="1800" kern="1200">
+      <a:lvl4pPr marL="1165860" algn="l" defTabSz="777240" rtl="0" eaLnBrk="1" latinLnBrk="0" hangingPunct="1">
+        <a:defRPr sz="1530" kern="1200">
           <a:solidFill>
             <a:schemeClr val="tx1"/>
           </a:solidFill>
@@ -2163,8 +2163,8 @@
           <a:cs typeface="+mn-cs"/>
         </a:defRPr>
       </a:lvl4pPr>
-      <a:lvl5pPr marL="1828800" algn="l" defTabSz="914400" rtl="0" eaLnBrk="1" latinLnBrk="0" hangingPunct="1">
-        <a:defRPr sz="1800" kern="1200">
+      <a:lvl5pPr marL="1554480" algn="l" defTabSz="777240" rtl="0" eaLnBrk="1" latinLnBrk="0" hangingPunct="1">
+        <a:defRPr sz="1530" kern="1200">
           <a:solidFill>
             <a:schemeClr val="tx1"/>
           </a:solidFill>
@@ -2173,8 +2173,8 @@
           <a:cs typeface="+mn-cs"/>
         </a:defRPr>
       </a:lvl5pPr>
-      <a:lvl6pPr marL="2286000" algn="l" defTabSz="914400" rtl="0" eaLnBrk="1" latinLnBrk="0" hangingPunct="1">
-        <a:defRPr sz="1800" kern="1200">
+      <a:lvl6pPr marL="1943100" algn="l" defTabSz="777240" rtl="0" eaLnBrk="1" latinLnBrk="0" hangingPunct="1">
+        <a:defRPr sz="1530" kern="1200">
           <a:solidFill>
             <a:schemeClr val="tx1"/>
           </a:solidFill>
@@ -2183,8 +2183,8 @@
           <a:cs typeface="+mn-cs"/>
         </a:defRPr>
       </a:lvl6pPr>
-      <a:lvl7pPr marL="2743200" algn="l" defTabSz="914400" rtl="0" eaLnBrk="1" latinLnBrk="0" hangingPunct="1">
-        <a:defRPr sz="1800" kern="1200">
+      <a:lvl7pPr marL="2331720" algn="l" defTabSz="777240" rtl="0" eaLnBrk="1" latinLnBrk="0" hangingPunct="1">
+        <a:defRPr sz="1530" kern="1200">
           <a:solidFill>
             <a:schemeClr val="tx1"/>
           </a:solidFill>
@@ -2193,8 +2193,8 @@
           <a:cs typeface="+mn-cs"/>
         </a:defRPr>
       </a:lvl7pPr>
-      <a:lvl8pPr marL="3200400" algn="l" defTabSz="914400" rtl="0" eaLnBrk="1" latinLnBrk="0" hangingPunct="1">
-        <a:defRPr sz="1800" kern="1200">
+      <a:lvl8pPr marL="2720340" algn="l" defTabSz="777240" rtl="0" eaLnBrk="1" latinLnBrk="0" hangingPunct="1">
+        <a:defRPr sz="1530" kern="1200">
           <a:solidFill>
             <a:schemeClr val="tx1"/>
           </a:solidFill>
@@ -2203,8 +2203,8 @@
           <a:cs typeface="+mn-cs"/>
         </a:defRPr>
       </a:lvl8pPr>
-      <a:lvl9pPr marL="3657600" algn="l" defTabSz="914400" rtl="0" eaLnBrk="1" latinLnBrk="0" hangingPunct="1">
-        <a:defRPr sz="1800" kern="1200">
+      <a:lvl9pPr marL="3108960" algn="l" defTabSz="777240" rtl="0" eaLnBrk="1" latinLnBrk="0" hangingPunct="1">
+        <a:defRPr sz="1530" kern="1200">
           <a:solidFill>
             <a:schemeClr val="tx1"/>
           </a:solidFill>
@@ -2257,8 +2257,8 @@
         </p:blipFill>
         <p:spPr>
           <a:xfrm>
-            <a:off x="6400800" y="11184961"/>
-            <a:ext cx="7772400" cy="5062078"/>
+            <a:off x="4469130" y="7907017"/>
+            <a:ext cx="6606540" cy="4302766"/>
           </a:xfrm>
           <a:prstGeom prst="rect">
             <a:avLst/>
@@ -2312,8 +2312,8 @@
         </p:blipFill>
         <p:spPr>
           <a:xfrm>
-            <a:off x="6400800" y="11184961"/>
-            <a:ext cx="7772400" cy="5062078"/>
+            <a:off x="4469130" y="7907017"/>
+            <a:ext cx="6606540" cy="4302766"/>
           </a:xfrm>
           <a:prstGeom prst="rect">
             <a:avLst/>
@@ -2379,8 +2379,8 @@
         </p:blipFill>
         <p:spPr>
           <a:xfrm>
-            <a:off x="6425952" y="11098324"/>
-            <a:ext cx="6237312" cy="3816424"/>
+            <a:off x="4490509" y="7833376"/>
+            <a:ext cx="5301715" cy="3243960"/>
           </a:xfrm>
           <a:prstGeom prst="rect">
             <a:avLst/>
@@ -2410,8 +2410,8 @@
         </p:blipFill>
         <p:spPr>
           <a:xfrm>
-            <a:off x="6400800" y="6731224"/>
-            <a:ext cx="6262464" cy="3816424"/>
+            <a:off x="4469130" y="4121341"/>
+            <a:ext cx="5323094" cy="3243960"/>
           </a:xfrm>
           <a:prstGeom prst="rect">
             <a:avLst/>
@@ -2432,8 +2432,8 @@
         </p:nvSpPr>
         <p:spPr>
           <a:xfrm>
-            <a:off x="6902624" y="6479196"/>
-            <a:ext cx="5544616" cy="504056"/>
+            <a:off x="4895680" y="3907116"/>
+            <a:ext cx="4712924" cy="428448"/>
           </a:xfrm>
           <a:prstGeom prst="rect">
             <a:avLst/>
@@ -2467,11 +2467,11 @@
           <a:bodyPr rtlCol="0" anchor="ctr"/>
           <a:lstStyle/>
           <a:p>
-            <a:pPr marL="457200" indent="-457200">
+            <a:pPr marL="388620" indent="-388620">
               <a:buAutoNum type="alphaUcParenBoth"/>
             </a:pPr>
             <a:r>
-              <a:rPr lang="en-US" sz="2400" dirty="0">
+              <a:rPr lang="en-US" sz="2040" dirty="0">
                 <a:solidFill>
                   <a:schemeClr val="tx1"/>
                 </a:solidFill>
@@ -2481,7 +2481,7 @@
           </a:p>
           <a:p>
             <a:r>
-              <a:rPr lang="en-US" sz="2400" dirty="0">
+              <a:rPr lang="en-US" sz="2040" dirty="0">
                 <a:solidFill>
                   <a:schemeClr val="tx1"/>
                 </a:solidFill>
@@ -2505,8 +2505,8 @@
         </p:nvSpPr>
         <p:spPr>
           <a:xfrm>
-            <a:off x="6902624" y="10814956"/>
-            <a:ext cx="5544616" cy="504056"/>
+            <a:off x="4895680" y="7592512"/>
+            <a:ext cx="4712924" cy="428448"/>
           </a:xfrm>
           <a:prstGeom prst="rect">
             <a:avLst/>
@@ -2541,7 +2541,7 @@
           <a:lstStyle/>
           <a:p>
             <a:r>
-              <a:rPr lang="en-US" sz="2400" dirty="0">
+              <a:rPr lang="en-US" sz="2040" dirty="0">
                 <a:solidFill>
                   <a:schemeClr val="tx1"/>
                 </a:solidFill>
@@ -2551,7 +2551,7 @@
           </a:p>
           <a:p>
             <a:r>
-              <a:rPr lang="en-US" sz="2400" dirty="0">
+              <a:rPr lang="en-US" sz="2040" dirty="0">
                 <a:solidFill>
                   <a:schemeClr val="tx1"/>
                 </a:solidFill>
@@ -2575,8 +2575,8 @@
         </p:nvSpPr>
         <p:spPr>
           <a:xfrm rot="16200000">
-            <a:off x="5445106" y="8146479"/>
-            <a:ext cx="1911388" cy="504056"/>
+            <a:off x="3656790" y="5324307"/>
+            <a:ext cx="1624680" cy="428448"/>
           </a:xfrm>
           <a:prstGeom prst="rect">
             <a:avLst/>
@@ -2612,7 +2612,7 @@
           <a:p>
             <a:pPr algn="ctr"/>
             <a:r>
-              <a:rPr lang="en-US" sz="1800" dirty="0">
+              <a:rPr lang="en-US" sz="1530" dirty="0">
                 <a:solidFill>
                   <a:schemeClr val="tx1"/>
                 </a:solidFill>
@@ -2636,8 +2636,8 @@
         </p:nvSpPr>
         <p:spPr>
           <a:xfrm rot="16200000">
-            <a:off x="5702449" y="12765621"/>
-            <a:ext cx="1396702" cy="504056"/>
+            <a:off x="3875532" y="9250578"/>
+            <a:ext cx="1187197" cy="428448"/>
           </a:xfrm>
           <a:prstGeom prst="rect">
             <a:avLst/>
@@ -2673,7 +2673,7 @@
           <a:p>
             <a:pPr algn="ctr"/>
             <a:r>
-              <a:rPr lang="en-US" sz="1800" dirty="0">
+              <a:rPr lang="en-US" sz="1530" dirty="0">
                 <a:solidFill>
                   <a:schemeClr val="tx1"/>
                 </a:solidFill>
@@ -2697,8 +2697,8 @@
         </p:nvSpPr>
         <p:spPr>
           <a:xfrm>
-            <a:off x="8719238" y="10344820"/>
-            <a:ext cx="1911388" cy="220688"/>
+            <a:off x="6439802" y="7192897"/>
+            <a:ext cx="1624680" cy="187585"/>
           </a:xfrm>
           <a:prstGeom prst="rect">
             <a:avLst/>
@@ -2734,7 +2734,7 @@
           <a:p>
             <a:pPr algn="ctr"/>
             <a:r>
-              <a:rPr lang="en-US" sz="1800" dirty="0">
+              <a:rPr lang="en-US" sz="1530" dirty="0">
                 <a:solidFill>
                   <a:schemeClr val="tx1"/>
                 </a:solidFill>
@@ -2758,8 +2758,8 @@
         </p:nvSpPr>
         <p:spPr>
           <a:xfrm>
-            <a:off x="8719238" y="14694060"/>
-            <a:ext cx="1911388" cy="220688"/>
+            <a:off x="6439802" y="10889751"/>
+            <a:ext cx="1624680" cy="187585"/>
           </a:xfrm>
           <a:prstGeom prst="rect">
             <a:avLst/>
@@ -2795,7 +2795,7 @@
           <a:p>
             <a:pPr algn="ctr"/>
             <a:r>
-              <a:rPr lang="en-US" sz="1800" dirty="0">
+              <a:rPr lang="en-US" sz="1530" dirty="0">
                 <a:solidFill>
                   <a:schemeClr val="tx1"/>
                 </a:solidFill>
@@ -2819,8 +2819,8 @@
         </p:nvGrpSpPr>
         <p:grpSpPr>
           <a:xfrm>
-            <a:off x="12591256" y="7158608"/>
-            <a:ext cx="1911388" cy="940769"/>
+            <a:off x="9731018" y="4484620"/>
+            <a:ext cx="1624680" cy="799654"/>
             <a:chOff x="12591256" y="7158608"/>
             <a:chExt cx="1911388" cy="940769"/>
           </a:xfrm>
@@ -2906,7 +2906,7 @@
             <a:lstStyle/>
             <a:p>
               <a:r>
-                <a:rPr lang="en-US" sz="1800" dirty="0">
+                <a:rPr lang="en-US" sz="1530" dirty="0">
                   <a:solidFill>
                     <a:schemeClr val="tx1"/>
                   </a:solidFill>
@@ -2966,7 +2966,7 @@
             <a:lstStyle/>
             <a:p>
               <a:r>
-                <a:rPr lang="en-US" sz="1600" dirty="0">
+                <a:rPr lang="en-US" sz="1360" dirty="0">
                   <a:solidFill>
                     <a:schemeClr val="tx1"/>
                   </a:solidFill>
@@ -3026,7 +3026,7 @@
             <a:lstStyle/>
             <a:p>
               <a:r>
-                <a:rPr lang="en-US" sz="1600" dirty="0">
+                <a:rPr lang="en-US" sz="1360" dirty="0">
                   <a:solidFill>
                     <a:schemeClr val="tx1"/>
                   </a:solidFill>
@@ -3082,7 +3082,7 @@
             <a:lstStyle/>
             <a:p>
               <a:pPr algn="ctr"/>
-              <a:endParaRPr lang="en-US"/>
+              <a:endParaRPr lang="en-US" sz="3409"/>
             </a:p>
           </p:txBody>
         </p:sp>
@@ -3132,7 +3132,7 @@
             <a:lstStyle/>
             <a:p>
               <a:pPr algn="ctr"/>
-              <a:endParaRPr lang="en-US"/>
+              <a:endParaRPr lang="en-US" sz="3409"/>
             </a:p>
           </p:txBody>
         </p:sp>
@@ -3195,8 +3195,8 @@
         </p:blipFill>
         <p:spPr>
           <a:xfrm>
-            <a:off x="6400800" y="11184961"/>
-            <a:ext cx="7772400" cy="5062078"/>
+            <a:off x="4469130" y="7907017"/>
+            <a:ext cx="6606540" cy="4302766"/>
           </a:xfrm>
           <a:prstGeom prst="rect">
             <a:avLst/>
@@ -3255,8 +3255,8 @@
         </p:blipFill>
         <p:spPr>
           <a:xfrm>
-            <a:off x="6400800" y="11184961"/>
-            <a:ext cx="7772400" cy="5062078"/>
+            <a:off x="4469130" y="7907017"/>
+            <a:ext cx="6606540" cy="4302766"/>
           </a:xfrm>
           <a:prstGeom prst="rect">
             <a:avLst/>
@@ -3293,872 +3293,12 @@
           <a:chExt cx="0" cy="0"/>
         </a:xfrm>
       </p:grpSpPr>
-      <p:pic>
-        <p:nvPicPr>
-          <p:cNvPr id="23" name="Picture 22">
+      <p:grpSp>
+        <p:nvGrpSpPr>
+          <p:cNvPr id="2" name="Group 1">
             <a:extLst>
               <a:ext uri="{FF2B5EF4-FFF2-40B4-BE49-F238E27FC236}">
-                <a16:creationId xmlns:a16="http://schemas.microsoft.com/office/drawing/2014/main" id="{E7E53A25-1C40-1D92-23FC-2925B8E04BB0}"/>
-              </a:ext>
-            </a:extLst>
-          </p:cNvPr>
-          <p:cNvPicPr>
-            <a:picLocks noChangeAspect="1"/>
-          </p:cNvPicPr>
-          <p:nvPr/>
-        </p:nvPicPr>
-        <p:blipFill>
-          <a:blip r:embed="rId2"/>
-          <a:srcRect r="21251"/>
-          <a:stretch>
-            <a:fillRect/>
-          </a:stretch>
-        </p:blipFill>
-        <p:spPr>
-          <a:xfrm>
-            <a:off x="1833267" y="10475639"/>
-            <a:ext cx="6120680" cy="5062078"/>
-          </a:xfrm>
-          <a:prstGeom prst="rect">
-            <a:avLst/>
-          </a:prstGeom>
-        </p:spPr>
-      </p:pic>
-      <p:pic>
-        <p:nvPicPr>
-          <p:cNvPr id="5" name="Picture 4">
-            <a:extLst>
-              <a:ext uri="{FF2B5EF4-FFF2-40B4-BE49-F238E27FC236}">
-                <a16:creationId xmlns:a16="http://schemas.microsoft.com/office/drawing/2014/main" id="{1D3196B2-5E38-8770-253B-B3F65DE8AB38}"/>
-              </a:ext>
-            </a:extLst>
-          </p:cNvPr>
-          <p:cNvPicPr>
-            <a:picLocks noChangeAspect="1"/>
-          </p:cNvPicPr>
-          <p:nvPr/>
-        </p:nvPicPr>
-        <p:blipFill>
-          <a:blip r:embed="rId3"/>
-          <a:srcRect r="21251"/>
-          <a:stretch>
-            <a:fillRect/>
-          </a:stretch>
-        </p:blipFill>
-        <p:spPr>
-          <a:xfrm>
-            <a:off x="8486800" y="10475640"/>
-            <a:ext cx="6120680" cy="5062078"/>
-          </a:xfrm>
-          <a:prstGeom prst="rect">
-            <a:avLst/>
-          </a:prstGeom>
-        </p:spPr>
-      </p:pic>
-      <p:sp>
-        <p:nvSpPr>
-          <p:cNvPr id="6" name="Rectangle 5">
-            <a:extLst>
-              <a:ext uri="{FF2B5EF4-FFF2-40B4-BE49-F238E27FC236}">
-                <a16:creationId xmlns:a16="http://schemas.microsoft.com/office/drawing/2014/main" id="{517FE153-138F-5037-73AC-9A49FA9A3851}"/>
-              </a:ext>
-            </a:extLst>
-          </p:cNvPr>
-          <p:cNvSpPr/>
-          <p:nvPr/>
-        </p:nvSpPr>
-        <p:spPr>
-          <a:xfrm>
-            <a:off x="2366120" y="10223612"/>
-            <a:ext cx="5544616" cy="504056"/>
-          </a:xfrm>
-          <a:prstGeom prst="rect">
-            <a:avLst/>
-          </a:prstGeom>
-          <a:solidFill>
-            <a:schemeClr val="bg1"/>
-          </a:solidFill>
-          <a:ln>
-            <a:solidFill>
-              <a:schemeClr val="bg1"/>
-            </a:solidFill>
-          </a:ln>
-        </p:spPr>
-        <p:style>
-          <a:lnRef idx="2">
-            <a:schemeClr val="accent1">
-              <a:shade val="15000"/>
-            </a:schemeClr>
-          </a:lnRef>
-          <a:fillRef idx="1">
-            <a:schemeClr val="accent1"/>
-          </a:fillRef>
-          <a:effectRef idx="0">
-            <a:schemeClr val="accent1"/>
-          </a:effectRef>
-          <a:fontRef idx="minor">
-            <a:schemeClr val="lt1"/>
-          </a:fontRef>
-        </p:style>
-        <p:txBody>
-          <a:bodyPr rtlCol="0" anchor="ctr"/>
-          <a:lstStyle/>
-          <a:p>
-            <a:pPr marL="457200" indent="-457200">
-              <a:buAutoNum type="alphaUcParenBoth"/>
-            </a:pPr>
-            <a:r>
-              <a:rPr lang="en-US" sz="2400" dirty="0">
-                <a:solidFill>
-                  <a:schemeClr val="tx1"/>
-                </a:solidFill>
-              </a:rPr>
-              <a:t>MSX Prevalence in Common Gardens</a:t>
-            </a:r>
-          </a:p>
-          <a:p>
-            <a:r>
-              <a:rPr lang="en-US" sz="2400" dirty="0">
-                <a:solidFill>
-                  <a:schemeClr val="tx1"/>
-                </a:solidFill>
-              </a:rPr>
-              <a:t>       over Experimental Period</a:t>
-            </a:r>
-          </a:p>
-        </p:txBody>
-      </p:sp>
-      <p:sp>
-        <p:nvSpPr>
-          <p:cNvPr id="7" name="Rectangle 6">
-            <a:extLst>
-              <a:ext uri="{FF2B5EF4-FFF2-40B4-BE49-F238E27FC236}">
-                <a16:creationId xmlns:a16="http://schemas.microsoft.com/office/drawing/2014/main" id="{86FBDB0B-43F6-DF09-BD60-F2DD48B7EF2D}"/>
-              </a:ext>
-            </a:extLst>
-          </p:cNvPr>
-          <p:cNvSpPr/>
-          <p:nvPr/>
-        </p:nvSpPr>
-        <p:spPr>
-          <a:xfrm>
-            <a:off x="9062864" y="10223612"/>
-            <a:ext cx="5544616" cy="504056"/>
-          </a:xfrm>
-          <a:prstGeom prst="rect">
-            <a:avLst/>
-          </a:prstGeom>
-          <a:solidFill>
-            <a:schemeClr val="bg1"/>
-          </a:solidFill>
-          <a:ln>
-            <a:solidFill>
-              <a:schemeClr val="bg1"/>
-            </a:solidFill>
-          </a:ln>
-        </p:spPr>
-        <p:style>
-          <a:lnRef idx="2">
-            <a:schemeClr val="accent1">
-              <a:shade val="15000"/>
-            </a:schemeClr>
-          </a:lnRef>
-          <a:fillRef idx="1">
-            <a:schemeClr val="accent1"/>
-          </a:fillRef>
-          <a:effectRef idx="0">
-            <a:schemeClr val="accent1"/>
-          </a:effectRef>
-          <a:fontRef idx="minor">
-            <a:schemeClr val="lt1"/>
-          </a:fontRef>
-        </p:style>
-        <p:txBody>
-          <a:bodyPr rtlCol="0" anchor="ctr"/>
-          <a:lstStyle/>
-          <a:p>
-            <a:r>
-              <a:rPr lang="en-US" sz="2400" dirty="0">
-                <a:solidFill>
-                  <a:schemeClr val="tx1"/>
-                </a:solidFill>
-              </a:rPr>
-              <a:t>(B) Dermo Prevalence in Common Gardens</a:t>
-            </a:r>
-          </a:p>
-          <a:p>
-            <a:r>
-              <a:rPr lang="en-US" sz="2400" dirty="0">
-                <a:solidFill>
-                  <a:schemeClr val="tx1"/>
-                </a:solidFill>
-              </a:rPr>
-              <a:t>       over Experimental Period</a:t>
-            </a:r>
-          </a:p>
-        </p:txBody>
-      </p:sp>
-      <p:sp>
-        <p:nvSpPr>
-          <p:cNvPr id="8" name="Rectangle 7">
-            <a:extLst>
-              <a:ext uri="{FF2B5EF4-FFF2-40B4-BE49-F238E27FC236}">
-                <a16:creationId xmlns:a16="http://schemas.microsoft.com/office/drawing/2014/main" id="{848E700F-0EF8-5456-DDDD-C6AE43DDAA7B}"/>
-              </a:ext>
-            </a:extLst>
-          </p:cNvPr>
-          <p:cNvSpPr/>
-          <p:nvPr/>
-        </p:nvSpPr>
-        <p:spPr>
-          <a:xfrm rot="16200000">
-            <a:off x="1003453" y="12754651"/>
-            <a:ext cx="1861238" cy="504056"/>
-          </a:xfrm>
-          <a:prstGeom prst="rect">
-            <a:avLst/>
-          </a:prstGeom>
-          <a:solidFill>
-            <a:schemeClr val="bg1"/>
-          </a:solidFill>
-          <a:ln>
-            <a:solidFill>
-              <a:schemeClr val="bg1"/>
-            </a:solidFill>
-          </a:ln>
-        </p:spPr>
-        <p:style>
-          <a:lnRef idx="2">
-            <a:schemeClr val="accent1">
-              <a:shade val="15000"/>
-            </a:schemeClr>
-          </a:lnRef>
-          <a:fillRef idx="1">
-            <a:schemeClr val="accent1"/>
-          </a:fillRef>
-          <a:effectRef idx="0">
-            <a:schemeClr val="accent1"/>
-          </a:effectRef>
-          <a:fontRef idx="minor">
-            <a:schemeClr val="lt1"/>
-          </a:fontRef>
-        </p:style>
-        <p:txBody>
-          <a:bodyPr rtlCol="0" anchor="ctr"/>
-          <a:lstStyle/>
-          <a:p>
-            <a:pPr algn="ctr"/>
-            <a:r>
-              <a:rPr lang="en-US" sz="1800" dirty="0">
-                <a:solidFill>
-                  <a:schemeClr val="tx1"/>
-                </a:solidFill>
-              </a:rPr>
-              <a:t>MSX Prevalence</a:t>
-            </a:r>
-          </a:p>
-        </p:txBody>
-      </p:sp>
-      <p:sp>
-        <p:nvSpPr>
-          <p:cNvPr id="9" name="Rectangle 8">
-            <a:extLst>
-              <a:ext uri="{FF2B5EF4-FFF2-40B4-BE49-F238E27FC236}">
-                <a16:creationId xmlns:a16="http://schemas.microsoft.com/office/drawing/2014/main" id="{CBDCFE68-8327-CBBF-9940-8C3FF8FA4A83}"/>
-              </a:ext>
-            </a:extLst>
-          </p:cNvPr>
-          <p:cNvSpPr/>
-          <p:nvPr/>
-        </p:nvSpPr>
-        <p:spPr>
-          <a:xfrm rot="16200000">
-            <a:off x="7479981" y="12754651"/>
-            <a:ext cx="2013638" cy="504056"/>
-          </a:xfrm>
-          <a:prstGeom prst="rect">
-            <a:avLst/>
-          </a:prstGeom>
-          <a:solidFill>
-            <a:schemeClr val="bg1"/>
-          </a:solidFill>
-          <a:ln>
-            <a:solidFill>
-              <a:schemeClr val="bg1"/>
-            </a:solidFill>
-          </a:ln>
-        </p:spPr>
-        <p:style>
-          <a:lnRef idx="2">
-            <a:schemeClr val="accent1">
-              <a:shade val="15000"/>
-            </a:schemeClr>
-          </a:lnRef>
-          <a:fillRef idx="1">
-            <a:schemeClr val="accent1"/>
-          </a:fillRef>
-          <a:effectRef idx="0">
-            <a:schemeClr val="accent1"/>
-          </a:effectRef>
-          <a:fontRef idx="minor">
-            <a:schemeClr val="lt1"/>
-          </a:fontRef>
-        </p:style>
-        <p:txBody>
-          <a:bodyPr rtlCol="0" anchor="ctr"/>
-          <a:lstStyle/>
-          <a:p>
-            <a:pPr algn="ctr"/>
-            <a:r>
-              <a:rPr lang="en-US" sz="1800" dirty="0">
-                <a:solidFill>
-                  <a:schemeClr val="tx1"/>
-                </a:solidFill>
-              </a:rPr>
-              <a:t>Dermo Prevalence</a:t>
-            </a:r>
-          </a:p>
-        </p:txBody>
-      </p:sp>
-      <p:pic>
-        <p:nvPicPr>
-          <p:cNvPr id="11" name="Picture 10">
-            <a:extLst>
-              <a:ext uri="{FF2B5EF4-FFF2-40B4-BE49-F238E27FC236}">
-                <a16:creationId xmlns:a16="http://schemas.microsoft.com/office/drawing/2014/main" id="{7D53A8DB-AFFB-CE30-C4F8-FBF259979F9E}"/>
-              </a:ext>
-            </a:extLst>
-          </p:cNvPr>
-          <p:cNvPicPr>
-            <a:picLocks noChangeAspect="1"/>
-          </p:cNvPicPr>
-          <p:nvPr/>
-        </p:nvPicPr>
-        <p:blipFill>
-          <a:blip r:embed="rId4"/>
-          <a:srcRect l="80573" t="40042" b="41465"/>
-          <a:stretch>
-            <a:fillRect/>
-          </a:stretch>
-        </p:blipFill>
-        <p:spPr>
-          <a:xfrm>
-            <a:off x="14695575" y="11063755"/>
-            <a:ext cx="1509936" cy="936105"/>
-          </a:xfrm>
-          <a:prstGeom prst="rect">
-            <a:avLst/>
-          </a:prstGeom>
-        </p:spPr>
-      </p:pic>
-      <p:sp>
-        <p:nvSpPr>
-          <p:cNvPr id="12" name="Rectangle 11">
-            <a:extLst>
-              <a:ext uri="{FF2B5EF4-FFF2-40B4-BE49-F238E27FC236}">
-                <a16:creationId xmlns:a16="http://schemas.microsoft.com/office/drawing/2014/main" id="{13D705FC-818C-E749-F479-1B13F50D427C}"/>
-              </a:ext>
-            </a:extLst>
-          </p:cNvPr>
-          <p:cNvSpPr/>
-          <p:nvPr/>
-        </p:nvSpPr>
-        <p:spPr>
-          <a:xfrm>
-            <a:off x="14623567" y="10775020"/>
-            <a:ext cx="1911388" cy="504056"/>
-          </a:xfrm>
-          <a:prstGeom prst="rect">
-            <a:avLst/>
-          </a:prstGeom>
-          <a:solidFill>
-            <a:schemeClr val="bg1"/>
-          </a:solidFill>
-          <a:ln>
-            <a:solidFill>
-              <a:schemeClr val="bg1"/>
-            </a:solidFill>
-          </a:ln>
-        </p:spPr>
-        <p:style>
-          <a:lnRef idx="2">
-            <a:schemeClr val="accent1">
-              <a:shade val="15000"/>
-            </a:schemeClr>
-          </a:lnRef>
-          <a:fillRef idx="1">
-            <a:schemeClr val="accent1"/>
-          </a:fillRef>
-          <a:effectRef idx="0">
-            <a:schemeClr val="accent1"/>
-          </a:effectRef>
-          <a:fontRef idx="minor">
-            <a:schemeClr val="lt1"/>
-          </a:fontRef>
-        </p:style>
-        <p:txBody>
-          <a:bodyPr rtlCol="0" anchor="ctr"/>
-          <a:lstStyle/>
-          <a:p>
-            <a:r>
-              <a:rPr lang="en-US" sz="1800" dirty="0">
-                <a:solidFill>
-                  <a:schemeClr val="tx1"/>
-                </a:solidFill>
-              </a:rPr>
-              <a:t>Common Garden</a:t>
-            </a:r>
-          </a:p>
-        </p:txBody>
-      </p:sp>
-      <p:sp>
-        <p:nvSpPr>
-          <p:cNvPr id="13" name="Rectangle 12">
-            <a:extLst>
-              <a:ext uri="{FF2B5EF4-FFF2-40B4-BE49-F238E27FC236}">
-                <a16:creationId xmlns:a16="http://schemas.microsoft.com/office/drawing/2014/main" id="{80BB86C2-778A-5741-1BB6-E10469737AC5}"/>
-              </a:ext>
-            </a:extLst>
-          </p:cNvPr>
-          <p:cNvSpPr/>
-          <p:nvPr/>
-        </p:nvSpPr>
-        <p:spPr>
-          <a:xfrm>
-            <a:off x="15075532" y="11343296"/>
-            <a:ext cx="1188132" cy="220688"/>
-          </a:xfrm>
-          <a:prstGeom prst="rect">
-            <a:avLst/>
-          </a:prstGeom>
-          <a:solidFill>
-            <a:schemeClr val="bg1"/>
-          </a:solidFill>
-          <a:ln>
-            <a:solidFill>
-              <a:schemeClr val="bg1"/>
-            </a:solidFill>
-          </a:ln>
-        </p:spPr>
-        <p:style>
-          <a:lnRef idx="2">
-            <a:schemeClr val="accent1">
-              <a:shade val="15000"/>
-            </a:schemeClr>
-          </a:lnRef>
-          <a:fillRef idx="1">
-            <a:schemeClr val="accent1"/>
-          </a:fillRef>
-          <a:effectRef idx="0">
-            <a:schemeClr val="accent1"/>
-          </a:effectRef>
-          <a:fontRef idx="minor">
-            <a:schemeClr val="lt1"/>
-          </a:fontRef>
-        </p:style>
-        <p:txBody>
-          <a:bodyPr rtlCol="0" anchor="ctr"/>
-          <a:lstStyle/>
-          <a:p>
-            <a:r>
-              <a:rPr lang="en-US" sz="1600" dirty="0">
-                <a:solidFill>
-                  <a:schemeClr val="tx1"/>
-                </a:solidFill>
-              </a:rPr>
-              <a:t>Lewisetta</a:t>
-            </a:r>
-          </a:p>
-        </p:txBody>
-      </p:sp>
-      <p:sp>
-        <p:nvSpPr>
-          <p:cNvPr id="14" name="Rectangle 13">
-            <a:extLst>
-              <a:ext uri="{FF2B5EF4-FFF2-40B4-BE49-F238E27FC236}">
-                <a16:creationId xmlns:a16="http://schemas.microsoft.com/office/drawing/2014/main" id="{B24EF363-8867-5EA1-46FF-5D2FF7DB813D}"/>
-              </a:ext>
-            </a:extLst>
-          </p:cNvPr>
-          <p:cNvSpPr/>
-          <p:nvPr/>
-        </p:nvSpPr>
-        <p:spPr>
-          <a:xfrm>
-            <a:off x="15075532" y="11691120"/>
-            <a:ext cx="1188132" cy="220688"/>
-          </a:xfrm>
-          <a:prstGeom prst="rect">
-            <a:avLst/>
-          </a:prstGeom>
-          <a:solidFill>
-            <a:schemeClr val="bg1"/>
-          </a:solidFill>
-          <a:ln>
-            <a:solidFill>
-              <a:schemeClr val="bg1"/>
-            </a:solidFill>
-          </a:ln>
-        </p:spPr>
-        <p:style>
-          <a:lnRef idx="2">
-            <a:schemeClr val="accent1">
-              <a:shade val="15000"/>
-            </a:schemeClr>
-          </a:lnRef>
-          <a:fillRef idx="1">
-            <a:schemeClr val="accent1"/>
-          </a:fillRef>
-          <a:effectRef idx="0">
-            <a:schemeClr val="accent1"/>
-          </a:effectRef>
-          <a:fontRef idx="minor">
-            <a:schemeClr val="lt1"/>
-          </a:fontRef>
-        </p:style>
-        <p:txBody>
-          <a:bodyPr rtlCol="0" anchor="ctr"/>
-          <a:lstStyle/>
-          <a:p>
-            <a:r>
-              <a:rPr lang="en-US" sz="1600" dirty="0">
-                <a:solidFill>
-                  <a:schemeClr val="tx1"/>
-                </a:solidFill>
-              </a:rPr>
-              <a:t>York River</a:t>
-            </a:r>
-          </a:p>
-        </p:txBody>
-      </p:sp>
-      <p:sp>
-        <p:nvSpPr>
-          <p:cNvPr id="18" name="Rectangle 17">
-            <a:extLst>
-              <a:ext uri="{FF2B5EF4-FFF2-40B4-BE49-F238E27FC236}">
-                <a16:creationId xmlns:a16="http://schemas.microsoft.com/office/drawing/2014/main" id="{B96F4F35-B256-A04C-C1E9-8CD700735543}"/>
-              </a:ext>
-            </a:extLst>
-          </p:cNvPr>
-          <p:cNvSpPr/>
-          <p:nvPr/>
-        </p:nvSpPr>
-        <p:spPr>
-          <a:xfrm>
-            <a:off x="4063793" y="15285690"/>
-            <a:ext cx="1861238" cy="504056"/>
-          </a:xfrm>
-          <a:prstGeom prst="rect">
-            <a:avLst/>
-          </a:prstGeom>
-          <a:solidFill>
-            <a:schemeClr val="bg1"/>
-          </a:solidFill>
-          <a:ln>
-            <a:solidFill>
-              <a:schemeClr val="bg1"/>
-            </a:solidFill>
-          </a:ln>
-        </p:spPr>
-        <p:style>
-          <a:lnRef idx="2">
-            <a:schemeClr val="accent1">
-              <a:shade val="15000"/>
-            </a:schemeClr>
-          </a:lnRef>
-          <a:fillRef idx="1">
-            <a:schemeClr val="accent1"/>
-          </a:fillRef>
-          <a:effectRef idx="0">
-            <a:schemeClr val="accent1"/>
-          </a:effectRef>
-          <a:fontRef idx="minor">
-            <a:schemeClr val="lt1"/>
-          </a:fontRef>
-        </p:style>
-        <p:txBody>
-          <a:bodyPr rtlCol="0" anchor="ctr"/>
-          <a:lstStyle/>
-          <a:p>
-            <a:pPr algn="ctr"/>
-            <a:r>
-              <a:rPr lang="en-US" sz="1800" dirty="0">
-                <a:solidFill>
-                  <a:schemeClr val="tx1"/>
-                </a:solidFill>
-              </a:rPr>
-              <a:t>Date</a:t>
-            </a:r>
-          </a:p>
-        </p:txBody>
-      </p:sp>
-      <p:sp>
-        <p:nvSpPr>
-          <p:cNvPr id="19" name="Rectangle 18">
-            <a:extLst>
-              <a:ext uri="{FF2B5EF4-FFF2-40B4-BE49-F238E27FC236}">
-                <a16:creationId xmlns:a16="http://schemas.microsoft.com/office/drawing/2014/main" id="{E950C191-6378-8F50-B5C2-16554B72D4E0}"/>
-              </a:ext>
-            </a:extLst>
-          </p:cNvPr>
-          <p:cNvSpPr/>
-          <p:nvPr/>
-        </p:nvSpPr>
-        <p:spPr>
-          <a:xfrm>
-            <a:off x="10724533" y="15285690"/>
-            <a:ext cx="1861238" cy="504056"/>
-          </a:xfrm>
-          <a:prstGeom prst="rect">
-            <a:avLst/>
-          </a:prstGeom>
-          <a:solidFill>
-            <a:schemeClr val="bg1"/>
-          </a:solidFill>
-          <a:ln>
-            <a:solidFill>
-              <a:schemeClr val="bg1"/>
-            </a:solidFill>
-          </a:ln>
-        </p:spPr>
-        <p:style>
-          <a:lnRef idx="2">
-            <a:schemeClr val="accent1">
-              <a:shade val="15000"/>
-            </a:schemeClr>
-          </a:lnRef>
-          <a:fillRef idx="1">
-            <a:schemeClr val="accent1"/>
-          </a:fillRef>
-          <a:effectRef idx="0">
-            <a:schemeClr val="accent1"/>
-          </a:effectRef>
-          <a:fontRef idx="minor">
-            <a:schemeClr val="lt1"/>
-          </a:fontRef>
-        </p:style>
-        <p:txBody>
-          <a:bodyPr rtlCol="0" anchor="ctr"/>
-          <a:lstStyle/>
-          <a:p>
-            <a:pPr algn="ctr"/>
-            <a:r>
-              <a:rPr lang="en-US" sz="1800" dirty="0">
-                <a:solidFill>
-                  <a:schemeClr val="tx1"/>
-                </a:solidFill>
-              </a:rPr>
-              <a:t>Date</a:t>
-            </a:r>
-          </a:p>
-        </p:txBody>
-      </p:sp>
-      <p:sp>
-        <p:nvSpPr>
-          <p:cNvPr id="16" name="Rectangle 15">
-            <a:extLst>
-              <a:ext uri="{FF2B5EF4-FFF2-40B4-BE49-F238E27FC236}">
-                <a16:creationId xmlns:a16="http://schemas.microsoft.com/office/drawing/2014/main" id="{F9413902-5562-5AA6-653F-D154E7BBE925}"/>
-              </a:ext>
-            </a:extLst>
-          </p:cNvPr>
-          <p:cNvSpPr/>
-          <p:nvPr/>
-        </p:nvSpPr>
-        <p:spPr>
-          <a:xfrm>
-            <a:off x="14752285" y="11628440"/>
-            <a:ext cx="180020" cy="173024"/>
-          </a:xfrm>
-          <a:prstGeom prst="rect">
-            <a:avLst/>
-          </a:prstGeom>
-          <a:solidFill>
-            <a:srgbClr val="1A79FF"/>
-          </a:solidFill>
-          <a:ln w="12700"/>
-        </p:spPr>
-        <p:style>
-          <a:lnRef idx="2">
-            <a:schemeClr val="accent1">
-              <a:shade val="15000"/>
-            </a:schemeClr>
-          </a:lnRef>
-          <a:fillRef idx="1">
-            <a:schemeClr val="accent1"/>
-          </a:fillRef>
-          <a:effectRef idx="0">
-            <a:schemeClr val="accent1"/>
-          </a:effectRef>
-          <a:fontRef idx="minor">
-            <a:schemeClr val="lt1"/>
-          </a:fontRef>
-        </p:style>
-        <p:txBody>
-          <a:bodyPr rtlCol="0" anchor="ctr"/>
-          <a:lstStyle/>
-          <a:p>
-            <a:pPr algn="ctr"/>
-            <a:endParaRPr lang="en-US"/>
-          </a:p>
-        </p:txBody>
-      </p:sp>
-      <p:sp>
-        <p:nvSpPr>
-          <p:cNvPr id="15" name="Rectangle 14">
-            <a:extLst>
-              <a:ext uri="{FF2B5EF4-FFF2-40B4-BE49-F238E27FC236}">
-                <a16:creationId xmlns:a16="http://schemas.microsoft.com/office/drawing/2014/main" id="{F51DCC6A-F960-7A05-075E-0F4DC1EC042C}"/>
-              </a:ext>
-            </a:extLst>
-          </p:cNvPr>
-          <p:cNvSpPr/>
-          <p:nvPr/>
-        </p:nvSpPr>
-        <p:spPr>
-          <a:xfrm>
-            <a:off x="14752285" y="11367128"/>
-            <a:ext cx="180020" cy="173024"/>
-          </a:xfrm>
-          <a:prstGeom prst="rect">
-            <a:avLst/>
-          </a:prstGeom>
-          <a:solidFill>
-            <a:srgbClr val="17FF7E"/>
-          </a:solidFill>
-          <a:ln w="12700"/>
-        </p:spPr>
-        <p:style>
-          <a:lnRef idx="2">
-            <a:schemeClr val="accent1">
-              <a:shade val="15000"/>
-            </a:schemeClr>
-          </a:lnRef>
-          <a:fillRef idx="1">
-            <a:schemeClr val="accent1"/>
-          </a:fillRef>
-          <a:effectRef idx="0">
-            <a:schemeClr val="accent1"/>
-          </a:effectRef>
-          <a:fontRef idx="minor">
-            <a:schemeClr val="lt1"/>
-          </a:fontRef>
-        </p:style>
-        <p:txBody>
-          <a:bodyPr rtlCol="0" anchor="ctr"/>
-          <a:lstStyle/>
-          <a:p>
-            <a:pPr algn="ctr"/>
-            <a:endParaRPr lang="en-US"/>
-          </a:p>
-        </p:txBody>
-      </p:sp>
-      <p:sp>
-        <p:nvSpPr>
-          <p:cNvPr id="30" name="Rectangle 29">
-            <a:extLst>
-              <a:ext uri="{FF2B5EF4-FFF2-40B4-BE49-F238E27FC236}">
-                <a16:creationId xmlns:a16="http://schemas.microsoft.com/office/drawing/2014/main" id="{1FB5CC8C-473E-A0DF-E263-34499A30C267}"/>
-              </a:ext>
-            </a:extLst>
-          </p:cNvPr>
-          <p:cNvSpPr/>
-          <p:nvPr/>
-        </p:nvSpPr>
-        <p:spPr>
-          <a:xfrm>
-            <a:off x="14679488" y="11276331"/>
-            <a:ext cx="338328" cy="334418"/>
-          </a:xfrm>
-          <a:prstGeom prst="rect">
-            <a:avLst/>
-          </a:prstGeom>
-          <a:solidFill>
-            <a:srgbClr val="17FF7E"/>
-          </a:solidFill>
-          <a:ln w="12700"/>
-        </p:spPr>
-        <p:style>
-          <a:lnRef idx="2">
-            <a:schemeClr val="accent1">
-              <a:shade val="15000"/>
-            </a:schemeClr>
-          </a:lnRef>
-          <a:fillRef idx="1">
-            <a:schemeClr val="accent1"/>
-          </a:fillRef>
-          <a:effectRef idx="0">
-            <a:schemeClr val="accent1"/>
-          </a:effectRef>
-          <a:fontRef idx="minor">
-            <a:schemeClr val="lt1"/>
-          </a:fontRef>
-        </p:style>
-        <p:txBody>
-          <a:bodyPr rtlCol="0" anchor="ctr"/>
-          <a:lstStyle/>
-          <a:p>
-            <a:pPr algn="ctr"/>
-            <a:endParaRPr lang="en-US"/>
-          </a:p>
-        </p:txBody>
-      </p:sp>
-      <p:sp>
-        <p:nvSpPr>
-          <p:cNvPr id="31" name="Rectangle 30">
-            <a:extLst>
-              <a:ext uri="{FF2B5EF4-FFF2-40B4-BE49-F238E27FC236}">
-                <a16:creationId xmlns:a16="http://schemas.microsoft.com/office/drawing/2014/main" id="{1BD2B97F-10BD-A100-9EDE-FB0184035C5A}"/>
-              </a:ext>
-            </a:extLst>
-          </p:cNvPr>
-          <p:cNvSpPr/>
-          <p:nvPr/>
-        </p:nvSpPr>
-        <p:spPr>
-          <a:xfrm>
-            <a:off x="14679488" y="11624037"/>
-            <a:ext cx="338328" cy="334418"/>
-          </a:xfrm>
-          <a:prstGeom prst="rect">
-            <a:avLst/>
-          </a:prstGeom>
-          <a:solidFill>
-            <a:srgbClr val="1A79FF"/>
-          </a:solidFill>
-          <a:ln w="12700"/>
-        </p:spPr>
-        <p:style>
-          <a:lnRef idx="2">
-            <a:schemeClr val="accent1">
-              <a:shade val="15000"/>
-            </a:schemeClr>
-          </a:lnRef>
-          <a:fillRef idx="1">
-            <a:schemeClr val="accent1"/>
-          </a:fillRef>
-          <a:effectRef idx="0">
-            <a:schemeClr val="accent1"/>
-          </a:effectRef>
-          <a:fontRef idx="minor">
-            <a:schemeClr val="lt1"/>
-          </a:fontRef>
-        </p:style>
-        <p:txBody>
-          <a:bodyPr rtlCol="0" anchor="ctr"/>
-          <a:lstStyle/>
-          <a:p>
-            <a:pPr algn="ctr"/>
-            <a:endParaRPr lang="en-US"/>
-          </a:p>
-        </p:txBody>
-      </p:sp>
-      <p:grpSp>
-        <p:nvGrpSpPr>
-          <p:cNvPr id="35" name="Group 34">
-            <a:extLst>
-              <a:ext uri="{FF2B5EF4-FFF2-40B4-BE49-F238E27FC236}">
-                <a16:creationId xmlns:a16="http://schemas.microsoft.com/office/drawing/2014/main" id="{3B685F93-01E0-04D8-399E-5745C28B6CF6}"/>
+                <a16:creationId xmlns:a16="http://schemas.microsoft.com/office/drawing/2014/main" id="{75422F85-B3B6-F013-4BE5-355D6F7A4061}"/>
               </a:ext>
             </a:extLst>
           </p:cNvPr>
@@ -4167,65 +3307,80 @@
         </p:nvGrpSpPr>
         <p:grpSpPr>
           <a:xfrm>
-            <a:off x="1248943" y="15625067"/>
-            <a:ext cx="15059220" cy="10188277"/>
-            <a:chOff x="1248943" y="15625067"/>
-            <a:chExt cx="15059220" cy="10995706"/>
+            <a:off x="1275844" y="3793704"/>
+            <a:ext cx="12993111" cy="13251275"/>
+            <a:chOff x="1583492" y="3784704"/>
+            <a:chExt cx="12993111" cy="13251275"/>
           </a:xfrm>
         </p:grpSpPr>
         <p:pic>
           <p:nvPicPr>
-            <p:cNvPr id="3076" name="Picture 4">
+            <p:cNvPr id="23" name="Picture 22">
               <a:extLst>
                 <a:ext uri="{FF2B5EF4-FFF2-40B4-BE49-F238E27FC236}">
-                  <a16:creationId xmlns:a16="http://schemas.microsoft.com/office/drawing/2014/main" id="{F6D93FDB-3310-08E6-8320-61ACF7510E4F}"/>
+                  <a16:creationId xmlns:a16="http://schemas.microsoft.com/office/drawing/2014/main" id="{E7E53A25-1C40-1D92-23FC-2925B8E04BB0}"/>
                 </a:ext>
               </a:extLst>
             </p:cNvPr>
             <p:cNvPicPr>
-              <a:picLocks noChangeAspect="1" noChangeArrowheads="1"/>
+              <a:picLocks noChangeAspect="1"/>
             </p:cNvPicPr>
             <p:nvPr/>
           </p:nvPicPr>
-          <p:blipFill rotWithShape="1">
-            <a:blip r:embed="rId5">
-              <a:extLst>
-                <a:ext uri="{28A0092B-C50C-407E-A947-70E740481C1C}">
-                  <a14:useLocalDpi xmlns:a14="http://schemas.microsoft.com/office/drawing/2010/main" val="0"/>
-                </a:ext>
-              </a:extLst>
-            </a:blip>
-            <a:srcRect r="16490"/>
+          <p:blipFill>
+            <a:blip r:embed="rId2"/>
+            <a:srcRect r="21251"/>
             <a:stretch>
               <a:fillRect/>
             </a:stretch>
           </p:blipFill>
-          <p:spPr bwMode="auto">
+          <p:spPr>
             <a:xfrm>
-              <a:off x="1248943" y="15625067"/>
-              <a:ext cx="11846368" cy="10743678"/>
+              <a:off x="2080168" y="3998927"/>
+              <a:ext cx="5202578" cy="4302766"/>
             </a:xfrm>
             <a:prstGeom prst="rect">
               <a:avLst/>
             </a:prstGeom>
-            <a:noFill/>
-            <a:extLst>
-              <a:ext uri="{909E8E84-426E-40DD-AFC4-6F175D3DCCD1}">
-                <a14:hiddenFill xmlns:a14="http://schemas.microsoft.com/office/drawing/2010/main">
-                  <a:solidFill>
-                    <a:srgbClr val="FFFFFF"/>
-                  </a:solidFill>
-                </a14:hiddenFill>
-              </a:ext>
-            </a:extLst>
+          </p:spPr>
+        </p:pic>
+        <p:pic>
+          <p:nvPicPr>
+            <p:cNvPr id="5" name="Picture 4">
+              <a:extLst>
+                <a:ext uri="{FF2B5EF4-FFF2-40B4-BE49-F238E27FC236}">
+                  <a16:creationId xmlns:a16="http://schemas.microsoft.com/office/drawing/2014/main" id="{1D3196B2-5E38-8770-253B-B3F65DE8AB38}"/>
+                </a:ext>
+              </a:extLst>
+            </p:cNvPr>
+            <p:cNvPicPr>
+              <a:picLocks noChangeAspect="1"/>
+            </p:cNvPicPr>
+            <p:nvPr/>
+          </p:nvPicPr>
+          <p:blipFill>
+            <a:blip r:embed="rId3"/>
+            <a:srcRect r="21251"/>
+            <a:stretch>
+              <a:fillRect/>
+            </a:stretch>
+          </p:blipFill>
+          <p:spPr>
+            <a:xfrm>
+              <a:off x="7735671" y="3998928"/>
+              <a:ext cx="5202578" cy="4302766"/>
+            </a:xfrm>
+            <a:prstGeom prst="rect">
+              <a:avLst/>
+            </a:prstGeom>
           </p:spPr>
         </p:pic>
         <p:sp>
           <p:nvSpPr>
-            <p:cNvPr id="20" name="Rectangle 19">
+            <p:cNvPr id="6" name="Rectangle 5">
               <a:extLst>
                 <a:ext uri="{FF2B5EF4-FFF2-40B4-BE49-F238E27FC236}">
-                  <a16:creationId xmlns:a16="http://schemas.microsoft.com/office/drawing/2014/main" id="{973C567E-A26E-786B-C29F-605FE95B1F4A}"/>
+                  <a16:creationId xmlns:a16="http://schemas.microsoft.com/office/drawing/2014/main" id="{517FE153-138F-5037-73AC-9A49FA9A3851}"/>
                 </a:ext>
               </a:extLst>
             </p:cNvPr>
@@ -4234,8 +3389,81 @@
           </p:nvSpPr>
           <p:spPr>
             <a:xfrm>
-              <a:off x="2517049" y="15789746"/>
-              <a:ext cx="12235236" cy="504056"/>
+              <a:off x="2533092" y="3784704"/>
+              <a:ext cx="4712924" cy="428448"/>
+            </a:xfrm>
+            <a:prstGeom prst="rect">
+              <a:avLst/>
+            </a:prstGeom>
+            <a:solidFill>
+              <a:schemeClr val="bg1"/>
+            </a:solidFill>
+            <a:ln>
+              <a:solidFill>
+                <a:schemeClr val="bg1"/>
+              </a:solidFill>
+            </a:ln>
+          </p:spPr>
+          <p:style>
+            <a:lnRef idx="2">
+              <a:schemeClr val="accent1">
+                <a:shade val="15000"/>
+              </a:schemeClr>
+            </a:lnRef>
+            <a:fillRef idx="1">
+              <a:schemeClr val="accent1"/>
+            </a:fillRef>
+            <a:effectRef idx="0">
+              <a:schemeClr val="accent1"/>
+            </a:effectRef>
+            <a:fontRef idx="minor">
+              <a:schemeClr val="lt1"/>
+            </a:fontRef>
+          </p:style>
+          <p:txBody>
+            <a:bodyPr rtlCol="0" anchor="ctr"/>
+            <a:lstStyle/>
+            <a:p>
+              <a:pPr marL="388620" indent="-388620">
+                <a:buAutoNum type="alphaUcParenBoth"/>
+              </a:pPr>
+              <a:r>
+                <a:rPr lang="en-US" sz="2040" dirty="0">
+                  <a:solidFill>
+                    <a:schemeClr val="tx1"/>
+                  </a:solidFill>
+                </a:rPr>
+                <a:t>MSX Prevalence in Common Gardens</a:t>
+              </a:r>
+            </a:p>
+            <a:p>
+              <a:r>
+                <a:rPr lang="en-US" sz="2040" dirty="0">
+                  <a:solidFill>
+                    <a:schemeClr val="tx1"/>
+                  </a:solidFill>
+                </a:rPr>
+                <a:t>       over Experimental Period</a:t>
+              </a:r>
+            </a:p>
+          </p:txBody>
+        </p:sp>
+        <p:sp>
+          <p:nvSpPr>
+            <p:cNvPr id="7" name="Rectangle 6">
+              <a:extLst>
+                <a:ext uri="{FF2B5EF4-FFF2-40B4-BE49-F238E27FC236}">
+                  <a16:creationId xmlns:a16="http://schemas.microsoft.com/office/drawing/2014/main" id="{86FBDB0B-43F6-DF09-BD60-F2DD48B7EF2D}"/>
+                </a:ext>
+              </a:extLst>
+            </p:cNvPr>
+            <p:cNvSpPr/>
+            <p:nvPr/>
+          </p:nvSpPr>
+          <p:spPr>
+            <a:xfrm>
+              <a:off x="8225325" y="3784704"/>
+              <a:ext cx="4712924" cy="428448"/>
             </a:xfrm>
             <a:prstGeom prst="rect">
               <a:avLst/>
@@ -4270,22 +3498,32 @@
             <a:lstStyle/>
             <a:p>
               <a:r>
-                <a:rPr lang="en-US" sz="2400" dirty="0">
+                <a:rPr lang="en-US" sz="2040" dirty="0">
                   <a:solidFill>
                     <a:schemeClr val="tx1"/>
                   </a:solidFill>
                 </a:rPr>
-                <a:t>(C) Median Disease Pressure By Common Garden Site</a:t>
+                <a:t>(B) Dermo Prevalence in Common Gardens</a:t>
+              </a:r>
+            </a:p>
+            <a:p>
+              <a:r>
+                <a:rPr lang="en-US" sz="2040" dirty="0">
+                  <a:solidFill>
+                    <a:schemeClr val="tx1"/>
+                  </a:solidFill>
+                </a:rPr>
+                <a:t>       over Experimental Period</a:t>
               </a:r>
             </a:p>
           </p:txBody>
         </p:sp>
         <p:sp>
           <p:nvSpPr>
-            <p:cNvPr id="24" name="Rectangle 23">
+            <p:cNvPr id="8" name="Rectangle 7">
               <a:extLst>
                 <a:ext uri="{FF2B5EF4-FFF2-40B4-BE49-F238E27FC236}">
-                  <a16:creationId xmlns:a16="http://schemas.microsoft.com/office/drawing/2014/main" id="{F0420000-4144-D14F-B365-BFC7642A389E}"/>
+                  <a16:creationId xmlns:a16="http://schemas.microsoft.com/office/drawing/2014/main" id="{848E700F-0EF8-5456-DDDD-C6AE43DDAA7B}"/>
                 </a:ext>
               </a:extLst>
             </p:cNvPr>
@@ -4294,8 +3532,8 @@
           </p:nvSpPr>
           <p:spPr>
             <a:xfrm rot="16200000">
-              <a:off x="-1184948" y="20744878"/>
-              <a:ext cx="5371839" cy="504056"/>
+              <a:off x="1374826" y="5936087"/>
+              <a:ext cx="1582052" cy="428448"/>
             </a:xfrm>
             <a:prstGeom prst="rect">
               <a:avLst/>
@@ -4331,69 +3569,22 @@
             <a:p>
               <a:pPr algn="ctr"/>
               <a:r>
-                <a:rPr lang="en-US" sz="1800" dirty="0">
+                <a:rPr lang="en-US" sz="1530" dirty="0">
                   <a:solidFill>
                     <a:schemeClr val="tx1"/>
                   </a:solidFill>
                 </a:rPr>
-                <a:t>Disease Prevalence</a:t>
+                <a:t>MSX Prevalence</a:t>
               </a:r>
             </a:p>
           </p:txBody>
         </p:sp>
-        <p:pic>
-          <p:nvPicPr>
-            <p:cNvPr id="25" name="Picture 4">
+        <p:sp>
+          <p:nvSpPr>
+            <p:cNvPr id="9" name="Rectangle 8">
               <a:extLst>
                 <a:ext uri="{FF2B5EF4-FFF2-40B4-BE49-F238E27FC236}">
-                  <a16:creationId xmlns:a16="http://schemas.microsoft.com/office/drawing/2014/main" id="{A85BCA85-A8CA-E9D2-74A9-9404749B3BC5}"/>
-                </a:ext>
-              </a:extLst>
-            </p:cNvPr>
-            <p:cNvPicPr>
-              <a:picLocks noChangeAspect="1" noChangeArrowheads="1"/>
-            </p:cNvPicPr>
-            <p:nvPr/>
-          </p:nvPicPr>
-          <p:blipFill rotWithShape="1">
-            <a:blip r:embed="rId5">
-              <a:extLst>
-                <a:ext uri="{28A0092B-C50C-407E-A947-70E740481C1C}">
-                  <a14:useLocalDpi xmlns:a14="http://schemas.microsoft.com/office/drawing/2010/main" val="0"/>
-                </a:ext>
-              </a:extLst>
-            </a:blip>
-            <a:srcRect l="82436" t="38214" b="39430"/>
-            <a:stretch>
-              <a:fillRect/>
-            </a:stretch>
-          </p:blipFill>
-          <p:spPr bwMode="auto">
-            <a:xfrm>
-              <a:off x="14695575" y="16426681"/>
-              <a:ext cx="1612588" cy="1554559"/>
-            </a:xfrm>
-            <a:prstGeom prst="rect">
-              <a:avLst/>
-            </a:prstGeom>
-            <a:noFill/>
-            <a:extLst>
-              <a:ext uri="{909E8E84-426E-40DD-AFC4-6F175D3DCCD1}">
-                <a14:hiddenFill xmlns:a14="http://schemas.microsoft.com/office/drawing/2010/main">
-                  <a:solidFill>
-                    <a:srgbClr val="FFFFFF"/>
-                  </a:solidFill>
-                </a14:hiddenFill>
-              </a:ext>
-            </a:extLst>
-          </p:spPr>
-        </p:pic>
-        <p:sp>
-          <p:nvSpPr>
-            <p:cNvPr id="26" name="Rectangle 25">
-              <a:extLst>
-                <a:ext uri="{FF2B5EF4-FFF2-40B4-BE49-F238E27FC236}">
-                  <a16:creationId xmlns:a16="http://schemas.microsoft.com/office/drawing/2014/main" id="{8A70AE1D-8B2A-765F-39A6-3F3BD09D5C55}"/>
+                  <a16:creationId xmlns:a16="http://schemas.microsoft.com/office/drawing/2014/main" id="{CBDCFE68-8327-CBBF-9940-8C3FF8FA4A83}"/>
                 </a:ext>
               </a:extLst>
             </p:cNvPr>
@@ -4401,159 +3592,9 @@
             <p:nvPr/>
           </p:nvSpPr>
           <p:spPr>
-            <a:xfrm>
-              <a:off x="14877288" y="16797528"/>
-              <a:ext cx="338328" cy="334418"/>
-            </a:xfrm>
-            <a:prstGeom prst="rect">
-              <a:avLst/>
-            </a:prstGeom>
-            <a:solidFill>
-              <a:srgbClr val="FA2F39"/>
-            </a:solidFill>
-            <a:ln w="12700"/>
-          </p:spPr>
-          <p:style>
-            <a:lnRef idx="2">
-              <a:schemeClr val="accent1">
-                <a:shade val="15000"/>
-              </a:schemeClr>
-            </a:lnRef>
-            <a:fillRef idx="1">
-              <a:schemeClr val="accent1"/>
-            </a:fillRef>
-            <a:effectRef idx="0">
-              <a:schemeClr val="accent1"/>
-            </a:effectRef>
-            <a:fontRef idx="minor">
-              <a:schemeClr val="lt1"/>
-            </a:fontRef>
-          </p:style>
-          <p:txBody>
-            <a:bodyPr rtlCol="0" anchor="ctr"/>
-            <a:lstStyle/>
-            <a:p>
-              <a:pPr algn="ctr"/>
-              <a:endParaRPr lang="en-US"/>
-            </a:p>
-          </p:txBody>
-        </p:sp>
-        <p:sp>
-          <p:nvSpPr>
-            <p:cNvPr id="27" name="Rectangle 26">
-              <a:extLst>
-                <a:ext uri="{FF2B5EF4-FFF2-40B4-BE49-F238E27FC236}">
-                  <a16:creationId xmlns:a16="http://schemas.microsoft.com/office/drawing/2014/main" id="{3C3BB425-0EBF-10DA-3D83-CF4F390350BF}"/>
-                </a:ext>
-              </a:extLst>
-            </p:cNvPr>
-            <p:cNvSpPr/>
-            <p:nvPr/>
-          </p:nvSpPr>
-          <p:spPr>
-            <a:xfrm>
-              <a:off x="14877288" y="17145234"/>
-              <a:ext cx="338328" cy="334418"/>
-            </a:xfrm>
-            <a:prstGeom prst="rect">
-              <a:avLst/>
-            </a:prstGeom>
-            <a:solidFill>
-              <a:srgbClr val="FED154"/>
-            </a:solidFill>
-            <a:ln w="12700"/>
-          </p:spPr>
-          <p:style>
-            <a:lnRef idx="2">
-              <a:schemeClr val="accent1">
-                <a:shade val="15000"/>
-              </a:schemeClr>
-            </a:lnRef>
-            <a:fillRef idx="1">
-              <a:schemeClr val="accent1"/>
-            </a:fillRef>
-            <a:effectRef idx="0">
-              <a:schemeClr val="accent1"/>
-            </a:effectRef>
-            <a:fontRef idx="minor">
-              <a:schemeClr val="lt1"/>
-            </a:fontRef>
-          </p:style>
-          <p:txBody>
-            <a:bodyPr rtlCol="0" anchor="ctr"/>
-            <a:lstStyle/>
-            <a:p>
-              <a:pPr algn="ctr"/>
-              <a:endParaRPr lang="en-US"/>
-            </a:p>
-          </p:txBody>
-        </p:sp>
-        <p:sp>
-          <p:nvSpPr>
-            <p:cNvPr id="28" name="Rectangle 27">
-              <a:extLst>
-                <a:ext uri="{FF2B5EF4-FFF2-40B4-BE49-F238E27FC236}">
-                  <a16:creationId xmlns:a16="http://schemas.microsoft.com/office/drawing/2014/main" id="{BBBDF8AB-D751-4B6D-C3FA-7C4D3D2527B3}"/>
-                </a:ext>
-              </a:extLst>
-            </p:cNvPr>
-            <p:cNvSpPr/>
-            <p:nvPr/>
-          </p:nvSpPr>
-          <p:spPr>
-            <a:xfrm>
-              <a:off x="14877288" y="17492940"/>
-              <a:ext cx="338328" cy="334418"/>
-            </a:xfrm>
-            <a:prstGeom prst="rect">
-              <a:avLst/>
-            </a:prstGeom>
-            <a:solidFill>
-              <a:srgbClr val="118EA8"/>
-            </a:solidFill>
-            <a:ln w="12700"/>
-          </p:spPr>
-          <p:style>
-            <a:lnRef idx="2">
-              <a:schemeClr val="accent1">
-                <a:shade val="15000"/>
-              </a:schemeClr>
-            </a:lnRef>
-            <a:fillRef idx="1">
-              <a:schemeClr val="accent1"/>
-            </a:fillRef>
-            <a:effectRef idx="0">
-              <a:schemeClr val="accent1"/>
-            </a:effectRef>
-            <a:fontRef idx="minor">
-              <a:schemeClr val="lt1"/>
-            </a:fontRef>
-          </p:style>
-          <p:txBody>
-            <a:bodyPr rtlCol="0" anchor="ctr"/>
-            <a:lstStyle/>
-            <a:p>
-              <a:pPr algn="ctr"/>
-              <a:endParaRPr lang="en-US"/>
-            </a:p>
-          </p:txBody>
-        </p:sp>
-        <p:sp>
-          <p:nvSpPr>
-            <p:cNvPr id="32" name="Rectangle 31">
-              <a:extLst>
-                <a:ext uri="{FF2B5EF4-FFF2-40B4-BE49-F238E27FC236}">
-                  <a16:creationId xmlns:a16="http://schemas.microsoft.com/office/drawing/2014/main" id="{795802A6-DCAC-04B2-21F4-8BE8E372DD2B}"/>
-                </a:ext>
-              </a:extLst>
-            </p:cNvPr>
-            <p:cNvSpPr/>
-            <p:nvPr/>
-          </p:nvSpPr>
-          <p:spPr>
-            <a:xfrm>
-              <a:off x="4993843" y="25813344"/>
-              <a:ext cx="5371839" cy="807429"/>
+            <a:xfrm rot="16200000">
+              <a:off x="6879875" y="5936087"/>
+              <a:ext cx="1711592" cy="428448"/>
             </a:xfrm>
             <a:prstGeom prst="rect">
               <a:avLst/>
@@ -4589,22 +3630,53 @@
             <a:p>
               <a:pPr algn="ctr"/>
               <a:r>
-                <a:rPr lang="en-US" sz="1800" dirty="0">
+                <a:rPr lang="en-US" sz="1530" dirty="0">
                   <a:solidFill>
                     <a:schemeClr val="tx1"/>
                   </a:solidFill>
                 </a:rPr>
-                <a:t>Common Garden Site</a:t>
+                <a:t>Dermo Prevalence</a:t>
               </a:r>
             </a:p>
           </p:txBody>
         </p:sp>
+        <p:pic>
+          <p:nvPicPr>
+            <p:cNvPr id="11" name="Picture 10">
+              <a:extLst>
+                <a:ext uri="{FF2B5EF4-FFF2-40B4-BE49-F238E27FC236}">
+                  <a16:creationId xmlns:a16="http://schemas.microsoft.com/office/drawing/2014/main" id="{7D53A8DB-AFFB-CE30-C4F8-FBF259979F9E}"/>
+                </a:ext>
+              </a:extLst>
+            </p:cNvPr>
+            <p:cNvPicPr>
+              <a:picLocks noChangeAspect="1"/>
+            </p:cNvPicPr>
+            <p:nvPr/>
+          </p:nvPicPr>
+          <p:blipFill>
+            <a:blip r:embed="rId4"/>
+            <a:srcRect l="80573" t="40042" b="41465"/>
+            <a:stretch>
+              <a:fillRect/>
+            </a:stretch>
+          </p:blipFill>
+          <p:spPr>
+            <a:xfrm>
+              <a:off x="13013129" y="4498829"/>
+              <a:ext cx="1283446" cy="795689"/>
+            </a:xfrm>
+            <a:prstGeom prst="rect">
+              <a:avLst/>
+            </a:prstGeom>
+          </p:spPr>
+        </p:pic>
         <p:sp>
           <p:nvSpPr>
-            <p:cNvPr id="33" name="Rectangle 32">
+            <p:cNvPr id="12" name="Rectangle 11">
               <a:extLst>
                 <a:ext uri="{FF2B5EF4-FFF2-40B4-BE49-F238E27FC236}">
-                  <a16:creationId xmlns:a16="http://schemas.microsoft.com/office/drawing/2014/main" id="{FD622416-87C8-F692-028A-58BAFC9CB925}"/>
+                  <a16:creationId xmlns:a16="http://schemas.microsoft.com/office/drawing/2014/main" id="{13D705FC-818C-E749-F479-1B13F50D427C}"/>
                 </a:ext>
               </a:extLst>
             </p:cNvPr>
@@ -4613,8 +3685,188 @@
           </p:nvSpPr>
           <p:spPr>
             <a:xfrm>
-              <a:off x="2538897" y="25525312"/>
-              <a:ext cx="5371839" cy="403715"/>
+              <a:off x="12951923" y="4253400"/>
+              <a:ext cx="1624680" cy="428448"/>
+            </a:xfrm>
+            <a:prstGeom prst="rect">
+              <a:avLst/>
+            </a:prstGeom>
+            <a:solidFill>
+              <a:schemeClr val="bg1"/>
+            </a:solidFill>
+            <a:ln>
+              <a:solidFill>
+                <a:schemeClr val="bg1"/>
+              </a:solidFill>
+            </a:ln>
+          </p:spPr>
+          <p:style>
+            <a:lnRef idx="2">
+              <a:schemeClr val="accent1">
+                <a:shade val="15000"/>
+              </a:schemeClr>
+            </a:lnRef>
+            <a:fillRef idx="1">
+              <a:schemeClr val="accent1"/>
+            </a:fillRef>
+            <a:effectRef idx="0">
+              <a:schemeClr val="accent1"/>
+            </a:effectRef>
+            <a:fontRef idx="minor">
+              <a:schemeClr val="lt1"/>
+            </a:fontRef>
+          </p:style>
+          <p:txBody>
+            <a:bodyPr rtlCol="0" anchor="ctr"/>
+            <a:lstStyle/>
+            <a:p>
+              <a:r>
+                <a:rPr lang="en-US" sz="1530" dirty="0">
+                  <a:solidFill>
+                    <a:schemeClr val="tx1"/>
+                  </a:solidFill>
+                </a:rPr>
+                <a:t>Common Garden</a:t>
+              </a:r>
+            </a:p>
+          </p:txBody>
+        </p:sp>
+        <p:sp>
+          <p:nvSpPr>
+            <p:cNvPr id="13" name="Rectangle 12">
+              <a:extLst>
+                <a:ext uri="{FF2B5EF4-FFF2-40B4-BE49-F238E27FC236}">
+                  <a16:creationId xmlns:a16="http://schemas.microsoft.com/office/drawing/2014/main" id="{80BB86C2-778A-5741-1BB6-E10469737AC5}"/>
+                </a:ext>
+              </a:extLst>
+            </p:cNvPr>
+            <p:cNvSpPr/>
+            <p:nvPr/>
+          </p:nvSpPr>
+          <p:spPr>
+            <a:xfrm>
+              <a:off x="13336093" y="4736435"/>
+              <a:ext cx="1009912" cy="187585"/>
+            </a:xfrm>
+            <a:prstGeom prst="rect">
+              <a:avLst/>
+            </a:prstGeom>
+            <a:solidFill>
+              <a:schemeClr val="bg1"/>
+            </a:solidFill>
+            <a:ln>
+              <a:solidFill>
+                <a:schemeClr val="bg1"/>
+              </a:solidFill>
+            </a:ln>
+          </p:spPr>
+          <p:style>
+            <a:lnRef idx="2">
+              <a:schemeClr val="accent1">
+                <a:shade val="15000"/>
+              </a:schemeClr>
+            </a:lnRef>
+            <a:fillRef idx="1">
+              <a:schemeClr val="accent1"/>
+            </a:fillRef>
+            <a:effectRef idx="0">
+              <a:schemeClr val="accent1"/>
+            </a:effectRef>
+            <a:fontRef idx="minor">
+              <a:schemeClr val="lt1"/>
+            </a:fontRef>
+          </p:style>
+          <p:txBody>
+            <a:bodyPr rtlCol="0" anchor="ctr"/>
+            <a:lstStyle/>
+            <a:p>
+              <a:r>
+                <a:rPr lang="en-US" sz="1360" dirty="0">
+                  <a:solidFill>
+                    <a:schemeClr val="tx1"/>
+                  </a:solidFill>
+                </a:rPr>
+                <a:t>Lewisetta</a:t>
+              </a:r>
+            </a:p>
+          </p:txBody>
+        </p:sp>
+        <p:sp>
+          <p:nvSpPr>
+            <p:cNvPr id="14" name="Rectangle 13">
+              <a:extLst>
+                <a:ext uri="{FF2B5EF4-FFF2-40B4-BE49-F238E27FC236}">
+                  <a16:creationId xmlns:a16="http://schemas.microsoft.com/office/drawing/2014/main" id="{B24EF363-8867-5EA1-46FF-5D2FF7DB813D}"/>
+                </a:ext>
+              </a:extLst>
+            </p:cNvPr>
+            <p:cNvSpPr/>
+            <p:nvPr/>
+          </p:nvSpPr>
+          <p:spPr>
+            <a:xfrm>
+              <a:off x="13336093" y="5032086"/>
+              <a:ext cx="1009912" cy="187585"/>
+            </a:xfrm>
+            <a:prstGeom prst="rect">
+              <a:avLst/>
+            </a:prstGeom>
+            <a:solidFill>
+              <a:schemeClr val="bg1"/>
+            </a:solidFill>
+            <a:ln>
+              <a:solidFill>
+                <a:schemeClr val="bg1"/>
+              </a:solidFill>
+            </a:ln>
+          </p:spPr>
+          <p:style>
+            <a:lnRef idx="2">
+              <a:schemeClr val="accent1">
+                <a:shade val="15000"/>
+              </a:schemeClr>
+            </a:lnRef>
+            <a:fillRef idx="1">
+              <a:schemeClr val="accent1"/>
+            </a:fillRef>
+            <a:effectRef idx="0">
+              <a:schemeClr val="accent1"/>
+            </a:effectRef>
+            <a:fontRef idx="minor">
+              <a:schemeClr val="lt1"/>
+            </a:fontRef>
+          </p:style>
+          <p:txBody>
+            <a:bodyPr rtlCol="0" anchor="ctr"/>
+            <a:lstStyle/>
+            <a:p>
+              <a:r>
+                <a:rPr lang="en-US" sz="1360" dirty="0">
+                  <a:solidFill>
+                    <a:schemeClr val="tx1"/>
+                  </a:solidFill>
+                </a:rPr>
+                <a:t>York River</a:t>
+              </a:r>
+            </a:p>
+          </p:txBody>
+        </p:sp>
+        <p:sp>
+          <p:nvSpPr>
+            <p:cNvPr id="18" name="Rectangle 17">
+              <a:extLst>
+                <a:ext uri="{FF2B5EF4-FFF2-40B4-BE49-F238E27FC236}">
+                  <a16:creationId xmlns:a16="http://schemas.microsoft.com/office/drawing/2014/main" id="{B96F4F35-B256-A04C-C1E9-8CD700735543}"/>
+                </a:ext>
+              </a:extLst>
+            </p:cNvPr>
+            <p:cNvSpPr/>
+            <p:nvPr/>
+          </p:nvSpPr>
+          <p:spPr>
+            <a:xfrm>
+              <a:off x="3976115" y="8087470"/>
+              <a:ext cx="1582052" cy="428448"/>
             </a:xfrm>
             <a:prstGeom prst="rect">
               <a:avLst/>
@@ -4650,22 +3902,22 @@
             <a:p>
               <a:pPr algn="ctr"/>
               <a:r>
-                <a:rPr lang="en-US" sz="1800" dirty="0">
+                <a:rPr lang="en-US" sz="1530" dirty="0">
                   <a:solidFill>
                     <a:schemeClr val="tx1"/>
                   </a:solidFill>
                 </a:rPr>
-                <a:t>Lewisetta</a:t>
+                <a:t>Date</a:t>
               </a:r>
             </a:p>
           </p:txBody>
         </p:sp>
         <p:sp>
           <p:nvSpPr>
-            <p:cNvPr id="34" name="Rectangle 33">
+            <p:cNvPr id="19" name="Rectangle 18">
               <a:extLst>
                 <a:ext uri="{FF2B5EF4-FFF2-40B4-BE49-F238E27FC236}">
-                  <a16:creationId xmlns:a16="http://schemas.microsoft.com/office/drawing/2014/main" id="{8B4077A6-CB69-03EA-3956-F08D2681C364}"/>
+                  <a16:creationId xmlns:a16="http://schemas.microsoft.com/office/drawing/2014/main" id="{E950C191-6378-8F50-B5C2-16554B72D4E0}"/>
                 </a:ext>
               </a:extLst>
             </p:cNvPr>
@@ -4674,8 +3926,8 @@
           </p:nvSpPr>
           <p:spPr>
             <a:xfrm>
-              <a:off x="7177990" y="25543313"/>
-              <a:ext cx="5371839" cy="403715"/>
+              <a:off x="9637744" y="8087470"/>
+              <a:ext cx="1582052" cy="428448"/>
             </a:xfrm>
             <a:prstGeom prst="rect">
               <a:avLst/>
@@ -4711,16 +3963,785 @@
             <a:p>
               <a:pPr algn="ctr"/>
               <a:r>
-                <a:rPr lang="en-US" sz="1800" dirty="0">
+                <a:rPr lang="en-US" sz="1530" dirty="0">
                   <a:solidFill>
                     <a:schemeClr val="tx1"/>
                   </a:solidFill>
                 </a:rPr>
-                <a:t>York River</a:t>
+                <a:t>Date</a:t>
               </a:r>
             </a:p>
           </p:txBody>
         </p:sp>
+        <p:sp>
+          <p:nvSpPr>
+            <p:cNvPr id="16" name="Rectangle 15">
+              <a:extLst>
+                <a:ext uri="{FF2B5EF4-FFF2-40B4-BE49-F238E27FC236}">
+                  <a16:creationId xmlns:a16="http://schemas.microsoft.com/office/drawing/2014/main" id="{F9413902-5562-5AA6-653F-D154E7BBE925}"/>
+                </a:ext>
+              </a:extLst>
+            </p:cNvPr>
+            <p:cNvSpPr/>
+            <p:nvPr/>
+          </p:nvSpPr>
+          <p:spPr>
+            <a:xfrm>
+              <a:off x="13061333" y="4978808"/>
+              <a:ext cx="153017" cy="147070"/>
+            </a:xfrm>
+            <a:prstGeom prst="rect">
+              <a:avLst/>
+            </a:prstGeom>
+            <a:solidFill>
+              <a:srgbClr val="1A79FF"/>
+            </a:solidFill>
+            <a:ln w="12700"/>
+          </p:spPr>
+          <p:style>
+            <a:lnRef idx="2">
+              <a:schemeClr val="accent1">
+                <a:shade val="15000"/>
+              </a:schemeClr>
+            </a:lnRef>
+            <a:fillRef idx="1">
+              <a:schemeClr val="accent1"/>
+            </a:fillRef>
+            <a:effectRef idx="0">
+              <a:schemeClr val="accent1"/>
+            </a:effectRef>
+            <a:fontRef idx="minor">
+              <a:schemeClr val="lt1"/>
+            </a:fontRef>
+          </p:style>
+          <p:txBody>
+            <a:bodyPr rtlCol="0" anchor="ctr"/>
+            <a:lstStyle/>
+            <a:p>
+              <a:pPr algn="ctr"/>
+              <a:endParaRPr lang="en-US" sz="3409"/>
+            </a:p>
+          </p:txBody>
+        </p:sp>
+        <p:sp>
+          <p:nvSpPr>
+            <p:cNvPr id="15" name="Rectangle 14">
+              <a:extLst>
+                <a:ext uri="{FF2B5EF4-FFF2-40B4-BE49-F238E27FC236}">
+                  <a16:creationId xmlns:a16="http://schemas.microsoft.com/office/drawing/2014/main" id="{F51DCC6A-F960-7A05-075E-0F4DC1EC042C}"/>
+                </a:ext>
+              </a:extLst>
+            </p:cNvPr>
+            <p:cNvSpPr/>
+            <p:nvPr/>
+          </p:nvSpPr>
+          <p:spPr>
+            <a:xfrm>
+              <a:off x="13061333" y="4756693"/>
+              <a:ext cx="153017" cy="147070"/>
+            </a:xfrm>
+            <a:prstGeom prst="rect">
+              <a:avLst/>
+            </a:prstGeom>
+            <a:solidFill>
+              <a:srgbClr val="17FF7E"/>
+            </a:solidFill>
+            <a:ln w="12700"/>
+          </p:spPr>
+          <p:style>
+            <a:lnRef idx="2">
+              <a:schemeClr val="accent1">
+                <a:shade val="15000"/>
+              </a:schemeClr>
+            </a:lnRef>
+            <a:fillRef idx="1">
+              <a:schemeClr val="accent1"/>
+            </a:fillRef>
+            <a:effectRef idx="0">
+              <a:schemeClr val="accent1"/>
+            </a:effectRef>
+            <a:fontRef idx="minor">
+              <a:schemeClr val="lt1"/>
+            </a:fontRef>
+          </p:style>
+          <p:txBody>
+            <a:bodyPr rtlCol="0" anchor="ctr"/>
+            <a:lstStyle/>
+            <a:p>
+              <a:pPr algn="ctr"/>
+              <a:endParaRPr lang="en-US" sz="3409"/>
+            </a:p>
+          </p:txBody>
+        </p:sp>
+        <p:sp>
+          <p:nvSpPr>
+            <p:cNvPr id="30" name="Rectangle 29">
+              <a:extLst>
+                <a:ext uri="{FF2B5EF4-FFF2-40B4-BE49-F238E27FC236}">
+                  <a16:creationId xmlns:a16="http://schemas.microsoft.com/office/drawing/2014/main" id="{1FB5CC8C-473E-A0DF-E263-34499A30C267}"/>
+                </a:ext>
+              </a:extLst>
+            </p:cNvPr>
+            <p:cNvSpPr/>
+            <p:nvPr/>
+          </p:nvSpPr>
+          <p:spPr>
+            <a:xfrm>
+              <a:off x="12999455" y="4679515"/>
+              <a:ext cx="287579" cy="284255"/>
+            </a:xfrm>
+            <a:prstGeom prst="rect">
+              <a:avLst/>
+            </a:prstGeom>
+            <a:solidFill>
+              <a:srgbClr val="17FF7E"/>
+            </a:solidFill>
+            <a:ln w="12700"/>
+          </p:spPr>
+          <p:style>
+            <a:lnRef idx="2">
+              <a:schemeClr val="accent1">
+                <a:shade val="15000"/>
+              </a:schemeClr>
+            </a:lnRef>
+            <a:fillRef idx="1">
+              <a:schemeClr val="accent1"/>
+            </a:fillRef>
+            <a:effectRef idx="0">
+              <a:schemeClr val="accent1"/>
+            </a:effectRef>
+            <a:fontRef idx="minor">
+              <a:schemeClr val="lt1"/>
+            </a:fontRef>
+          </p:style>
+          <p:txBody>
+            <a:bodyPr rtlCol="0" anchor="ctr"/>
+            <a:lstStyle/>
+            <a:p>
+              <a:pPr algn="ctr"/>
+              <a:endParaRPr lang="en-US" sz="3409"/>
+            </a:p>
+          </p:txBody>
+        </p:sp>
+        <p:sp>
+          <p:nvSpPr>
+            <p:cNvPr id="31" name="Rectangle 30">
+              <a:extLst>
+                <a:ext uri="{FF2B5EF4-FFF2-40B4-BE49-F238E27FC236}">
+                  <a16:creationId xmlns:a16="http://schemas.microsoft.com/office/drawing/2014/main" id="{1BD2B97F-10BD-A100-9EDE-FB0184035C5A}"/>
+                </a:ext>
+              </a:extLst>
+            </p:cNvPr>
+            <p:cNvSpPr/>
+            <p:nvPr/>
+          </p:nvSpPr>
+          <p:spPr>
+            <a:xfrm>
+              <a:off x="12999455" y="4975065"/>
+              <a:ext cx="287579" cy="284255"/>
+            </a:xfrm>
+            <a:prstGeom prst="rect">
+              <a:avLst/>
+            </a:prstGeom>
+            <a:solidFill>
+              <a:srgbClr val="1A79FF"/>
+            </a:solidFill>
+            <a:ln w="12700"/>
+          </p:spPr>
+          <p:style>
+            <a:lnRef idx="2">
+              <a:schemeClr val="accent1">
+                <a:shade val="15000"/>
+              </a:schemeClr>
+            </a:lnRef>
+            <a:fillRef idx="1">
+              <a:schemeClr val="accent1"/>
+            </a:fillRef>
+            <a:effectRef idx="0">
+              <a:schemeClr val="accent1"/>
+            </a:effectRef>
+            <a:fontRef idx="minor">
+              <a:schemeClr val="lt1"/>
+            </a:fontRef>
+          </p:style>
+          <p:txBody>
+            <a:bodyPr rtlCol="0" anchor="ctr"/>
+            <a:lstStyle/>
+            <a:p>
+              <a:pPr algn="ctr"/>
+              <a:endParaRPr lang="en-US" sz="3409"/>
+            </a:p>
+          </p:txBody>
+        </p:sp>
+        <p:grpSp>
+          <p:nvGrpSpPr>
+            <p:cNvPr id="35" name="Group 34">
+              <a:extLst>
+                <a:ext uri="{FF2B5EF4-FFF2-40B4-BE49-F238E27FC236}">
+                  <a16:creationId xmlns:a16="http://schemas.microsoft.com/office/drawing/2014/main" id="{3B685F93-01E0-04D8-399E-5745C28B6CF6}"/>
+                </a:ext>
+              </a:extLst>
+            </p:cNvPr>
+            <p:cNvGrpSpPr/>
+            <p:nvPr/>
+          </p:nvGrpSpPr>
+          <p:grpSpPr>
+            <a:xfrm>
+              <a:off x="1583492" y="8375944"/>
+              <a:ext cx="12800337" cy="8660035"/>
+              <a:chOff x="1248943" y="15625067"/>
+              <a:chExt cx="15059220" cy="10995706"/>
+            </a:xfrm>
+          </p:grpSpPr>
+          <p:pic>
+            <p:nvPicPr>
+              <p:cNvPr id="3076" name="Picture 4">
+                <a:extLst>
+                  <a:ext uri="{FF2B5EF4-FFF2-40B4-BE49-F238E27FC236}">
+                    <a16:creationId xmlns:a16="http://schemas.microsoft.com/office/drawing/2014/main" id="{F6D93FDB-3310-08E6-8320-61ACF7510E4F}"/>
+                  </a:ext>
+                </a:extLst>
+              </p:cNvPr>
+              <p:cNvPicPr>
+                <a:picLocks noChangeAspect="1" noChangeArrowheads="1"/>
+              </p:cNvPicPr>
+              <p:nvPr/>
+            </p:nvPicPr>
+            <p:blipFill rotWithShape="1">
+              <a:blip r:embed="rId5">
+                <a:extLst>
+                  <a:ext uri="{28A0092B-C50C-407E-A947-70E740481C1C}">
+                    <a14:useLocalDpi xmlns:a14="http://schemas.microsoft.com/office/drawing/2010/main" val="0"/>
+                  </a:ext>
+                </a:extLst>
+              </a:blip>
+              <a:srcRect r="16490"/>
+              <a:stretch>
+                <a:fillRect/>
+              </a:stretch>
+            </p:blipFill>
+            <p:spPr bwMode="auto">
+              <a:xfrm>
+                <a:off x="1248943" y="15625067"/>
+                <a:ext cx="11846368" cy="10743678"/>
+              </a:xfrm>
+              <a:prstGeom prst="rect">
+                <a:avLst/>
+              </a:prstGeom>
+              <a:noFill/>
+              <a:extLst>
+                <a:ext uri="{909E8E84-426E-40DD-AFC4-6F175D3DCCD1}">
+                  <a14:hiddenFill xmlns:a14="http://schemas.microsoft.com/office/drawing/2010/main">
+                    <a:solidFill>
+                      <a:srgbClr val="FFFFFF"/>
+                    </a:solidFill>
+                  </a14:hiddenFill>
+                </a:ext>
+              </a:extLst>
+            </p:spPr>
+          </p:pic>
+          <p:sp>
+            <p:nvSpPr>
+              <p:cNvPr id="20" name="Rectangle 19">
+                <a:extLst>
+                  <a:ext uri="{FF2B5EF4-FFF2-40B4-BE49-F238E27FC236}">
+                    <a16:creationId xmlns:a16="http://schemas.microsoft.com/office/drawing/2014/main" id="{973C567E-A26E-786B-C29F-605FE95B1F4A}"/>
+                  </a:ext>
+                </a:extLst>
+              </p:cNvPr>
+              <p:cNvSpPr/>
+              <p:nvPr/>
+            </p:nvSpPr>
+            <p:spPr>
+              <a:xfrm>
+                <a:off x="2517049" y="15789746"/>
+                <a:ext cx="12235236" cy="504056"/>
+              </a:xfrm>
+              <a:prstGeom prst="rect">
+                <a:avLst/>
+              </a:prstGeom>
+              <a:solidFill>
+                <a:schemeClr val="bg1"/>
+              </a:solidFill>
+              <a:ln>
+                <a:solidFill>
+                  <a:schemeClr val="bg1"/>
+                </a:solidFill>
+              </a:ln>
+            </p:spPr>
+            <p:style>
+              <a:lnRef idx="2">
+                <a:schemeClr val="accent1">
+                  <a:shade val="15000"/>
+                </a:schemeClr>
+              </a:lnRef>
+              <a:fillRef idx="1">
+                <a:schemeClr val="accent1"/>
+              </a:fillRef>
+              <a:effectRef idx="0">
+                <a:schemeClr val="accent1"/>
+              </a:effectRef>
+              <a:fontRef idx="minor">
+                <a:schemeClr val="lt1"/>
+              </a:fontRef>
+            </p:style>
+            <p:txBody>
+              <a:bodyPr rtlCol="0" anchor="ctr"/>
+              <a:lstStyle/>
+              <a:p>
+                <a:r>
+                  <a:rPr lang="en-US" sz="2040" dirty="0">
+                    <a:solidFill>
+                      <a:schemeClr val="tx1"/>
+                    </a:solidFill>
+                  </a:rPr>
+                  <a:t>(C) Median Disease Pressure By Common Garden Site</a:t>
+                </a:r>
+              </a:p>
+            </p:txBody>
+          </p:sp>
+          <p:sp>
+            <p:nvSpPr>
+              <p:cNvPr id="24" name="Rectangle 23">
+                <a:extLst>
+                  <a:ext uri="{FF2B5EF4-FFF2-40B4-BE49-F238E27FC236}">
+                    <a16:creationId xmlns:a16="http://schemas.microsoft.com/office/drawing/2014/main" id="{F0420000-4144-D14F-B365-BFC7642A389E}"/>
+                  </a:ext>
+                </a:extLst>
+              </p:cNvPr>
+              <p:cNvSpPr/>
+              <p:nvPr/>
+            </p:nvSpPr>
+            <p:spPr>
+              <a:xfrm rot="16200000">
+                <a:off x="-1184948" y="20744878"/>
+                <a:ext cx="5371839" cy="504056"/>
+              </a:xfrm>
+              <a:prstGeom prst="rect">
+                <a:avLst/>
+              </a:prstGeom>
+              <a:solidFill>
+                <a:schemeClr val="bg1"/>
+              </a:solidFill>
+              <a:ln>
+                <a:solidFill>
+                  <a:schemeClr val="bg1"/>
+                </a:solidFill>
+              </a:ln>
+            </p:spPr>
+            <p:style>
+              <a:lnRef idx="2">
+                <a:schemeClr val="accent1">
+                  <a:shade val="15000"/>
+                </a:schemeClr>
+              </a:lnRef>
+              <a:fillRef idx="1">
+                <a:schemeClr val="accent1"/>
+              </a:fillRef>
+              <a:effectRef idx="0">
+                <a:schemeClr val="accent1"/>
+              </a:effectRef>
+              <a:fontRef idx="minor">
+                <a:schemeClr val="lt1"/>
+              </a:fontRef>
+            </p:style>
+            <p:txBody>
+              <a:bodyPr rtlCol="0" anchor="ctr"/>
+              <a:lstStyle/>
+              <a:p>
+                <a:pPr algn="ctr"/>
+                <a:r>
+                  <a:rPr lang="en-US" sz="1530" dirty="0">
+                    <a:solidFill>
+                      <a:schemeClr val="tx1"/>
+                    </a:solidFill>
+                  </a:rPr>
+                  <a:t>Disease Prevalence</a:t>
+                </a:r>
+              </a:p>
+            </p:txBody>
+          </p:sp>
+          <p:pic>
+            <p:nvPicPr>
+              <p:cNvPr id="25" name="Picture 4">
+                <a:extLst>
+                  <a:ext uri="{FF2B5EF4-FFF2-40B4-BE49-F238E27FC236}">
+                    <a16:creationId xmlns:a16="http://schemas.microsoft.com/office/drawing/2014/main" id="{A85BCA85-A8CA-E9D2-74A9-9404749B3BC5}"/>
+                  </a:ext>
+                </a:extLst>
+              </p:cNvPr>
+              <p:cNvPicPr>
+                <a:picLocks noChangeAspect="1" noChangeArrowheads="1"/>
+              </p:cNvPicPr>
+              <p:nvPr/>
+            </p:nvPicPr>
+            <p:blipFill rotWithShape="1">
+              <a:blip r:embed="rId5">
+                <a:extLst>
+                  <a:ext uri="{28A0092B-C50C-407E-A947-70E740481C1C}">
+                    <a14:useLocalDpi xmlns:a14="http://schemas.microsoft.com/office/drawing/2010/main" val="0"/>
+                  </a:ext>
+                </a:extLst>
+              </a:blip>
+              <a:srcRect l="82436" t="38214" b="39430"/>
+              <a:stretch>
+                <a:fillRect/>
+              </a:stretch>
+            </p:blipFill>
+            <p:spPr bwMode="auto">
+              <a:xfrm>
+                <a:off x="14695575" y="16426681"/>
+                <a:ext cx="1612588" cy="1554559"/>
+              </a:xfrm>
+              <a:prstGeom prst="rect">
+                <a:avLst/>
+              </a:prstGeom>
+              <a:noFill/>
+              <a:extLst>
+                <a:ext uri="{909E8E84-426E-40DD-AFC4-6F175D3DCCD1}">
+                  <a14:hiddenFill xmlns:a14="http://schemas.microsoft.com/office/drawing/2010/main">
+                    <a:solidFill>
+                      <a:srgbClr val="FFFFFF"/>
+                    </a:solidFill>
+                  </a14:hiddenFill>
+                </a:ext>
+              </a:extLst>
+            </p:spPr>
+          </p:pic>
+          <p:sp>
+            <p:nvSpPr>
+              <p:cNvPr id="26" name="Rectangle 25">
+                <a:extLst>
+                  <a:ext uri="{FF2B5EF4-FFF2-40B4-BE49-F238E27FC236}">
+                    <a16:creationId xmlns:a16="http://schemas.microsoft.com/office/drawing/2014/main" id="{8A70AE1D-8B2A-765F-39A6-3F3BD09D5C55}"/>
+                  </a:ext>
+                </a:extLst>
+              </p:cNvPr>
+              <p:cNvSpPr/>
+              <p:nvPr/>
+            </p:nvSpPr>
+            <p:spPr>
+              <a:xfrm>
+                <a:off x="14877288" y="16797528"/>
+                <a:ext cx="338328" cy="334418"/>
+              </a:xfrm>
+              <a:prstGeom prst="rect">
+                <a:avLst/>
+              </a:prstGeom>
+              <a:solidFill>
+                <a:srgbClr val="FA2F39"/>
+              </a:solidFill>
+              <a:ln w="12700"/>
+            </p:spPr>
+            <p:style>
+              <a:lnRef idx="2">
+                <a:schemeClr val="accent1">
+                  <a:shade val="15000"/>
+                </a:schemeClr>
+              </a:lnRef>
+              <a:fillRef idx="1">
+                <a:schemeClr val="accent1"/>
+              </a:fillRef>
+              <a:effectRef idx="0">
+                <a:schemeClr val="accent1"/>
+              </a:effectRef>
+              <a:fontRef idx="minor">
+                <a:schemeClr val="lt1"/>
+              </a:fontRef>
+            </p:style>
+            <p:txBody>
+              <a:bodyPr rtlCol="0" anchor="ctr"/>
+              <a:lstStyle/>
+              <a:p>
+                <a:pPr algn="ctr"/>
+                <a:endParaRPr lang="en-US" sz="3409"/>
+              </a:p>
+            </p:txBody>
+          </p:sp>
+          <p:sp>
+            <p:nvSpPr>
+              <p:cNvPr id="27" name="Rectangle 26">
+                <a:extLst>
+                  <a:ext uri="{FF2B5EF4-FFF2-40B4-BE49-F238E27FC236}">
+                    <a16:creationId xmlns:a16="http://schemas.microsoft.com/office/drawing/2014/main" id="{3C3BB425-0EBF-10DA-3D83-CF4F390350BF}"/>
+                  </a:ext>
+                </a:extLst>
+              </p:cNvPr>
+              <p:cNvSpPr/>
+              <p:nvPr/>
+            </p:nvSpPr>
+            <p:spPr>
+              <a:xfrm>
+                <a:off x="14877288" y="17145234"/>
+                <a:ext cx="338328" cy="334418"/>
+              </a:xfrm>
+              <a:prstGeom prst="rect">
+                <a:avLst/>
+              </a:prstGeom>
+              <a:solidFill>
+                <a:srgbClr val="FED154"/>
+              </a:solidFill>
+              <a:ln w="12700"/>
+            </p:spPr>
+            <p:style>
+              <a:lnRef idx="2">
+                <a:schemeClr val="accent1">
+                  <a:shade val="15000"/>
+                </a:schemeClr>
+              </a:lnRef>
+              <a:fillRef idx="1">
+                <a:schemeClr val="accent1"/>
+              </a:fillRef>
+              <a:effectRef idx="0">
+                <a:schemeClr val="accent1"/>
+              </a:effectRef>
+              <a:fontRef idx="minor">
+                <a:schemeClr val="lt1"/>
+              </a:fontRef>
+            </p:style>
+            <p:txBody>
+              <a:bodyPr rtlCol="0" anchor="ctr"/>
+              <a:lstStyle/>
+              <a:p>
+                <a:pPr algn="ctr"/>
+                <a:endParaRPr lang="en-US" sz="3409"/>
+              </a:p>
+            </p:txBody>
+          </p:sp>
+          <p:sp>
+            <p:nvSpPr>
+              <p:cNvPr id="28" name="Rectangle 27">
+                <a:extLst>
+                  <a:ext uri="{FF2B5EF4-FFF2-40B4-BE49-F238E27FC236}">
+                    <a16:creationId xmlns:a16="http://schemas.microsoft.com/office/drawing/2014/main" id="{BBBDF8AB-D751-4B6D-C3FA-7C4D3D2527B3}"/>
+                  </a:ext>
+                </a:extLst>
+              </p:cNvPr>
+              <p:cNvSpPr/>
+              <p:nvPr/>
+            </p:nvSpPr>
+            <p:spPr>
+              <a:xfrm>
+                <a:off x="14877288" y="17492940"/>
+                <a:ext cx="338328" cy="334418"/>
+              </a:xfrm>
+              <a:prstGeom prst="rect">
+                <a:avLst/>
+              </a:prstGeom>
+              <a:solidFill>
+                <a:srgbClr val="118EA8"/>
+              </a:solidFill>
+              <a:ln w="12700"/>
+            </p:spPr>
+            <p:style>
+              <a:lnRef idx="2">
+                <a:schemeClr val="accent1">
+                  <a:shade val="15000"/>
+                </a:schemeClr>
+              </a:lnRef>
+              <a:fillRef idx="1">
+                <a:schemeClr val="accent1"/>
+              </a:fillRef>
+              <a:effectRef idx="0">
+                <a:schemeClr val="accent1"/>
+              </a:effectRef>
+              <a:fontRef idx="minor">
+                <a:schemeClr val="lt1"/>
+              </a:fontRef>
+            </p:style>
+            <p:txBody>
+              <a:bodyPr rtlCol="0" anchor="ctr"/>
+              <a:lstStyle/>
+              <a:p>
+                <a:pPr algn="ctr"/>
+                <a:endParaRPr lang="en-US" sz="3409"/>
+              </a:p>
+            </p:txBody>
+          </p:sp>
+          <p:sp>
+            <p:nvSpPr>
+              <p:cNvPr id="32" name="Rectangle 31">
+                <a:extLst>
+                  <a:ext uri="{FF2B5EF4-FFF2-40B4-BE49-F238E27FC236}">
+                    <a16:creationId xmlns:a16="http://schemas.microsoft.com/office/drawing/2014/main" id="{795802A6-DCAC-04B2-21F4-8BE8E372DD2B}"/>
+                  </a:ext>
+                </a:extLst>
+              </p:cNvPr>
+              <p:cNvSpPr/>
+              <p:nvPr/>
+            </p:nvSpPr>
+            <p:spPr>
+              <a:xfrm>
+                <a:off x="4993843" y="25813344"/>
+                <a:ext cx="5371839" cy="807429"/>
+              </a:xfrm>
+              <a:prstGeom prst="rect">
+                <a:avLst/>
+              </a:prstGeom>
+              <a:solidFill>
+                <a:schemeClr val="bg1"/>
+              </a:solidFill>
+              <a:ln>
+                <a:solidFill>
+                  <a:schemeClr val="bg1"/>
+                </a:solidFill>
+              </a:ln>
+            </p:spPr>
+            <p:style>
+              <a:lnRef idx="2">
+                <a:schemeClr val="accent1">
+                  <a:shade val="15000"/>
+                </a:schemeClr>
+              </a:lnRef>
+              <a:fillRef idx="1">
+                <a:schemeClr val="accent1"/>
+              </a:fillRef>
+              <a:effectRef idx="0">
+                <a:schemeClr val="accent1"/>
+              </a:effectRef>
+              <a:fontRef idx="minor">
+                <a:schemeClr val="lt1"/>
+              </a:fontRef>
+            </p:style>
+            <p:txBody>
+              <a:bodyPr rtlCol="0" anchor="ctr"/>
+              <a:lstStyle/>
+              <a:p>
+                <a:pPr algn="ctr"/>
+                <a:r>
+                  <a:rPr lang="en-US" sz="1530" dirty="0">
+                    <a:solidFill>
+                      <a:schemeClr val="tx1"/>
+                    </a:solidFill>
+                  </a:rPr>
+                  <a:t>Common Garden Site</a:t>
+                </a:r>
+              </a:p>
+            </p:txBody>
+          </p:sp>
+          <p:sp>
+            <p:nvSpPr>
+              <p:cNvPr id="33" name="Rectangle 32">
+                <a:extLst>
+                  <a:ext uri="{FF2B5EF4-FFF2-40B4-BE49-F238E27FC236}">
+                    <a16:creationId xmlns:a16="http://schemas.microsoft.com/office/drawing/2014/main" id="{FD622416-87C8-F692-028A-58BAFC9CB925}"/>
+                  </a:ext>
+                </a:extLst>
+              </p:cNvPr>
+              <p:cNvSpPr/>
+              <p:nvPr/>
+            </p:nvSpPr>
+            <p:spPr>
+              <a:xfrm>
+                <a:off x="2538897" y="25525312"/>
+                <a:ext cx="5371839" cy="403715"/>
+              </a:xfrm>
+              <a:prstGeom prst="rect">
+                <a:avLst/>
+              </a:prstGeom>
+              <a:solidFill>
+                <a:schemeClr val="bg1"/>
+              </a:solidFill>
+              <a:ln>
+                <a:solidFill>
+                  <a:schemeClr val="bg1"/>
+                </a:solidFill>
+              </a:ln>
+            </p:spPr>
+            <p:style>
+              <a:lnRef idx="2">
+                <a:schemeClr val="accent1">
+                  <a:shade val="15000"/>
+                </a:schemeClr>
+              </a:lnRef>
+              <a:fillRef idx="1">
+                <a:schemeClr val="accent1"/>
+              </a:fillRef>
+              <a:effectRef idx="0">
+                <a:schemeClr val="accent1"/>
+              </a:effectRef>
+              <a:fontRef idx="minor">
+                <a:schemeClr val="lt1"/>
+              </a:fontRef>
+            </p:style>
+            <p:txBody>
+              <a:bodyPr rtlCol="0" anchor="ctr"/>
+              <a:lstStyle/>
+              <a:p>
+                <a:pPr algn="ctr"/>
+                <a:r>
+                  <a:rPr lang="en-US" sz="1530" dirty="0">
+                    <a:solidFill>
+                      <a:schemeClr val="tx1"/>
+                    </a:solidFill>
+                  </a:rPr>
+                  <a:t>Lewisetta</a:t>
+                </a:r>
+              </a:p>
+            </p:txBody>
+          </p:sp>
+          <p:sp>
+            <p:nvSpPr>
+              <p:cNvPr id="34" name="Rectangle 33">
+                <a:extLst>
+                  <a:ext uri="{FF2B5EF4-FFF2-40B4-BE49-F238E27FC236}">
+                    <a16:creationId xmlns:a16="http://schemas.microsoft.com/office/drawing/2014/main" id="{8B4077A6-CB69-03EA-3956-F08D2681C364}"/>
+                  </a:ext>
+                </a:extLst>
+              </p:cNvPr>
+              <p:cNvSpPr/>
+              <p:nvPr/>
+            </p:nvSpPr>
+            <p:spPr>
+              <a:xfrm>
+                <a:off x="7177990" y="25543313"/>
+                <a:ext cx="5371839" cy="403715"/>
+              </a:xfrm>
+              <a:prstGeom prst="rect">
+                <a:avLst/>
+              </a:prstGeom>
+              <a:solidFill>
+                <a:schemeClr val="bg1"/>
+              </a:solidFill>
+              <a:ln>
+                <a:solidFill>
+                  <a:schemeClr val="bg1"/>
+                </a:solidFill>
+              </a:ln>
+            </p:spPr>
+            <p:style>
+              <a:lnRef idx="2">
+                <a:schemeClr val="accent1">
+                  <a:shade val="15000"/>
+                </a:schemeClr>
+              </a:lnRef>
+              <a:fillRef idx="1">
+                <a:schemeClr val="accent1"/>
+              </a:fillRef>
+              <a:effectRef idx="0">
+                <a:schemeClr val="accent1"/>
+              </a:effectRef>
+              <a:fontRef idx="minor">
+                <a:schemeClr val="lt1"/>
+              </a:fontRef>
+            </p:style>
+            <p:txBody>
+              <a:bodyPr rtlCol="0" anchor="ctr"/>
+              <a:lstStyle/>
+              <a:p>
+                <a:pPr algn="ctr"/>
+                <a:r>
+                  <a:rPr lang="en-US" sz="1530" dirty="0">
+                    <a:solidFill>
+                      <a:schemeClr val="tx1"/>
+                    </a:solidFill>
+                  </a:rPr>
+                  <a:t>York River</a:t>
+                </a:r>
+              </a:p>
+            </p:txBody>
+          </p:sp>
+        </p:grpSp>
       </p:grpSp>
     </p:spTree>
     <p:extLst>

</xml_diff>